<commit_message>
Deck: replace Flow&Edge with full two-engine Architecture slide
New Architecture slide shows both pipelines end-to-end: (1) the AI
Review Engine (collect->label->embed/retrieve->synthesize->insight)
that found the acceptance gap, and (2) the Off Repeat MVP
(signals->taste->retrieve/filter->grounded story+trust->serve/learn),
on a shared grounded-LLM/no-fabrication backbone. Breadcrumb renamed
Flow & Edge -> Architecture.

Co-Authored-By: Claude Opus 4.8 <noreply@anthropic.com>
</commit_message>
<xml_diff>
--- a/Off_Repeat_Deck_TopFellow.pptx
+++ b/Off_Repeat_Deck_TopFellow.pptx
@@ -2186,7 +2186,7 @@
                 <a:ea typeface="Arial" pitchFamily="34" charset="-122"/>
                 <a:cs typeface="Arial" pitchFamily="34" charset="-120"/>
               </a:rPr>
-              <a:t>From a stale feed to a song you'll actually try.</a:t>
+              <a:t>One grounded engine, twice — to find the problem, then fix it.</a:t>
             </a:r>
             <a:endParaRPr lang="en-US" sz="2100" dirty="0"/>
           </a:p>
@@ -2200,8 +2200,8 @@
         </p:nvSpPr>
         <p:spPr>
           <a:xfrm>
-            <a:off x="274320" y="932688"/>
-            <a:ext cx="4206240" cy="237744"/>
+            <a:off x="274320" y="914400"/>
+            <a:ext cx="8595360" cy="237744"/>
           </a:xfrm>
           <a:prstGeom prst="rect">
             <a:avLst/>
@@ -2225,7 +2225,7 @@
                 <a:ea typeface="Arial" pitchFamily="34" charset="-122"/>
                 <a:cs typeface="Arial" pitchFamily="34" charset="-120"/>
               </a:rPr>
-              <a:t>SYSTEM &amp; DATA FLOW</a:t>
+              <a:t>① AI REVIEW ENGINE — HOW WE FOUND THE PROBLEM (RESEARCH AT SCALE)</a:t>
             </a:r>
             <a:endParaRPr lang="en-US" sz="1000" dirty="0"/>
           </a:p>
@@ -2239,348 +2239,12 @@
         </p:nvSpPr>
         <p:spPr>
           <a:xfrm>
-            <a:off x="274320" y="1207008"/>
-            <a:ext cx="4206240" cy="530352"/>
+            <a:off x="274320" y="1225296"/>
+            <a:ext cx="1554480" cy="786384"/>
           </a:xfrm>
           <a:prstGeom prst="roundRect">
             <a:avLst>
-              <a:gd name="adj" fmla="val 12069"/>
-            </a:avLst>
-          </a:prstGeom>
-          <a:solidFill>
-            <a:srgbClr val="FFFFFF"/>
-          </a:solidFill>
-          <a:ln w="12700">
-            <a:solidFill>
-              <a:srgbClr val="D8E5DC"/>
-            </a:solidFill>
-            <a:prstDash val="solid"/>
-          </a:ln>
-          <a:effectLst>
-            <a:outerShdw sx="100000" sy="100000" kx="0" ky="0" algn="bl" rotWithShape="0" blurRad="88900" dist="25400" dir="5400000">
-              <a:srgbClr val="6B6B6B">
-                <a:alpha val="22000"/>
-              </a:srgbClr>
-            </a:outerShdw>
-          </a:effectLst>
-        </p:spPr>
-      </p:sp>
-      <p:sp>
-        <p:nvSpPr>
-          <p:cNvPr id="6" name="Text 4"/>
-          <p:cNvSpPr/>
-          <p:nvPr/>
-        </p:nvSpPr>
-        <p:spPr>
-          <a:xfrm>
-            <a:off x="411480" y="1261872"/>
-            <a:ext cx="3931920" cy="237744"/>
-          </a:xfrm>
-          <a:prstGeom prst="rect">
-            <a:avLst/>
-          </a:prstGeom>
-          <a:noFill/>
-          <a:ln/>
-        </p:spPr>
-        <p:txBody>
-          <a:bodyPr wrap="square" lIns="0" tIns="0" rIns="0" bIns="0" rtlCol="0" anchor="ctr"/>
-          <a:lstStyle/>
-          <a:p>
-            <a:pPr indent="0" marL="0">
-              <a:buNone/>
-            </a:pPr>
-            <a:r>
-              <a:rPr lang="en-US" sz="1100" b="1" dirty="0">
-                <a:solidFill>
-                  <a:srgbClr val="17241D"/>
-                </a:solidFill>
-                <a:latin typeface="Arial" pitchFamily="34" charset="0"/>
-                <a:ea typeface="Arial" pitchFamily="34" charset="-122"/>
-                <a:cs typeface="Arial" pitchFamily="34" charset="-120"/>
-              </a:rPr>
-              <a:t>1 · Taste profile</a:t>
-            </a:r>
-            <a:endParaRPr lang="en-US" sz="1100" dirty="0"/>
-          </a:p>
-        </p:txBody>
-      </p:sp>
-      <p:sp>
-        <p:nvSpPr>
-          <p:cNvPr id="7" name="Text 5"/>
-          <p:cNvSpPr/>
-          <p:nvPr/>
-        </p:nvSpPr>
-        <p:spPr>
-          <a:xfrm>
-            <a:off x="411480" y="1490472"/>
-            <a:ext cx="3931920" cy="219456"/>
-          </a:xfrm>
-          <a:prstGeom prst="rect">
-            <a:avLst/>
-          </a:prstGeom>
-          <a:noFill/>
-          <a:ln/>
-        </p:spPr>
-        <p:txBody>
-          <a:bodyPr wrap="square" lIns="0" tIns="0" rIns="0" bIns="0" rtlCol="0" anchor="ctr"/>
-          <a:lstStyle/>
-          <a:p>
-            <a:pPr indent="0" marL="0">
-              <a:buNone/>
-            </a:pPr>
-            <a:r>
-              <a:rPr lang="en-US" sz="900" dirty="0">
-                <a:solidFill>
-                  <a:srgbClr val="5C6B62"/>
-                </a:solidFill>
-                <a:latin typeface="Arial" pitchFamily="34" charset="0"/>
-                <a:ea typeface="Arial" pitchFamily="34" charset="-122"/>
-                <a:cs typeface="Arial" pitchFamily="34" charset="-120"/>
-              </a:rPr>
-              <a:t>embed listening history + saves</a:t>
-            </a:r>
-            <a:endParaRPr lang="en-US" sz="900" dirty="0"/>
-          </a:p>
-        </p:txBody>
-      </p:sp>
-      <p:sp>
-        <p:nvSpPr>
-          <p:cNvPr id="8" name="Shape 6"/>
-          <p:cNvSpPr/>
-          <p:nvPr/>
-        </p:nvSpPr>
-        <p:spPr>
-          <a:xfrm>
-            <a:off x="274320" y="1810512"/>
-            <a:ext cx="4206240" cy="530352"/>
-          </a:xfrm>
-          <a:prstGeom prst="roundRect">
-            <a:avLst>
-              <a:gd name="adj" fmla="val 12069"/>
-            </a:avLst>
-          </a:prstGeom>
-          <a:solidFill>
-            <a:srgbClr val="FFFFFF"/>
-          </a:solidFill>
-          <a:ln w="12700">
-            <a:solidFill>
-              <a:srgbClr val="D8E5DC"/>
-            </a:solidFill>
-            <a:prstDash val="solid"/>
-          </a:ln>
-          <a:effectLst>
-            <a:outerShdw sx="100000" sy="100000" kx="0" ky="0" algn="bl" rotWithShape="0" blurRad="88900" dist="25400" dir="5400000">
-              <a:srgbClr val="6B6B6B">
-                <a:alpha val="22000"/>
-              </a:srgbClr>
-            </a:outerShdw>
-          </a:effectLst>
-        </p:spPr>
-      </p:sp>
-      <p:sp>
-        <p:nvSpPr>
-          <p:cNvPr id="9" name="Text 7"/>
-          <p:cNvSpPr/>
-          <p:nvPr/>
-        </p:nvSpPr>
-        <p:spPr>
-          <a:xfrm>
-            <a:off x="411480" y="1865376"/>
-            <a:ext cx="3931920" cy="237744"/>
-          </a:xfrm>
-          <a:prstGeom prst="rect">
-            <a:avLst/>
-          </a:prstGeom>
-          <a:noFill/>
-          <a:ln/>
-        </p:spPr>
-        <p:txBody>
-          <a:bodyPr wrap="square" lIns="0" tIns="0" rIns="0" bIns="0" rtlCol="0" anchor="ctr"/>
-          <a:lstStyle/>
-          <a:p>
-            <a:pPr indent="0" marL="0">
-              <a:buNone/>
-            </a:pPr>
-            <a:r>
-              <a:rPr lang="en-US" sz="1100" b="1" dirty="0">
-                <a:solidFill>
-                  <a:srgbClr val="17241D"/>
-                </a:solidFill>
-                <a:latin typeface="Arial" pitchFamily="34" charset="0"/>
-                <a:ea typeface="Arial" pitchFamily="34" charset="-122"/>
-                <a:cs typeface="Arial" pitchFamily="34" charset="-120"/>
-              </a:rPr>
-              <a:t>2 · Candidate retrieval</a:t>
-            </a:r>
-            <a:endParaRPr lang="en-US" sz="1100" dirty="0"/>
-          </a:p>
-        </p:txBody>
-      </p:sp>
-      <p:sp>
-        <p:nvSpPr>
-          <p:cNvPr id="10" name="Text 8"/>
-          <p:cNvSpPr/>
-          <p:nvPr/>
-        </p:nvSpPr>
-        <p:spPr>
-          <a:xfrm>
-            <a:off x="411480" y="2093976"/>
-            <a:ext cx="3931920" cy="219456"/>
-          </a:xfrm>
-          <a:prstGeom prst="rect">
-            <a:avLst/>
-          </a:prstGeom>
-          <a:noFill/>
-          <a:ln/>
-        </p:spPr>
-        <p:txBody>
-          <a:bodyPr wrap="square" lIns="0" tIns="0" rIns="0" bIns="0" rtlCol="0" anchor="ctr"/>
-          <a:lstStyle/>
-          <a:p>
-            <a:pPr indent="0" marL="0">
-              <a:buNone/>
-            </a:pPr>
-            <a:r>
-              <a:rPr lang="en-US" sz="900" dirty="0">
-                <a:solidFill>
-                  <a:srgbClr val="5C6B62"/>
-                </a:solidFill>
-                <a:latin typeface="Arial" pitchFamily="34" charset="0"/>
-                <a:ea typeface="Arial" pitchFamily="34" charset="-122"/>
-                <a:cs typeface="Arial" pitchFamily="34" charset="-120"/>
-              </a:rPr>
-              <a:t>semantic match → fresh, long-tail tracks</a:t>
-            </a:r>
-            <a:endParaRPr lang="en-US" sz="900" dirty="0"/>
-          </a:p>
-        </p:txBody>
-      </p:sp>
-      <p:sp>
-        <p:nvSpPr>
-          <p:cNvPr id="11" name="Shape 9"/>
-          <p:cNvSpPr/>
-          <p:nvPr/>
-        </p:nvSpPr>
-        <p:spPr>
-          <a:xfrm>
-            <a:off x="274320" y="2414016"/>
-            <a:ext cx="4206240" cy="530352"/>
-          </a:xfrm>
-          <a:prstGeom prst="roundRect">
-            <a:avLst>
-              <a:gd name="adj" fmla="val 12069"/>
-            </a:avLst>
-          </a:prstGeom>
-          <a:solidFill>
-            <a:srgbClr val="FFFFFF"/>
-          </a:solidFill>
-          <a:ln w="12700">
-            <a:solidFill>
-              <a:srgbClr val="D8E5DC"/>
-            </a:solidFill>
-            <a:prstDash val="solid"/>
-          </a:ln>
-          <a:effectLst>
-            <a:outerShdw sx="100000" sy="100000" kx="0" ky="0" algn="bl" rotWithShape="0" blurRad="88900" dist="25400" dir="5400000">
-              <a:srgbClr val="6B6B6B">
-                <a:alpha val="22000"/>
-              </a:srgbClr>
-            </a:outerShdw>
-          </a:effectLst>
-        </p:spPr>
-      </p:sp>
-      <p:sp>
-        <p:nvSpPr>
-          <p:cNvPr id="12" name="Text 10"/>
-          <p:cNvSpPr/>
-          <p:nvPr/>
-        </p:nvSpPr>
-        <p:spPr>
-          <a:xfrm>
-            <a:off x="411480" y="2468880"/>
-            <a:ext cx="3931920" cy="237744"/>
-          </a:xfrm>
-          <a:prstGeom prst="rect">
-            <a:avLst/>
-          </a:prstGeom>
-          <a:noFill/>
-          <a:ln/>
-        </p:spPr>
-        <p:txBody>
-          <a:bodyPr wrap="square" lIns="0" tIns="0" rIns="0" bIns="0" rtlCol="0" anchor="ctr"/>
-          <a:lstStyle/>
-          <a:p>
-            <a:pPr indent="0" marL="0">
-              <a:buNone/>
-            </a:pPr>
-            <a:r>
-              <a:rPr lang="en-US" sz="1100" b="1" dirty="0">
-                <a:solidFill>
-                  <a:srgbClr val="17241D"/>
-                </a:solidFill>
-                <a:latin typeface="Arial" pitchFamily="34" charset="0"/>
-                <a:ea typeface="Arial" pitchFamily="34" charset="-122"/>
-                <a:cs typeface="Arial" pitchFamily="34" charset="-120"/>
-              </a:rPr>
-              <a:t>3 · Novelty filter</a:t>
-            </a:r>
-            <a:endParaRPr lang="en-US" sz="1100" dirty="0"/>
-          </a:p>
-        </p:txBody>
-      </p:sp>
-      <p:sp>
-        <p:nvSpPr>
-          <p:cNvPr id="13" name="Text 11"/>
-          <p:cNvSpPr/>
-          <p:nvPr/>
-        </p:nvSpPr>
-        <p:spPr>
-          <a:xfrm>
-            <a:off x="411480" y="2697480"/>
-            <a:ext cx="3931920" cy="219456"/>
-          </a:xfrm>
-          <a:prstGeom prst="rect">
-            <a:avLst/>
-          </a:prstGeom>
-          <a:noFill/>
-          <a:ln/>
-        </p:spPr>
-        <p:txBody>
-          <a:bodyPr wrap="square" lIns="0" tIns="0" rIns="0" bIns="0" rtlCol="0" anchor="ctr"/>
-          <a:lstStyle/>
-          <a:p>
-            <a:pPr indent="0" marL="0">
-              <a:buNone/>
-            </a:pPr>
-            <a:r>
-              <a:rPr lang="en-US" sz="900" dirty="0">
-                <a:solidFill>
-                  <a:srgbClr val="5C6B62"/>
-                </a:solidFill>
-                <a:latin typeface="Arial" pitchFamily="34" charset="0"/>
-                <a:ea typeface="Arial" pitchFamily="34" charset="-122"/>
-                <a:cs typeface="Arial" pitchFamily="34" charset="-120"/>
-              </a:rPr>
-              <a:t>drop anything already in the library</a:t>
-            </a:r>
-            <a:endParaRPr lang="en-US" sz="900" dirty="0"/>
-          </a:p>
-        </p:txBody>
-      </p:sp>
-      <p:sp>
-        <p:nvSpPr>
-          <p:cNvPr id="14" name="Shape 12"/>
-          <p:cNvSpPr/>
-          <p:nvPr/>
-        </p:nvSpPr>
-        <p:spPr>
-          <a:xfrm>
-            <a:off x="274320" y="3017520"/>
-            <a:ext cx="4206240" cy="530352"/>
-          </a:xfrm>
-          <a:prstGeom prst="roundRect">
-            <a:avLst>
-              <a:gd name="adj" fmla="val 12069"/>
+              <a:gd name="adj" fmla="val 6977"/>
             </a:avLst>
           </a:prstGeom>
           <a:solidFill>
@@ -2603,69 +2267,75 @@
       </p:sp>
       <p:sp>
         <p:nvSpPr>
-          <p:cNvPr id="15" name="Text 13"/>
-          <p:cNvSpPr/>
-          <p:nvPr/>
-        </p:nvSpPr>
-        <p:spPr>
-          <a:xfrm>
-            <a:off x="411480" y="3072384"/>
-            <a:ext cx="3931920" cy="237744"/>
-          </a:xfrm>
-          <a:prstGeom prst="rect">
-            <a:avLst/>
-          </a:prstGeom>
-          <a:noFill/>
-          <a:ln/>
-        </p:spPr>
-        <p:txBody>
-          <a:bodyPr wrap="square" lIns="0" tIns="0" rIns="0" bIns="0" rtlCol="0" anchor="ctr"/>
-          <a:lstStyle/>
-          <a:p>
-            <a:pPr indent="0" marL="0">
-              <a:buNone/>
-            </a:pPr>
-            <a:r>
-              <a:rPr lang="en-US" sz="1100" b="1" dirty="0">
-                <a:solidFill>
-                  <a:srgbClr val="0E6B37"/>
-                </a:solidFill>
-                <a:latin typeface="Arial" pitchFamily="34" charset="0"/>
-                <a:ea typeface="Arial" pitchFamily="34" charset="-122"/>
-                <a:cs typeface="Arial" pitchFamily="34" charset="-120"/>
-              </a:rPr>
-              <a:t>4 · Grounded narrative</a:t>
-            </a:r>
-            <a:endParaRPr lang="en-US" sz="1100" dirty="0"/>
-          </a:p>
-        </p:txBody>
-      </p:sp>
-      <p:sp>
-        <p:nvSpPr>
-          <p:cNvPr id="16" name="Text 14"/>
-          <p:cNvSpPr/>
-          <p:nvPr/>
-        </p:nvSpPr>
-        <p:spPr>
-          <a:xfrm>
-            <a:off x="411480" y="3300984"/>
-            <a:ext cx="3931920" cy="219456"/>
-          </a:xfrm>
-          <a:prstGeom prst="rect">
-            <a:avLst/>
-          </a:prstGeom>
-          <a:noFill/>
-          <a:ln/>
-        </p:spPr>
-        <p:txBody>
-          <a:bodyPr wrap="square" lIns="0" tIns="0" rIns="0" bIns="0" rtlCol="0" anchor="ctr"/>
-          <a:lstStyle/>
-          <a:p>
-            <a:pPr indent="0" marL="0">
-              <a:buNone/>
-            </a:pPr>
-            <a:r>
-              <a:rPr lang="en-US" sz="900" dirty="0">
+          <p:cNvPr id="6" name="Text 4"/>
+          <p:cNvSpPr/>
+          <p:nvPr/>
+        </p:nvSpPr>
+        <p:spPr>
+          <a:xfrm>
+            <a:off x="329184" y="1280160"/>
+            <a:ext cx="1444752" cy="256032"/>
+          </a:xfrm>
+          <a:prstGeom prst="rect">
+            <a:avLst/>
+          </a:prstGeom>
+          <a:noFill/>
+          <a:ln/>
+        </p:spPr>
+        <p:txBody>
+          <a:bodyPr wrap="square" lIns="0" tIns="0" rIns="0" bIns="0" rtlCol="0" anchor="ctr"/>
+          <a:lstStyle/>
+          <a:p>
+            <a:pPr algn="ctr" indent="0" marL="0">
+              <a:lnSpc>
+                <a:spcPct val="90000"/>
+              </a:lnSpc>
+              <a:buNone/>
+            </a:pPr>
+            <a:r>
+              <a:rPr lang="en-US" sz="950" b="1" dirty="0">
+                <a:solidFill>
+                  <a:srgbClr val="17241D"/>
+                </a:solidFill>
+                <a:latin typeface="Arial" pitchFamily="34" charset="0"/>
+                <a:ea typeface="Arial" pitchFamily="34" charset="-122"/>
+                <a:cs typeface="Arial" pitchFamily="34" charset="-120"/>
+              </a:rPr>
+              <a:t>Collect</a:t>
+            </a:r>
+            <a:endParaRPr lang="en-US" sz="950" dirty="0"/>
+          </a:p>
+        </p:txBody>
+      </p:sp>
+      <p:sp>
+        <p:nvSpPr>
+          <p:cNvPr id="7" name="Text 5"/>
+          <p:cNvSpPr/>
+          <p:nvPr/>
+        </p:nvSpPr>
+        <p:spPr>
+          <a:xfrm>
+            <a:off x="329184" y="1527048"/>
+            <a:ext cx="1444752" cy="438912"/>
+          </a:xfrm>
+          <a:prstGeom prst="rect">
+            <a:avLst/>
+          </a:prstGeom>
+          <a:noFill/>
+          <a:ln/>
+        </p:spPr>
+        <p:txBody>
+          <a:bodyPr wrap="square" lIns="0" tIns="0" rIns="0" bIns="0" rtlCol="0" anchor="ctr"/>
+          <a:lstStyle/>
+          <a:p>
+            <a:pPr algn="ctr" indent="0" marL="0">
+              <a:lnSpc>
+                <a:spcPct val="100000"/>
+              </a:lnSpc>
+              <a:buNone/>
+            </a:pPr>
+            <a:r>
+              <a:rPr lang="en-US" sz="750" dirty="0">
                 <a:solidFill>
                   <a:srgbClr val="5C6B62"/>
                 </a:solidFill>
@@ -2673,30 +2343,109 @@
                 <a:ea typeface="Arial" pitchFamily="34" charset="-122"/>
                 <a:cs typeface="Arial" pitchFamily="34" charset="-120"/>
               </a:rPr>
-              <a:t>LLM writes the 'why', grounded in real artist facts</a:t>
-            </a:r>
-            <a:endParaRPr lang="en-US" sz="900" dirty="0"/>
-          </a:p>
-        </p:txBody>
-      </p:sp>
-      <p:sp>
-        <p:nvSpPr>
-          <p:cNvPr id="17" name="Shape 15"/>
-          <p:cNvSpPr/>
-          <p:nvPr/>
-        </p:nvSpPr>
-        <p:spPr>
-          <a:xfrm>
-            <a:off x="274320" y="3621024"/>
-            <a:ext cx="4206240" cy="530352"/>
+              <a:t>App Store · Play Store</a:t>
+            </a:r>
+            <a:endParaRPr lang="en-US" sz="750" dirty="0"/>
+          </a:p>
+          <a:p>
+            <a:pPr algn="ctr" indent="0" marL="0">
+              <a:lnSpc>
+                <a:spcPct val="100000"/>
+              </a:lnSpc>
+              <a:buNone/>
+            </a:pPr>
+            <a:r>
+              <a:rPr lang="en-US" sz="750" dirty="0">
+                <a:solidFill>
+                  <a:srgbClr val="5C6B62"/>
+                </a:solidFill>
+                <a:latin typeface="Arial" pitchFamily="34" charset="0"/>
+                <a:ea typeface="Arial" pitchFamily="34" charset="-122"/>
+                <a:cs typeface="Arial" pitchFamily="34" charset="-120"/>
+              </a:rPr>
+              <a:t>YouTube · Community</a:t>
+            </a:r>
+            <a:endParaRPr lang="en-US" sz="750" dirty="0"/>
+          </a:p>
+          <a:p>
+            <a:pPr algn="ctr" indent="0" marL="0">
+              <a:lnSpc>
+                <a:spcPct val="100000"/>
+              </a:lnSpc>
+              <a:buNone/>
+            </a:pPr>
+            <a:r>
+              <a:rPr lang="en-US" sz="750" dirty="0">
+                <a:solidFill>
+                  <a:srgbClr val="5C6B62"/>
+                </a:solidFill>
+                <a:latin typeface="Arial" pitchFamily="34" charset="0"/>
+                <a:ea typeface="Arial" pitchFamily="34" charset="-122"/>
+                <a:cs typeface="Arial" pitchFamily="34" charset="-120"/>
+              </a:rPr>
+              <a:t>7,296 reviews</a:t>
+            </a:r>
+            <a:endParaRPr lang="en-US" sz="750" dirty="0"/>
+          </a:p>
+        </p:txBody>
+      </p:sp>
+      <p:sp>
+        <p:nvSpPr>
+          <p:cNvPr id="8" name="Text 6"/>
+          <p:cNvSpPr/>
+          <p:nvPr/>
+        </p:nvSpPr>
+        <p:spPr>
+          <a:xfrm>
+            <a:off x="1847088" y="1426464"/>
+            <a:ext cx="201168" cy="365760"/>
+          </a:xfrm>
+          <a:prstGeom prst="rect">
+            <a:avLst/>
+          </a:prstGeom>
+          <a:noFill/>
+          <a:ln/>
+        </p:spPr>
+        <p:txBody>
+          <a:bodyPr wrap="square" lIns="0" tIns="0" rIns="0" bIns="0" rtlCol="0" anchor="ctr"/>
+          <a:lstStyle/>
+          <a:p>
+            <a:pPr algn="ctr" indent="0" marL="0">
+              <a:buNone/>
+            </a:pPr>
+            <a:r>
+              <a:rPr lang="en-US" sz="1500" b="1" dirty="0">
+                <a:solidFill>
+                  <a:srgbClr val="9AA6A0"/>
+                </a:solidFill>
+                <a:latin typeface="Arial" pitchFamily="34" charset="0"/>
+                <a:ea typeface="Arial" pitchFamily="34" charset="-122"/>
+                <a:cs typeface="Arial" pitchFamily="34" charset="-120"/>
+              </a:rPr>
+              <a:t>→</a:t>
+            </a:r>
+            <a:endParaRPr lang="en-US" sz="1500" dirty="0"/>
+          </a:p>
+        </p:txBody>
+      </p:sp>
+      <p:sp>
+        <p:nvSpPr>
+          <p:cNvPr id="9" name="Shape 7"/>
+          <p:cNvSpPr/>
+          <p:nvPr/>
+        </p:nvSpPr>
+        <p:spPr>
+          <a:xfrm>
+            <a:off x="2034540" y="1225296"/>
+            <a:ext cx="1554480" cy="786384"/>
           </a:xfrm>
           <a:prstGeom prst="roundRect">
             <a:avLst>
-              <a:gd name="adj" fmla="val 12069"/>
+              <a:gd name="adj" fmla="val 6977"/>
             </a:avLst>
           </a:prstGeom>
           <a:solidFill>
-            <a:srgbClr val="FFFFFF"/>
+            <a:srgbClr val="E7F6EC"/>
           </a:solidFill>
           <a:ln w="12700">
             <a:solidFill>
@@ -2715,30 +2464,33 @@
       </p:sp>
       <p:sp>
         <p:nvSpPr>
-          <p:cNvPr id="18" name="Text 16"/>
-          <p:cNvSpPr/>
-          <p:nvPr/>
-        </p:nvSpPr>
-        <p:spPr>
-          <a:xfrm>
-            <a:off x="411480" y="3675888"/>
-            <a:ext cx="3931920" cy="237744"/>
-          </a:xfrm>
-          <a:prstGeom prst="rect">
-            <a:avLst/>
-          </a:prstGeom>
-          <a:noFill/>
-          <a:ln/>
-        </p:spPr>
-        <p:txBody>
-          <a:bodyPr wrap="square" lIns="0" tIns="0" rIns="0" bIns="0" rtlCol="0" anchor="ctr"/>
-          <a:lstStyle/>
-          <a:p>
-            <a:pPr indent="0" marL="0">
-              <a:buNone/>
-            </a:pPr>
-            <a:r>
-              <a:rPr lang="en-US" sz="1100" b="1" dirty="0">
+          <p:cNvPr id="10" name="Text 8"/>
+          <p:cNvSpPr/>
+          <p:nvPr/>
+        </p:nvSpPr>
+        <p:spPr>
+          <a:xfrm>
+            <a:off x="2089404" y="1280160"/>
+            <a:ext cx="1444752" cy="256032"/>
+          </a:xfrm>
+          <a:prstGeom prst="rect">
+            <a:avLst/>
+          </a:prstGeom>
+          <a:noFill/>
+          <a:ln/>
+        </p:spPr>
+        <p:txBody>
+          <a:bodyPr wrap="square" lIns="0" tIns="0" rIns="0" bIns="0" rtlCol="0" anchor="ctr"/>
+          <a:lstStyle/>
+          <a:p>
+            <a:pPr algn="ctr" indent="0" marL="0">
+              <a:lnSpc>
+                <a:spcPct val="90000"/>
+              </a:lnSpc>
+              <a:buNone/>
+            </a:pPr>
+            <a:r>
+              <a:rPr lang="en-US" sz="950" b="1" dirty="0">
                 <a:solidFill>
                   <a:srgbClr val="17241D"/>
                 </a:solidFill>
@@ -2746,38 +2498,41 @@
                 <a:ea typeface="Arial" pitchFamily="34" charset="-122"/>
                 <a:cs typeface="Arial" pitchFamily="34" charset="-120"/>
               </a:rPr>
-              <a:t>5 · Serve + learn</a:t>
-            </a:r>
-            <a:endParaRPr lang="en-US" sz="1100" dirty="0"/>
-          </a:p>
-        </p:txBody>
-      </p:sp>
-      <p:sp>
-        <p:nvSpPr>
-          <p:cNvPr id="19" name="Text 17"/>
-          <p:cNvSpPr/>
-          <p:nvPr/>
-        </p:nvSpPr>
-        <p:spPr>
-          <a:xfrm>
-            <a:off x="411480" y="3904488"/>
-            <a:ext cx="3931920" cy="219456"/>
-          </a:xfrm>
-          <a:prstGeom prst="rect">
-            <a:avLst/>
-          </a:prstGeom>
-          <a:noFill/>
-          <a:ln/>
-        </p:spPr>
-        <p:txBody>
-          <a:bodyPr wrap="square" lIns="0" tIns="0" rIns="0" bIns="0" rtlCol="0" anchor="ctr"/>
-          <a:lstStyle/>
-          <a:p>
-            <a:pPr indent="0" marL="0">
-              <a:buNone/>
-            </a:pPr>
-            <a:r>
-              <a:rPr lang="en-US" sz="900" dirty="0">
+              <a:t>Label</a:t>
+            </a:r>
+            <a:endParaRPr lang="en-US" sz="950" dirty="0"/>
+          </a:p>
+        </p:txBody>
+      </p:sp>
+      <p:sp>
+        <p:nvSpPr>
+          <p:cNvPr id="11" name="Text 9"/>
+          <p:cNvSpPr/>
+          <p:nvPr/>
+        </p:nvSpPr>
+        <p:spPr>
+          <a:xfrm>
+            <a:off x="2089404" y="1527048"/>
+            <a:ext cx="1444752" cy="438912"/>
+          </a:xfrm>
+          <a:prstGeom prst="rect">
+            <a:avLst/>
+          </a:prstGeom>
+          <a:noFill/>
+          <a:ln/>
+        </p:spPr>
+        <p:txBody>
+          <a:bodyPr wrap="square" lIns="0" tIns="0" rIns="0" bIns="0" rtlCol="0" anchor="ctr"/>
+          <a:lstStyle/>
+          <a:p>
+            <a:pPr algn="ctr" indent="0" marL="0">
+              <a:lnSpc>
+                <a:spcPct val="100000"/>
+              </a:lnSpc>
+              <a:buNone/>
+            </a:pPr>
+            <a:r>
+              <a:rPr lang="en-US" sz="750" dirty="0">
                 <a:solidFill>
                   <a:srgbClr val="5C6B62"/>
                 </a:solidFill>
@@ -2785,69 +2540,89 @@
                 <a:ea typeface="Arial" pitchFamily="34" charset="-122"/>
                 <a:cs typeface="Arial" pitchFamily="34" charset="-120"/>
               </a:rPr>
-              <a:t>trust badge + story; learns what you adopt</a:t>
-            </a:r>
-            <a:endParaRPr lang="en-US" sz="900" dirty="0"/>
-          </a:p>
-        </p:txBody>
-      </p:sp>
-      <p:sp>
-        <p:nvSpPr>
-          <p:cNvPr id="20" name="Text 18"/>
-          <p:cNvSpPr/>
-          <p:nvPr/>
-        </p:nvSpPr>
-        <p:spPr>
-          <a:xfrm>
-            <a:off x="4663440" y="932688"/>
-            <a:ext cx="4206240" cy="237744"/>
-          </a:xfrm>
-          <a:prstGeom prst="rect">
-            <a:avLst/>
-          </a:prstGeom>
-          <a:noFill/>
-          <a:ln/>
-        </p:spPr>
-        <p:txBody>
-          <a:bodyPr wrap="square" lIns="0" tIns="0" rIns="0" bIns="0" rtlCol="0" anchor="ctr"/>
-          <a:lstStyle/>
-          <a:p>
-            <a:pPr indent="0" marL="0">
-              <a:buNone/>
-            </a:pPr>
-            <a:r>
-              <a:rPr lang="en-US" sz="1000" b="1" spc="150" kern="0" dirty="0">
-                <a:solidFill>
-                  <a:srgbClr val="0E6B37"/>
-                </a:solidFill>
-                <a:latin typeface="Arial" pitchFamily="34" charset="0"/>
-                <a:ea typeface="Arial" pitchFamily="34" charset="-122"/>
-                <a:cs typeface="Arial" pitchFamily="34" charset="-120"/>
-              </a:rPr>
-              <a:t>WHERE IT HOLDS UP UNDER PRESSURE</a:t>
-            </a:r>
-            <a:endParaRPr lang="en-US" sz="1000" dirty="0"/>
-          </a:p>
-        </p:txBody>
-      </p:sp>
-      <p:sp>
-        <p:nvSpPr>
-          <p:cNvPr id="21" name="Shape 19"/>
-          <p:cNvSpPr/>
-          <p:nvPr/>
-        </p:nvSpPr>
-        <p:spPr>
-          <a:xfrm>
-            <a:off x="4663440" y="1207008"/>
-            <a:ext cx="4206240" cy="969264"/>
+              <a:t>per-review LLM</a:t>
+            </a:r>
+            <a:endParaRPr lang="en-US" sz="750" dirty="0"/>
+          </a:p>
+          <a:p>
+            <a:pPr algn="ctr" indent="0" marL="0">
+              <a:lnSpc>
+                <a:spcPct val="100000"/>
+              </a:lnSpc>
+              <a:buNone/>
+            </a:pPr>
+            <a:r>
+              <a:rPr lang="en-US" sz="750" dirty="0">
+                <a:solidFill>
+                  <a:srgbClr val="5C6B62"/>
+                </a:solidFill>
+                <a:latin typeface="Arial" pitchFamily="34" charset="0"/>
+                <a:ea typeface="Arial" pitchFamily="34" charset="-122"/>
+                <a:cs typeface="Arial" pitchFamily="34" charset="-120"/>
+              </a:rPr>
+              <a:t>coding (Groq)</a:t>
+            </a:r>
+            <a:endParaRPr lang="en-US" sz="750" dirty="0"/>
+          </a:p>
+        </p:txBody>
+      </p:sp>
+      <p:sp>
+        <p:nvSpPr>
+          <p:cNvPr id="12" name="Text 10"/>
+          <p:cNvSpPr/>
+          <p:nvPr/>
+        </p:nvSpPr>
+        <p:spPr>
+          <a:xfrm>
+            <a:off x="3607308" y="1426464"/>
+            <a:ext cx="201168" cy="365760"/>
+          </a:xfrm>
+          <a:prstGeom prst="rect">
+            <a:avLst/>
+          </a:prstGeom>
+          <a:noFill/>
+          <a:ln/>
+        </p:spPr>
+        <p:txBody>
+          <a:bodyPr wrap="square" lIns="0" tIns="0" rIns="0" bIns="0" rtlCol="0" anchor="ctr"/>
+          <a:lstStyle/>
+          <a:p>
+            <a:pPr algn="ctr" indent="0" marL="0">
+              <a:buNone/>
+            </a:pPr>
+            <a:r>
+              <a:rPr lang="en-US" sz="1500" b="1" dirty="0">
+                <a:solidFill>
+                  <a:srgbClr val="9AA6A0"/>
+                </a:solidFill>
+                <a:latin typeface="Arial" pitchFamily="34" charset="0"/>
+                <a:ea typeface="Arial" pitchFamily="34" charset="-122"/>
+                <a:cs typeface="Arial" pitchFamily="34" charset="-120"/>
+              </a:rPr>
+              <a:t>→</a:t>
+            </a:r>
+            <a:endParaRPr lang="en-US" sz="1500" dirty="0"/>
+          </a:p>
+        </p:txBody>
+      </p:sp>
+      <p:sp>
+        <p:nvSpPr>
+          <p:cNvPr id="13" name="Shape 11"/>
+          <p:cNvSpPr/>
+          <p:nvPr/>
+        </p:nvSpPr>
+        <p:spPr>
+          <a:xfrm>
+            <a:off x="3794760" y="1225296"/>
+            <a:ext cx="1554480" cy="786384"/>
           </a:xfrm>
           <a:prstGeom prst="roundRect">
             <a:avLst>
-              <a:gd name="adj" fmla="val 6604"/>
+              <a:gd name="adj" fmla="val 6977"/>
             </a:avLst>
           </a:prstGeom>
           <a:solidFill>
-            <a:srgbClr val="FBE3DD"/>
+            <a:srgbClr val="E7F6EC"/>
           </a:solidFill>
           <a:ln w="12700">
             <a:solidFill>
@@ -2866,30 +2641,33 @@
       </p:sp>
       <p:sp>
         <p:nvSpPr>
-          <p:cNvPr id="22" name="Text 20"/>
-          <p:cNvSpPr/>
-          <p:nvPr/>
-        </p:nvSpPr>
-        <p:spPr>
-          <a:xfrm>
-            <a:off x="4818888" y="1280160"/>
-            <a:ext cx="3895344" cy="256032"/>
-          </a:xfrm>
-          <a:prstGeom prst="rect">
-            <a:avLst/>
-          </a:prstGeom>
-          <a:noFill/>
-          <a:ln/>
-        </p:spPr>
-        <p:txBody>
-          <a:bodyPr wrap="square" lIns="0" tIns="0" rIns="0" bIns="0" rtlCol="0" anchor="ctr"/>
-          <a:lstStyle/>
-          <a:p>
-            <a:pPr indent="0" marL="0">
-              <a:buNone/>
-            </a:pPr>
-            <a:r>
-              <a:rPr lang="en-US" sz="1100" b="1" dirty="0">
+          <p:cNvPr id="14" name="Text 12"/>
+          <p:cNvSpPr/>
+          <p:nvPr/>
+        </p:nvSpPr>
+        <p:spPr>
+          <a:xfrm>
+            <a:off x="3849624" y="1280160"/>
+            <a:ext cx="1444752" cy="256032"/>
+          </a:xfrm>
+          <a:prstGeom prst="rect">
+            <a:avLst/>
+          </a:prstGeom>
+          <a:noFill/>
+          <a:ln/>
+        </p:spPr>
+        <p:txBody>
+          <a:bodyPr wrap="square" lIns="0" tIns="0" rIns="0" bIns="0" rtlCol="0" anchor="ctr"/>
+          <a:lstStyle/>
+          <a:p>
+            <a:pPr algn="ctr" indent="0" marL="0">
+              <a:lnSpc>
+                <a:spcPct val="90000"/>
+              </a:lnSpc>
+              <a:buNone/>
+            </a:pPr>
+            <a:r>
+              <a:rPr lang="en-US" sz="950" b="1" dirty="0">
                 <a:solidFill>
                   <a:srgbClr val="17241D"/>
                 </a:solidFill>
@@ -2897,72 +2675,131 @@
                 <a:ea typeface="Arial" pitchFamily="34" charset="-122"/>
                 <a:cs typeface="Arial" pitchFamily="34" charset="-120"/>
               </a:rPr>
-              <a:t>Hallucinated facts</a:t>
-            </a:r>
-            <a:endParaRPr lang="en-US" sz="1100" dirty="0"/>
-          </a:p>
-        </p:txBody>
-      </p:sp>
-      <p:sp>
-        <p:nvSpPr>
-          <p:cNvPr id="23" name="Text 21"/>
-          <p:cNvSpPr/>
-          <p:nvPr/>
-        </p:nvSpPr>
-        <p:spPr>
-          <a:xfrm>
-            <a:off x="4818888" y="1536192"/>
-            <a:ext cx="3895344" cy="603504"/>
-          </a:xfrm>
-          <a:prstGeom prst="rect">
-            <a:avLst/>
-          </a:prstGeom>
-          <a:noFill/>
-          <a:ln/>
-        </p:spPr>
-        <p:txBody>
-          <a:bodyPr wrap="square" lIns="0" tIns="0" rIns="0" bIns="0" rtlCol="0" anchor="ctr"/>
-          <a:lstStyle/>
-          <a:p>
-            <a:pPr indent="0" marL="0">
+              <a:t>Embed + retrieve</a:t>
+            </a:r>
+            <a:endParaRPr lang="en-US" sz="950" dirty="0"/>
+          </a:p>
+        </p:txBody>
+      </p:sp>
+      <p:sp>
+        <p:nvSpPr>
+          <p:cNvPr id="15" name="Text 13"/>
+          <p:cNvSpPr/>
+          <p:nvPr/>
+        </p:nvSpPr>
+        <p:spPr>
+          <a:xfrm>
+            <a:off x="3849624" y="1527048"/>
+            <a:ext cx="1444752" cy="438912"/>
+          </a:xfrm>
+          <a:prstGeom prst="rect">
+            <a:avLst/>
+          </a:prstGeom>
+          <a:noFill/>
+          <a:ln/>
+        </p:spPr>
+        <p:txBody>
+          <a:bodyPr wrap="square" lIns="0" tIns="0" rIns="0" bIns="0" rtlCol="0" anchor="ctr"/>
+          <a:lstStyle/>
+          <a:p>
+            <a:pPr algn="ctr" indent="0" marL="0">
               <a:lnSpc>
-                <a:spcPct val="108000"/>
+                <a:spcPct val="100000"/>
               </a:lnSpc>
               <a:buNone/>
             </a:pPr>
             <a:r>
-              <a:rPr lang="en-US" sz="950" dirty="0">
-                <a:solidFill>
-                  <a:srgbClr val="17241D"/>
-                </a:solidFill>
-                <a:latin typeface="Arial" pitchFamily="34" charset="0"/>
-                <a:ea typeface="Arial" pitchFamily="34" charset="-122"/>
-                <a:cs typeface="Arial" pitchFamily="34" charset="-120"/>
-              </a:rPr>
-              <a:t>A trust feature can't lie → every story is grounded in a real artist-data source (RAG). Same no-fabrication guardrail as the engine.</a:t>
-            </a:r>
-            <a:endParaRPr lang="en-US" sz="950" dirty="0"/>
-          </a:p>
-        </p:txBody>
-      </p:sp>
-      <p:sp>
-        <p:nvSpPr>
-          <p:cNvPr id="24" name="Shape 22"/>
-          <p:cNvSpPr/>
-          <p:nvPr/>
-        </p:nvSpPr>
-        <p:spPr>
-          <a:xfrm>
-            <a:off x="4663440" y="2286000"/>
-            <a:ext cx="4206240" cy="969264"/>
+              <a:rPr lang="en-US" sz="750" dirty="0">
+                <a:solidFill>
+                  <a:srgbClr val="5C6B62"/>
+                </a:solidFill>
+                <a:latin typeface="Arial" pitchFamily="34" charset="0"/>
+                <a:ea typeface="Arial" pitchFamily="34" charset="-122"/>
+                <a:cs typeface="Arial" pitchFamily="34" charset="-120"/>
+              </a:rPr>
+              <a:t>MiniLM 384-d</a:t>
+            </a:r>
+            <a:endParaRPr lang="en-US" sz="750" dirty="0"/>
+          </a:p>
+          <a:p>
+            <a:pPr algn="ctr" indent="0" marL="0">
+              <a:lnSpc>
+                <a:spcPct val="100000"/>
+              </a:lnSpc>
+              <a:buNone/>
+            </a:pPr>
+            <a:r>
+              <a:rPr lang="en-US" sz="750" dirty="0">
+                <a:solidFill>
+                  <a:srgbClr val="5C6B62"/>
+                </a:solidFill>
+                <a:latin typeface="Arial" pitchFamily="34" charset="0"/>
+                <a:ea typeface="Arial" pitchFamily="34" charset="-122"/>
+                <a:cs typeface="Arial" pitchFamily="34" charset="-120"/>
+              </a:rPr>
+              <a:t>semantic search</a:t>
+            </a:r>
+            <a:endParaRPr lang="en-US" sz="750" dirty="0"/>
+          </a:p>
+        </p:txBody>
+      </p:sp>
+      <p:sp>
+        <p:nvSpPr>
+          <p:cNvPr id="16" name="Text 14"/>
+          <p:cNvSpPr/>
+          <p:nvPr/>
+        </p:nvSpPr>
+        <p:spPr>
+          <a:xfrm>
+            <a:off x="5367528" y="1426464"/>
+            <a:ext cx="201168" cy="365760"/>
+          </a:xfrm>
+          <a:prstGeom prst="rect">
+            <a:avLst/>
+          </a:prstGeom>
+          <a:noFill/>
+          <a:ln/>
+        </p:spPr>
+        <p:txBody>
+          <a:bodyPr wrap="square" lIns="0" tIns="0" rIns="0" bIns="0" rtlCol="0" anchor="ctr"/>
+          <a:lstStyle/>
+          <a:p>
+            <a:pPr algn="ctr" indent="0" marL="0">
+              <a:buNone/>
+            </a:pPr>
+            <a:r>
+              <a:rPr lang="en-US" sz="1500" b="1" dirty="0">
+                <a:solidFill>
+                  <a:srgbClr val="9AA6A0"/>
+                </a:solidFill>
+                <a:latin typeface="Arial" pitchFamily="34" charset="0"/>
+                <a:ea typeface="Arial" pitchFamily="34" charset="-122"/>
+                <a:cs typeface="Arial" pitchFamily="34" charset="-120"/>
+              </a:rPr>
+              <a:t>→</a:t>
+            </a:r>
+            <a:endParaRPr lang="en-US" sz="1500" dirty="0"/>
+          </a:p>
+        </p:txBody>
+      </p:sp>
+      <p:sp>
+        <p:nvSpPr>
+          <p:cNvPr id="17" name="Shape 15"/>
+          <p:cNvSpPr/>
+          <p:nvPr/>
+        </p:nvSpPr>
+        <p:spPr>
+          <a:xfrm>
+            <a:off x="5554980" y="1225296"/>
+            <a:ext cx="1554480" cy="786384"/>
           </a:xfrm>
           <a:prstGeom prst="roundRect">
             <a:avLst>
-              <a:gd name="adj" fmla="val 6604"/>
+              <a:gd name="adj" fmla="val 6977"/>
             </a:avLst>
           </a:prstGeom>
           <a:solidFill>
-            <a:srgbClr val="FBE3DD"/>
+            <a:srgbClr val="E7F6EC"/>
           </a:solidFill>
           <a:ln w="12700">
             <a:solidFill>
@@ -2981,30 +2818,33 @@
       </p:sp>
       <p:sp>
         <p:nvSpPr>
-          <p:cNvPr id="25" name="Text 23"/>
-          <p:cNvSpPr/>
-          <p:nvPr/>
-        </p:nvSpPr>
-        <p:spPr>
-          <a:xfrm>
-            <a:off x="4818888" y="2359152"/>
-            <a:ext cx="3895344" cy="256032"/>
-          </a:xfrm>
-          <a:prstGeom prst="rect">
-            <a:avLst/>
-          </a:prstGeom>
-          <a:noFill/>
-          <a:ln/>
-        </p:spPr>
-        <p:txBody>
-          <a:bodyPr wrap="square" lIns="0" tIns="0" rIns="0" bIns="0" rtlCol="0" anchor="ctr"/>
-          <a:lstStyle/>
-          <a:p>
-            <a:pPr indent="0" marL="0">
-              <a:buNone/>
-            </a:pPr>
-            <a:r>
-              <a:rPr lang="en-US" sz="1100" b="1" dirty="0">
+          <p:cNvPr id="18" name="Text 16"/>
+          <p:cNvSpPr/>
+          <p:nvPr/>
+        </p:nvSpPr>
+        <p:spPr>
+          <a:xfrm>
+            <a:off x="5609844" y="1280160"/>
+            <a:ext cx="1444752" cy="256032"/>
+          </a:xfrm>
+          <a:prstGeom prst="rect">
+            <a:avLst/>
+          </a:prstGeom>
+          <a:noFill/>
+          <a:ln/>
+        </p:spPr>
+        <p:txBody>
+          <a:bodyPr wrap="square" lIns="0" tIns="0" rIns="0" bIns="0" rtlCol="0" anchor="ctr"/>
+          <a:lstStyle/>
+          <a:p>
+            <a:pPr algn="ctr" indent="0" marL="0">
+              <a:lnSpc>
+                <a:spcPct val="90000"/>
+              </a:lnSpc>
+              <a:buNone/>
+            </a:pPr>
+            <a:r>
+              <a:rPr lang="en-US" sz="950" b="1" dirty="0">
                 <a:solidFill>
                   <a:srgbClr val="17241D"/>
                 </a:solidFill>
@@ -3012,72 +2852,131 @@
                 <a:ea typeface="Arial" pitchFamily="34" charset="-122"/>
                 <a:cs typeface="Arial" pitchFamily="34" charset="-120"/>
               </a:rPr>
-              <a:t>Cold start (no friends/history)</a:t>
-            </a:r>
-            <a:endParaRPr lang="en-US" sz="1100" dirty="0"/>
-          </a:p>
-        </p:txBody>
-      </p:sp>
-      <p:sp>
-        <p:nvSpPr>
-          <p:cNvPr id="26" name="Text 24"/>
-          <p:cNvSpPr/>
-          <p:nvPr/>
-        </p:nvSpPr>
-        <p:spPr>
-          <a:xfrm>
-            <a:off x="4818888" y="2615184"/>
-            <a:ext cx="3895344" cy="603504"/>
-          </a:xfrm>
-          <a:prstGeom prst="rect">
-            <a:avLst/>
-          </a:prstGeom>
-          <a:noFill/>
-          <a:ln/>
-        </p:spPr>
-        <p:txBody>
-          <a:bodyPr wrap="square" lIns="0" tIns="0" rIns="0" bIns="0" rtlCol="0" anchor="ctr"/>
-          <a:lstStyle/>
-          <a:p>
-            <a:pPr indent="0" marL="0">
+              <a:t>Synthesize</a:t>
+            </a:r>
+            <a:endParaRPr lang="en-US" sz="950" dirty="0"/>
+          </a:p>
+        </p:txBody>
+      </p:sp>
+      <p:sp>
+        <p:nvSpPr>
+          <p:cNvPr id="19" name="Text 17"/>
+          <p:cNvSpPr/>
+          <p:nvPr/>
+        </p:nvSpPr>
+        <p:spPr>
+          <a:xfrm>
+            <a:off x="5609844" y="1527048"/>
+            <a:ext cx="1444752" cy="438912"/>
+          </a:xfrm>
+          <a:prstGeom prst="rect">
+            <a:avLst/>
+          </a:prstGeom>
+          <a:noFill/>
+          <a:ln/>
+        </p:spPr>
+        <p:txBody>
+          <a:bodyPr wrap="square" lIns="0" tIns="0" rIns="0" bIns="0" rtlCol="0" anchor="ctr"/>
+          <a:lstStyle/>
+          <a:p>
+            <a:pPr algn="ctr" indent="0" marL="0">
               <a:lnSpc>
-                <a:spcPct val="108000"/>
+                <a:spcPct val="100000"/>
               </a:lnSpc>
               <a:buNone/>
             </a:pPr>
             <a:r>
-              <a:rPr lang="en-US" sz="950" dirty="0">
-                <a:solidFill>
-                  <a:srgbClr val="17241D"/>
-                </a:solidFill>
-                <a:latin typeface="Arial" pitchFamily="34" charset="0"/>
-                <a:ea typeface="Arial" pitchFamily="34" charset="-122"/>
-                <a:cs typeface="Arial" pitchFamily="34" charset="-120"/>
-              </a:rPr>
-              <a:t>The AI story always works alone; taste-twin fills in; social is a bonus, never required.</a:t>
-            </a:r>
-            <a:endParaRPr lang="en-US" sz="950" dirty="0"/>
-          </a:p>
-        </p:txBody>
-      </p:sp>
-      <p:sp>
-        <p:nvSpPr>
-          <p:cNvPr id="27" name="Shape 25"/>
-          <p:cNvSpPr/>
-          <p:nvPr/>
-        </p:nvSpPr>
-        <p:spPr>
-          <a:xfrm>
-            <a:off x="4663440" y="3364992"/>
-            <a:ext cx="4206240" cy="969264"/>
+              <a:rPr lang="en-US" sz="750" dirty="0">
+                <a:solidFill>
+                  <a:srgbClr val="5C6B62"/>
+                </a:solidFill>
+                <a:latin typeface="Arial" pitchFamily="34" charset="0"/>
+                <a:ea typeface="Arial" pitchFamily="34" charset="-122"/>
+                <a:cs typeface="Arial" pitchFamily="34" charset="-120"/>
+              </a:rPr>
+              <a:t>grounded, cited</a:t>
+            </a:r>
+            <a:endParaRPr lang="en-US" sz="750" dirty="0"/>
+          </a:p>
+          <a:p>
+            <a:pPr algn="ctr" indent="0" marL="0">
+              <a:lnSpc>
+                <a:spcPct val="100000"/>
+              </a:lnSpc>
+              <a:buNone/>
+            </a:pPr>
+            <a:r>
+              <a:rPr lang="en-US" sz="750" dirty="0">
+                <a:solidFill>
+                  <a:srgbClr val="5C6B62"/>
+                </a:solidFill>
+                <a:latin typeface="Arial" pitchFamily="34" charset="0"/>
+                <a:ea typeface="Arial" pitchFamily="34" charset="-122"/>
+                <a:cs typeface="Arial" pitchFamily="34" charset="-120"/>
+              </a:rPr>
+              <a:t>Q&amp;A · no fabrication</a:t>
+            </a:r>
+            <a:endParaRPr lang="en-US" sz="750" dirty="0"/>
+          </a:p>
+        </p:txBody>
+      </p:sp>
+      <p:sp>
+        <p:nvSpPr>
+          <p:cNvPr id="20" name="Text 18"/>
+          <p:cNvSpPr/>
+          <p:nvPr/>
+        </p:nvSpPr>
+        <p:spPr>
+          <a:xfrm>
+            <a:off x="7127748" y="1426464"/>
+            <a:ext cx="201168" cy="365760"/>
+          </a:xfrm>
+          <a:prstGeom prst="rect">
+            <a:avLst/>
+          </a:prstGeom>
+          <a:noFill/>
+          <a:ln/>
+        </p:spPr>
+        <p:txBody>
+          <a:bodyPr wrap="square" lIns="0" tIns="0" rIns="0" bIns="0" rtlCol="0" anchor="ctr"/>
+          <a:lstStyle/>
+          <a:p>
+            <a:pPr algn="ctr" indent="0" marL="0">
+              <a:buNone/>
+            </a:pPr>
+            <a:r>
+              <a:rPr lang="en-US" sz="1500" b="1" dirty="0">
+                <a:solidFill>
+                  <a:srgbClr val="9AA6A0"/>
+                </a:solidFill>
+                <a:latin typeface="Arial" pitchFamily="34" charset="0"/>
+                <a:ea typeface="Arial" pitchFamily="34" charset="-122"/>
+                <a:cs typeface="Arial" pitchFamily="34" charset="-120"/>
+              </a:rPr>
+              <a:t>→</a:t>
+            </a:r>
+            <a:endParaRPr lang="en-US" sz="1500" dirty="0"/>
+          </a:p>
+        </p:txBody>
+      </p:sp>
+      <p:sp>
+        <p:nvSpPr>
+          <p:cNvPr id="21" name="Shape 19"/>
+          <p:cNvSpPr/>
+          <p:nvPr/>
+        </p:nvSpPr>
+        <p:spPr>
+          <a:xfrm>
+            <a:off x="7315200" y="1225296"/>
+            <a:ext cx="1554480" cy="786384"/>
           </a:xfrm>
           <a:prstGeom prst="roundRect">
             <a:avLst>
-              <a:gd name="adj" fmla="val 6604"/>
+              <a:gd name="adj" fmla="val 6977"/>
             </a:avLst>
           </a:prstGeom>
           <a:solidFill>
-            <a:srgbClr val="FBE3DD"/>
+            <a:srgbClr val="CFEAD8"/>
           </a:solidFill>
           <a:ln w="12700">
             <a:solidFill>
@@ -3096,30 +2995,426 @@
       </p:sp>
       <p:sp>
         <p:nvSpPr>
+          <p:cNvPr id="22" name="Text 20"/>
+          <p:cNvSpPr/>
+          <p:nvPr/>
+        </p:nvSpPr>
+        <p:spPr>
+          <a:xfrm>
+            <a:off x="7370064" y="1280160"/>
+            <a:ext cx="1444752" cy="256032"/>
+          </a:xfrm>
+          <a:prstGeom prst="rect">
+            <a:avLst/>
+          </a:prstGeom>
+          <a:noFill/>
+          <a:ln/>
+        </p:spPr>
+        <p:txBody>
+          <a:bodyPr wrap="square" lIns="0" tIns="0" rIns="0" bIns="0" rtlCol="0" anchor="ctr"/>
+          <a:lstStyle/>
+          <a:p>
+            <a:pPr algn="ctr" indent="0" marL="0">
+              <a:lnSpc>
+                <a:spcPct val="90000"/>
+              </a:lnSpc>
+              <a:buNone/>
+            </a:pPr>
+            <a:r>
+              <a:rPr lang="en-US" sz="950" b="1" dirty="0">
+                <a:solidFill>
+                  <a:srgbClr val="0E6B37"/>
+                </a:solidFill>
+                <a:latin typeface="Arial" pitchFamily="34" charset="0"/>
+                <a:ea typeface="Arial" pitchFamily="34" charset="-122"/>
+                <a:cs typeface="Arial" pitchFamily="34" charset="-120"/>
+              </a:rPr>
+              <a:t>💡 Insight</a:t>
+            </a:r>
+            <a:endParaRPr lang="en-US" sz="950" dirty="0"/>
+          </a:p>
+        </p:txBody>
+      </p:sp>
+      <p:sp>
+        <p:nvSpPr>
+          <p:cNvPr id="23" name="Text 21"/>
+          <p:cNvSpPr/>
+          <p:nvPr/>
+        </p:nvSpPr>
+        <p:spPr>
+          <a:xfrm>
+            <a:off x="7370064" y="1527048"/>
+            <a:ext cx="1444752" cy="438912"/>
+          </a:xfrm>
+          <a:prstGeom prst="rect">
+            <a:avLst/>
+          </a:prstGeom>
+          <a:noFill/>
+          <a:ln/>
+        </p:spPr>
+        <p:txBody>
+          <a:bodyPr wrap="square" lIns="0" tIns="0" rIns="0" bIns="0" rtlCol="0" anchor="ctr"/>
+          <a:lstStyle/>
+          <a:p>
+            <a:pPr algn="ctr" indent="0" marL="0">
+              <a:lnSpc>
+                <a:spcPct val="100000"/>
+              </a:lnSpc>
+              <a:buNone/>
+            </a:pPr>
+            <a:r>
+              <a:rPr lang="en-US" sz="750" dirty="0">
+                <a:solidFill>
+                  <a:srgbClr val="5C6B62"/>
+                </a:solidFill>
+                <a:latin typeface="Arial" pitchFamily="34" charset="0"/>
+                <a:ea typeface="Arial" pitchFamily="34" charset="-122"/>
+                <a:cs typeface="Arial" pitchFamily="34" charset="-120"/>
+              </a:rPr>
+              <a:t>#1 pain = stale/repeat</a:t>
+            </a:r>
+            <a:endParaRPr lang="en-US" sz="750" dirty="0"/>
+          </a:p>
+          <a:p>
+            <a:pPr algn="ctr" indent="0" marL="0">
+              <a:lnSpc>
+                <a:spcPct val="100000"/>
+              </a:lnSpc>
+              <a:buNone/>
+            </a:pPr>
+            <a:r>
+              <a:rPr lang="en-US" sz="750" dirty="0">
+                <a:solidFill>
+                  <a:srgbClr val="5C6B62"/>
+                </a:solidFill>
+                <a:latin typeface="Arial" pitchFamily="34" charset="0"/>
+                <a:ea typeface="Arial" pitchFamily="34" charset="-122"/>
+                <a:cs typeface="Arial" pitchFamily="34" charset="-120"/>
+              </a:rPr>
+              <a:t>→ gap is ACCEPTANCE</a:t>
+            </a:r>
+            <a:endParaRPr lang="en-US" sz="750" dirty="0"/>
+          </a:p>
+        </p:txBody>
+      </p:sp>
+      <p:sp>
+        <p:nvSpPr>
+          <p:cNvPr id="24" name="Text 22"/>
+          <p:cNvSpPr/>
+          <p:nvPr/>
+        </p:nvSpPr>
+        <p:spPr>
+          <a:xfrm>
+            <a:off x="274320" y="2103120"/>
+            <a:ext cx="8595360" cy="237744"/>
+          </a:xfrm>
+          <a:prstGeom prst="rect">
+            <a:avLst/>
+          </a:prstGeom>
+          <a:noFill/>
+          <a:ln/>
+        </p:spPr>
+        <p:txBody>
+          <a:bodyPr wrap="square" lIns="0" tIns="0" rIns="0" bIns="0" rtlCol="0" anchor="ctr"/>
+          <a:lstStyle/>
+          <a:p>
+            <a:pPr algn="ctr" indent="0" marL="0">
+              <a:buNone/>
+            </a:pPr>
+            <a:r>
+              <a:rPr lang="en-US" sz="1000" b="1" i="1" dirty="0">
+                <a:solidFill>
+                  <a:srgbClr val="0E6B37"/>
+                </a:solidFill>
+                <a:latin typeface="Arial" pitchFamily="34" charset="0"/>
+                <a:ea typeface="Arial" pitchFamily="34" charset="-122"/>
+                <a:cs typeface="Arial" pitchFamily="34" charset="-120"/>
+              </a:rPr>
+              <a:t>▼  the finding is the product spec</a:t>
+            </a:r>
+            <a:endParaRPr lang="en-US" sz="1000" dirty="0"/>
+          </a:p>
+        </p:txBody>
+      </p:sp>
+      <p:sp>
+        <p:nvSpPr>
+          <p:cNvPr id="25" name="Text 23"/>
+          <p:cNvSpPr/>
+          <p:nvPr/>
+        </p:nvSpPr>
+        <p:spPr>
+          <a:xfrm>
+            <a:off x="274320" y="2377440"/>
+            <a:ext cx="8595360" cy="237744"/>
+          </a:xfrm>
+          <a:prstGeom prst="rect">
+            <a:avLst/>
+          </a:prstGeom>
+          <a:noFill/>
+          <a:ln/>
+        </p:spPr>
+        <p:txBody>
+          <a:bodyPr wrap="square" lIns="0" tIns="0" rIns="0" bIns="0" rtlCol="0" anchor="ctr"/>
+          <a:lstStyle/>
+          <a:p>
+            <a:pPr indent="0" marL="0">
+              <a:buNone/>
+            </a:pPr>
+            <a:r>
+              <a:rPr lang="en-US" sz="1000" b="1" spc="150" kern="0" dirty="0">
+                <a:solidFill>
+                  <a:srgbClr val="0E6B37"/>
+                </a:solidFill>
+                <a:latin typeface="Arial" pitchFamily="34" charset="0"/>
+                <a:ea typeface="Arial" pitchFamily="34" charset="-122"/>
+                <a:cs typeface="Arial" pitchFamily="34" charset="-120"/>
+              </a:rPr>
+              <a:t>② OFF REPEAT MVP — HOW WE ACT ON IT (LIVE, PER USER)</a:t>
+            </a:r>
+            <a:endParaRPr lang="en-US" sz="1000" dirty="0"/>
+          </a:p>
+        </p:txBody>
+      </p:sp>
+      <p:sp>
+        <p:nvSpPr>
+          <p:cNvPr id="26" name="Shape 24"/>
+          <p:cNvSpPr/>
+          <p:nvPr/>
+        </p:nvSpPr>
+        <p:spPr>
+          <a:xfrm>
+            <a:off x="274320" y="2688336"/>
+            <a:ext cx="1554480" cy="786384"/>
+          </a:xfrm>
+          <a:prstGeom prst="roundRect">
+            <a:avLst>
+              <a:gd name="adj" fmla="val 6977"/>
+            </a:avLst>
+          </a:prstGeom>
+          <a:solidFill>
+            <a:srgbClr val="E6EFF7"/>
+          </a:solidFill>
+          <a:ln w="12700">
+            <a:solidFill>
+              <a:srgbClr val="D8E5DC"/>
+            </a:solidFill>
+            <a:prstDash val="solid"/>
+          </a:ln>
+          <a:effectLst>
+            <a:outerShdw sx="100000" sy="100000" kx="0" ky="0" algn="bl" rotWithShape="0" blurRad="88900" dist="25400" dir="5400000">
+              <a:srgbClr val="6B6B6B">
+                <a:alpha val="22000"/>
+              </a:srgbClr>
+            </a:outerShdw>
+          </a:effectLst>
+        </p:spPr>
+      </p:sp>
+      <p:sp>
+        <p:nvSpPr>
+          <p:cNvPr id="27" name="Text 25"/>
+          <p:cNvSpPr/>
+          <p:nvPr/>
+        </p:nvSpPr>
+        <p:spPr>
+          <a:xfrm>
+            <a:off x="329184" y="2743200"/>
+            <a:ext cx="1444752" cy="256032"/>
+          </a:xfrm>
+          <a:prstGeom prst="rect">
+            <a:avLst/>
+          </a:prstGeom>
+          <a:noFill/>
+          <a:ln/>
+        </p:spPr>
+        <p:txBody>
+          <a:bodyPr wrap="square" lIns="0" tIns="0" rIns="0" bIns="0" rtlCol="0" anchor="ctr"/>
+          <a:lstStyle/>
+          <a:p>
+            <a:pPr algn="ctr" indent="0" marL="0">
+              <a:lnSpc>
+                <a:spcPct val="90000"/>
+              </a:lnSpc>
+              <a:buNone/>
+            </a:pPr>
+            <a:r>
+              <a:rPr lang="en-US" sz="950" b="1" dirty="0">
+                <a:solidFill>
+                  <a:srgbClr val="17241D"/>
+                </a:solidFill>
+                <a:latin typeface="Arial" pitchFamily="34" charset="0"/>
+                <a:ea typeface="Arial" pitchFamily="34" charset="-122"/>
+                <a:cs typeface="Arial" pitchFamily="34" charset="-120"/>
+              </a:rPr>
+              <a:t>Signals</a:t>
+            </a:r>
+            <a:endParaRPr lang="en-US" sz="950" dirty="0"/>
+          </a:p>
+        </p:txBody>
+      </p:sp>
+      <p:sp>
+        <p:nvSpPr>
           <p:cNvPr id="28" name="Text 26"/>
           <p:cNvSpPr/>
           <p:nvPr/>
         </p:nvSpPr>
         <p:spPr>
           <a:xfrm>
-            <a:off x="4818888" y="3438144"/>
-            <a:ext cx="3895344" cy="256032"/>
-          </a:xfrm>
-          <a:prstGeom prst="rect">
-            <a:avLst/>
-          </a:prstGeom>
-          <a:noFill/>
-          <a:ln/>
-        </p:spPr>
-        <p:txBody>
-          <a:bodyPr wrap="square" lIns="0" tIns="0" rIns="0" bIns="0" rtlCol="0" anchor="ctr"/>
-          <a:lstStyle/>
-          <a:p>
-            <a:pPr indent="0" marL="0">
-              <a:buNone/>
-            </a:pPr>
-            <a:r>
-              <a:rPr lang="en-US" sz="1100" b="1" dirty="0">
+            <a:off x="329184" y="2990088"/>
+            <a:ext cx="1444752" cy="438912"/>
+          </a:xfrm>
+          <a:prstGeom prst="rect">
+            <a:avLst/>
+          </a:prstGeom>
+          <a:noFill/>
+          <a:ln/>
+        </p:spPr>
+        <p:txBody>
+          <a:bodyPr wrap="square" lIns="0" tIns="0" rIns="0" bIns="0" rtlCol="0" anchor="ctr"/>
+          <a:lstStyle/>
+          <a:p>
+            <a:pPr algn="ctr" indent="0" marL="0">
+              <a:lnSpc>
+                <a:spcPct val="100000"/>
+              </a:lnSpc>
+              <a:buNone/>
+            </a:pPr>
+            <a:r>
+              <a:rPr lang="en-US" sz="750" dirty="0">
+                <a:solidFill>
+                  <a:srgbClr val="5C6B62"/>
+                </a:solidFill>
+                <a:latin typeface="Arial" pitchFamily="34" charset="0"/>
+                <a:ea typeface="Arial" pitchFamily="34" charset="-122"/>
+                <a:cs typeface="Arial" pitchFamily="34" charset="-120"/>
+              </a:rPr>
+              <a:t>listening history</a:t>
+            </a:r>
+            <a:endParaRPr lang="en-US" sz="750" dirty="0"/>
+          </a:p>
+          <a:p>
+            <a:pPr algn="ctr" indent="0" marL="0">
+              <a:lnSpc>
+                <a:spcPct val="100000"/>
+              </a:lnSpc>
+              <a:buNone/>
+            </a:pPr>
+            <a:r>
+              <a:rPr lang="en-US" sz="750" dirty="0">
+                <a:solidFill>
+                  <a:srgbClr val="5C6B62"/>
+                </a:solidFill>
+                <a:latin typeface="Arial" pitchFamily="34" charset="0"/>
+                <a:ea typeface="Arial" pitchFamily="34" charset="-122"/>
+                <a:cs typeface="Arial" pitchFamily="34" charset="-120"/>
+              </a:rPr>
+              <a:t>saves · friends</a:t>
+            </a:r>
+            <a:endParaRPr lang="en-US" sz="750" dirty="0"/>
+          </a:p>
+        </p:txBody>
+      </p:sp>
+      <p:sp>
+        <p:nvSpPr>
+          <p:cNvPr id="29" name="Text 27"/>
+          <p:cNvSpPr/>
+          <p:nvPr/>
+        </p:nvSpPr>
+        <p:spPr>
+          <a:xfrm>
+            <a:off x="1847088" y="2889504"/>
+            <a:ext cx="201168" cy="365760"/>
+          </a:xfrm>
+          <a:prstGeom prst="rect">
+            <a:avLst/>
+          </a:prstGeom>
+          <a:noFill/>
+          <a:ln/>
+        </p:spPr>
+        <p:txBody>
+          <a:bodyPr wrap="square" lIns="0" tIns="0" rIns="0" bIns="0" rtlCol="0" anchor="ctr"/>
+          <a:lstStyle/>
+          <a:p>
+            <a:pPr algn="ctr" indent="0" marL="0">
+              <a:buNone/>
+            </a:pPr>
+            <a:r>
+              <a:rPr lang="en-US" sz="1500" b="1" dirty="0">
+                <a:solidFill>
+                  <a:srgbClr val="9AA6A0"/>
+                </a:solidFill>
+                <a:latin typeface="Arial" pitchFamily="34" charset="0"/>
+                <a:ea typeface="Arial" pitchFamily="34" charset="-122"/>
+                <a:cs typeface="Arial" pitchFamily="34" charset="-120"/>
+              </a:rPr>
+              <a:t>→</a:t>
+            </a:r>
+            <a:endParaRPr lang="en-US" sz="1500" dirty="0"/>
+          </a:p>
+        </p:txBody>
+      </p:sp>
+      <p:sp>
+        <p:nvSpPr>
+          <p:cNvPr id="30" name="Shape 28"/>
+          <p:cNvSpPr/>
+          <p:nvPr/>
+        </p:nvSpPr>
+        <p:spPr>
+          <a:xfrm>
+            <a:off x="2034540" y="2688336"/>
+            <a:ext cx="1554480" cy="786384"/>
+          </a:xfrm>
+          <a:prstGeom prst="roundRect">
+            <a:avLst>
+              <a:gd name="adj" fmla="val 6977"/>
+            </a:avLst>
+          </a:prstGeom>
+          <a:solidFill>
+            <a:srgbClr val="E6EFF7"/>
+          </a:solidFill>
+          <a:ln w="12700">
+            <a:solidFill>
+              <a:srgbClr val="D8E5DC"/>
+            </a:solidFill>
+            <a:prstDash val="solid"/>
+          </a:ln>
+          <a:effectLst>
+            <a:outerShdw sx="100000" sy="100000" kx="0" ky="0" algn="bl" rotWithShape="0" blurRad="88900" dist="25400" dir="5400000">
+              <a:srgbClr val="6B6B6B">
+                <a:alpha val="22000"/>
+              </a:srgbClr>
+            </a:outerShdw>
+          </a:effectLst>
+        </p:spPr>
+      </p:sp>
+      <p:sp>
+        <p:nvSpPr>
+          <p:cNvPr id="31" name="Text 29"/>
+          <p:cNvSpPr/>
+          <p:nvPr/>
+        </p:nvSpPr>
+        <p:spPr>
+          <a:xfrm>
+            <a:off x="2089404" y="2743200"/>
+            <a:ext cx="1444752" cy="256032"/>
+          </a:xfrm>
+          <a:prstGeom prst="rect">
+            <a:avLst/>
+          </a:prstGeom>
+          <a:noFill/>
+          <a:ln/>
+        </p:spPr>
+        <p:txBody>
+          <a:bodyPr wrap="square" lIns="0" tIns="0" rIns="0" bIns="0" rtlCol="0" anchor="ctr"/>
+          <a:lstStyle/>
+          <a:p>
+            <a:pPr algn="ctr" indent="0" marL="0">
+              <a:lnSpc>
+                <a:spcPct val="90000"/>
+              </a:lnSpc>
+              <a:buNone/>
+            </a:pPr>
+            <a:r>
+              <a:rPr lang="en-US" sz="950" b="1" dirty="0">
                 <a:solidFill>
                   <a:srgbClr val="17241D"/>
                 </a:solidFill>
@@ -3127,41 +3422,176 @@
                 <a:ea typeface="Arial" pitchFamily="34" charset="-122"/>
                 <a:cs typeface="Arial" pitchFamily="34" charset="-120"/>
               </a:rPr>
-              <a:t>Story fatigue</a:t>
-            </a:r>
-            <a:endParaRPr lang="en-US" sz="1100" dirty="0"/>
-          </a:p>
-        </p:txBody>
-      </p:sp>
-      <p:sp>
-        <p:nvSpPr>
-          <p:cNvPr id="29" name="Text 27"/>
-          <p:cNvSpPr/>
-          <p:nvPr/>
-        </p:nvSpPr>
-        <p:spPr>
-          <a:xfrm>
-            <a:off x="4818888" y="3694176"/>
-            <a:ext cx="3895344" cy="603504"/>
-          </a:xfrm>
-          <a:prstGeom prst="rect">
-            <a:avLst/>
-          </a:prstGeom>
-          <a:noFill/>
-          <a:ln/>
-        </p:spPr>
-        <p:txBody>
-          <a:bodyPr wrap="square" lIns="0" tIns="0" rIns="0" bIns="0" rtlCol="0" anchor="ctr"/>
-          <a:lstStyle/>
-          <a:p>
-            <a:pPr indent="0" marL="0">
+              <a:t>Taste vector</a:t>
+            </a:r>
+            <a:endParaRPr lang="en-US" sz="950" dirty="0"/>
+          </a:p>
+        </p:txBody>
+      </p:sp>
+      <p:sp>
+        <p:nvSpPr>
+          <p:cNvPr id="32" name="Text 30"/>
+          <p:cNvSpPr/>
+          <p:nvPr/>
+        </p:nvSpPr>
+        <p:spPr>
+          <a:xfrm>
+            <a:off x="2089404" y="2990088"/>
+            <a:ext cx="1444752" cy="438912"/>
+          </a:xfrm>
+          <a:prstGeom prst="rect">
+            <a:avLst/>
+          </a:prstGeom>
+          <a:noFill/>
+          <a:ln/>
+        </p:spPr>
+        <p:txBody>
+          <a:bodyPr wrap="square" lIns="0" tIns="0" rIns="0" bIns="0" rtlCol="0" anchor="ctr"/>
+          <a:lstStyle/>
+          <a:p>
+            <a:pPr algn="ctr" indent="0" marL="0">
               <a:lnSpc>
-                <a:spcPct val="108000"/>
+                <a:spcPct val="100000"/>
               </a:lnSpc>
               <a:buNone/>
             </a:pPr>
             <a:r>
-              <a:rPr lang="en-US" sz="950" dirty="0">
+              <a:rPr lang="en-US" sz="750" dirty="0">
+                <a:solidFill>
+                  <a:srgbClr val="5C6B62"/>
+                </a:solidFill>
+                <a:latin typeface="Arial" pitchFamily="34" charset="0"/>
+                <a:ea typeface="Arial" pitchFamily="34" charset="-122"/>
+                <a:cs typeface="Arial" pitchFamily="34" charset="-120"/>
+              </a:rPr>
+              <a:t>embed what</a:t>
+            </a:r>
+            <a:endParaRPr lang="en-US" sz="750" dirty="0"/>
+          </a:p>
+          <a:p>
+            <a:pPr algn="ctr" indent="0" marL="0">
+              <a:lnSpc>
+                <a:spcPct val="100000"/>
+              </a:lnSpc>
+              <a:buNone/>
+            </a:pPr>
+            <a:r>
+              <a:rPr lang="en-US" sz="750" dirty="0">
+                <a:solidFill>
+                  <a:srgbClr val="5C6B62"/>
+                </a:solidFill>
+                <a:latin typeface="Arial" pitchFamily="34" charset="0"/>
+                <a:ea typeface="Arial" pitchFamily="34" charset="-122"/>
+                <a:cs typeface="Arial" pitchFamily="34" charset="-120"/>
+              </a:rPr>
+              <a:t>you love</a:t>
+            </a:r>
+            <a:endParaRPr lang="en-US" sz="750" dirty="0"/>
+          </a:p>
+        </p:txBody>
+      </p:sp>
+      <p:sp>
+        <p:nvSpPr>
+          <p:cNvPr id="33" name="Text 31"/>
+          <p:cNvSpPr/>
+          <p:nvPr/>
+        </p:nvSpPr>
+        <p:spPr>
+          <a:xfrm>
+            <a:off x="3607308" y="2889504"/>
+            <a:ext cx="201168" cy="365760"/>
+          </a:xfrm>
+          <a:prstGeom prst="rect">
+            <a:avLst/>
+          </a:prstGeom>
+          <a:noFill/>
+          <a:ln/>
+        </p:spPr>
+        <p:txBody>
+          <a:bodyPr wrap="square" lIns="0" tIns="0" rIns="0" bIns="0" rtlCol="0" anchor="ctr"/>
+          <a:lstStyle/>
+          <a:p>
+            <a:pPr algn="ctr" indent="0" marL="0">
+              <a:buNone/>
+            </a:pPr>
+            <a:r>
+              <a:rPr lang="en-US" sz="1500" b="1" dirty="0">
+                <a:solidFill>
+                  <a:srgbClr val="9AA6A0"/>
+                </a:solidFill>
+                <a:latin typeface="Arial" pitchFamily="34" charset="0"/>
+                <a:ea typeface="Arial" pitchFamily="34" charset="-122"/>
+                <a:cs typeface="Arial" pitchFamily="34" charset="-120"/>
+              </a:rPr>
+              <a:t>→</a:t>
+            </a:r>
+            <a:endParaRPr lang="en-US" sz="1500" dirty="0"/>
+          </a:p>
+        </p:txBody>
+      </p:sp>
+      <p:sp>
+        <p:nvSpPr>
+          <p:cNvPr id="34" name="Shape 32"/>
+          <p:cNvSpPr/>
+          <p:nvPr/>
+        </p:nvSpPr>
+        <p:spPr>
+          <a:xfrm>
+            <a:off x="3794760" y="2688336"/>
+            <a:ext cx="1554480" cy="786384"/>
+          </a:xfrm>
+          <a:prstGeom prst="roundRect">
+            <a:avLst>
+              <a:gd name="adj" fmla="val 6977"/>
+            </a:avLst>
+          </a:prstGeom>
+          <a:solidFill>
+            <a:srgbClr val="E6EFF7"/>
+          </a:solidFill>
+          <a:ln w="12700">
+            <a:solidFill>
+              <a:srgbClr val="D8E5DC"/>
+            </a:solidFill>
+            <a:prstDash val="solid"/>
+          </a:ln>
+          <a:effectLst>
+            <a:outerShdw sx="100000" sy="100000" kx="0" ky="0" algn="bl" rotWithShape="0" blurRad="88900" dist="25400" dir="5400000">
+              <a:srgbClr val="6B6B6B">
+                <a:alpha val="22000"/>
+              </a:srgbClr>
+            </a:outerShdw>
+          </a:effectLst>
+        </p:spPr>
+      </p:sp>
+      <p:sp>
+        <p:nvSpPr>
+          <p:cNvPr id="35" name="Text 33"/>
+          <p:cNvSpPr/>
+          <p:nvPr/>
+        </p:nvSpPr>
+        <p:spPr>
+          <a:xfrm>
+            <a:off x="3849624" y="2743200"/>
+            <a:ext cx="1444752" cy="256032"/>
+          </a:xfrm>
+          <a:prstGeom prst="rect">
+            <a:avLst/>
+          </a:prstGeom>
+          <a:noFill/>
+          <a:ln/>
+        </p:spPr>
+        <p:txBody>
+          <a:bodyPr wrap="square" lIns="0" tIns="0" rIns="0" bIns="0" rtlCol="0" anchor="ctr"/>
+          <a:lstStyle/>
+          <a:p>
+            <a:pPr algn="ctr" indent="0" marL="0">
+              <a:lnSpc>
+                <a:spcPct val="90000"/>
+              </a:lnSpc>
+              <a:buNone/>
+            </a:pPr>
+            <a:r>
+              <a:rPr lang="en-US" sz="950" b="1" dirty="0">
                 <a:solidFill>
                   <a:srgbClr val="17241D"/>
                 </a:solidFill>
@@ -3169,7 +3599,7 @@
                 <a:ea typeface="Arial" pitchFamily="34" charset="-122"/>
                 <a:cs typeface="Arial" pitchFamily="34" charset="-120"/>
               </a:rPr>
-              <a:t>Lean-in moments only. Default = one glanceable line; full story on tap. Silent in background listening.</a:t>
+              <a:t>Retrieve + filter</a:t>
             </a:r>
             <a:endParaRPr lang="en-US" sz="950" dirty="0"/>
           </a:p>
@@ -3177,33 +3607,345 @@
       </p:sp>
       <p:sp>
         <p:nvSpPr>
-          <p:cNvPr id="30" name="Text 28"/>
-          <p:cNvSpPr/>
-          <p:nvPr/>
-        </p:nvSpPr>
-        <p:spPr>
-          <a:xfrm>
-            <a:off x="274320" y="4297680"/>
-            <a:ext cx="4206240" cy="365760"/>
-          </a:xfrm>
-          <a:prstGeom prst="rect">
-            <a:avLst/>
-          </a:prstGeom>
-          <a:noFill/>
-          <a:ln/>
-        </p:spPr>
-        <p:txBody>
-          <a:bodyPr wrap="square" lIns="0" tIns="0" rIns="0" bIns="0" rtlCol="0" anchor="ctr"/>
-          <a:lstStyle/>
-          <a:p>
-            <a:pPr indent="0" marL="0">
+          <p:cNvPr id="36" name="Text 34"/>
+          <p:cNvSpPr/>
+          <p:nvPr/>
+        </p:nvSpPr>
+        <p:spPr>
+          <a:xfrm>
+            <a:off x="3849624" y="2990088"/>
+            <a:ext cx="1444752" cy="438912"/>
+          </a:xfrm>
+          <a:prstGeom prst="rect">
+            <a:avLst/>
+          </a:prstGeom>
+          <a:noFill/>
+          <a:ln/>
+        </p:spPr>
+        <p:txBody>
+          <a:bodyPr wrap="square" lIns="0" tIns="0" rIns="0" bIns="0" rtlCol="0" anchor="ctr"/>
+          <a:lstStyle/>
+          <a:p>
+            <a:pPr algn="ctr" indent="0" marL="0">
               <a:lnSpc>
-                <a:spcPct val="105000"/>
+                <a:spcPct val="100000"/>
               </a:lnSpc>
               <a:buNone/>
             </a:pPr>
             <a:r>
-              <a:rPr lang="en-US" sz="950" b="1" i="1" dirty="0">
+              <a:rPr lang="en-US" sz="750" dirty="0">
+                <a:solidFill>
+                  <a:srgbClr val="5C6B62"/>
+                </a:solidFill>
+                <a:latin typeface="Arial" pitchFamily="34" charset="0"/>
+                <a:ea typeface="Arial" pitchFamily="34" charset="-122"/>
+                <a:cs typeface="Arial" pitchFamily="34" charset="-120"/>
+              </a:rPr>
+              <a:t>novel, long-tail</a:t>
+            </a:r>
+            <a:endParaRPr lang="en-US" sz="750" dirty="0"/>
+          </a:p>
+          <a:p>
+            <a:pPr algn="ctr" indent="0" marL="0">
+              <a:lnSpc>
+                <a:spcPct val="100000"/>
+              </a:lnSpc>
+              <a:buNone/>
+            </a:pPr>
+            <a:r>
+              <a:rPr lang="en-US" sz="750" dirty="0">
+                <a:solidFill>
+                  <a:srgbClr val="5C6B62"/>
+                </a:solidFill>
+                <a:latin typeface="Arial" pitchFamily="34" charset="0"/>
+                <a:ea typeface="Arial" pitchFamily="34" charset="-122"/>
+                <a:cs typeface="Arial" pitchFamily="34" charset="-120"/>
+              </a:rPr>
+              <a:t>drop the known</a:t>
+            </a:r>
+            <a:endParaRPr lang="en-US" sz="750" dirty="0"/>
+          </a:p>
+        </p:txBody>
+      </p:sp>
+      <p:sp>
+        <p:nvSpPr>
+          <p:cNvPr id="37" name="Text 35"/>
+          <p:cNvSpPr/>
+          <p:nvPr/>
+        </p:nvSpPr>
+        <p:spPr>
+          <a:xfrm>
+            <a:off x="5367528" y="2889504"/>
+            <a:ext cx="201168" cy="365760"/>
+          </a:xfrm>
+          <a:prstGeom prst="rect">
+            <a:avLst/>
+          </a:prstGeom>
+          <a:noFill/>
+          <a:ln/>
+        </p:spPr>
+        <p:txBody>
+          <a:bodyPr wrap="square" lIns="0" tIns="0" rIns="0" bIns="0" rtlCol="0" anchor="ctr"/>
+          <a:lstStyle/>
+          <a:p>
+            <a:pPr algn="ctr" indent="0" marL="0">
+              <a:buNone/>
+            </a:pPr>
+            <a:r>
+              <a:rPr lang="en-US" sz="1500" b="1" dirty="0">
+                <a:solidFill>
+                  <a:srgbClr val="9AA6A0"/>
+                </a:solidFill>
+                <a:latin typeface="Arial" pitchFamily="34" charset="0"/>
+                <a:ea typeface="Arial" pitchFamily="34" charset="-122"/>
+                <a:cs typeface="Arial" pitchFamily="34" charset="-120"/>
+              </a:rPr>
+              <a:t>→</a:t>
+            </a:r>
+            <a:endParaRPr lang="en-US" sz="1500" dirty="0"/>
+          </a:p>
+        </p:txBody>
+      </p:sp>
+      <p:sp>
+        <p:nvSpPr>
+          <p:cNvPr id="38" name="Shape 36"/>
+          <p:cNvSpPr/>
+          <p:nvPr/>
+        </p:nvSpPr>
+        <p:spPr>
+          <a:xfrm>
+            <a:off x="5554980" y="2688336"/>
+            <a:ext cx="1554480" cy="786384"/>
+          </a:xfrm>
+          <a:prstGeom prst="roundRect">
+            <a:avLst>
+              <a:gd name="adj" fmla="val 6977"/>
+            </a:avLst>
+          </a:prstGeom>
+          <a:solidFill>
+            <a:srgbClr val="E6EFF7"/>
+          </a:solidFill>
+          <a:ln w="12700">
+            <a:solidFill>
+              <a:srgbClr val="D8E5DC"/>
+            </a:solidFill>
+            <a:prstDash val="solid"/>
+          </a:ln>
+          <a:effectLst>
+            <a:outerShdw sx="100000" sy="100000" kx="0" ky="0" algn="bl" rotWithShape="0" blurRad="88900" dist="25400" dir="5400000">
+              <a:srgbClr val="6B6B6B">
+                <a:alpha val="22000"/>
+              </a:srgbClr>
+            </a:outerShdw>
+          </a:effectLst>
+        </p:spPr>
+      </p:sp>
+      <p:sp>
+        <p:nvSpPr>
+          <p:cNvPr id="39" name="Text 37"/>
+          <p:cNvSpPr/>
+          <p:nvPr/>
+        </p:nvSpPr>
+        <p:spPr>
+          <a:xfrm>
+            <a:off x="5609844" y="2743200"/>
+            <a:ext cx="1444752" cy="256032"/>
+          </a:xfrm>
+          <a:prstGeom prst="rect">
+            <a:avLst/>
+          </a:prstGeom>
+          <a:noFill/>
+          <a:ln/>
+        </p:spPr>
+        <p:txBody>
+          <a:bodyPr wrap="square" lIns="0" tIns="0" rIns="0" bIns="0" rtlCol="0" anchor="ctr"/>
+          <a:lstStyle/>
+          <a:p>
+            <a:pPr algn="ctr" indent="0" marL="0">
+              <a:lnSpc>
+                <a:spcPct val="90000"/>
+              </a:lnSpc>
+              <a:buNone/>
+            </a:pPr>
+            <a:r>
+              <a:rPr lang="en-US" sz="950" b="1" dirty="0">
+                <a:solidFill>
+                  <a:srgbClr val="17241D"/>
+                </a:solidFill>
+                <a:latin typeface="Arial" pitchFamily="34" charset="0"/>
+                <a:ea typeface="Arial" pitchFamily="34" charset="-122"/>
+                <a:cs typeface="Arial" pitchFamily="34" charset="-120"/>
+              </a:rPr>
+              <a:t>Grounded story + trust</a:t>
+            </a:r>
+            <a:endParaRPr lang="en-US" sz="950" dirty="0"/>
+          </a:p>
+        </p:txBody>
+      </p:sp>
+      <p:sp>
+        <p:nvSpPr>
+          <p:cNvPr id="40" name="Text 38"/>
+          <p:cNvSpPr/>
+          <p:nvPr/>
+        </p:nvSpPr>
+        <p:spPr>
+          <a:xfrm>
+            <a:off x="5609844" y="2990088"/>
+            <a:ext cx="1444752" cy="438912"/>
+          </a:xfrm>
+          <a:prstGeom prst="rect">
+            <a:avLst/>
+          </a:prstGeom>
+          <a:noFill/>
+          <a:ln/>
+        </p:spPr>
+        <p:txBody>
+          <a:bodyPr wrap="square" lIns="0" tIns="0" rIns="0" bIns="0" rtlCol="0" anchor="ctr"/>
+          <a:lstStyle/>
+          <a:p>
+            <a:pPr algn="ctr" indent="0" marL="0">
+              <a:lnSpc>
+                <a:spcPct val="100000"/>
+              </a:lnSpc>
+              <a:buNone/>
+            </a:pPr>
+            <a:r>
+              <a:rPr lang="en-US" sz="750" dirty="0">
+                <a:solidFill>
+                  <a:srgbClr val="5C6B62"/>
+                </a:solidFill>
+                <a:latin typeface="Arial" pitchFamily="34" charset="0"/>
+                <a:ea typeface="Arial" pitchFamily="34" charset="-122"/>
+                <a:cs typeface="Arial" pitchFamily="34" charset="-120"/>
+              </a:rPr>
+              <a:t>LLM writes the 'why' (RAG)</a:t>
+            </a:r>
+            <a:endParaRPr lang="en-US" sz="750" dirty="0"/>
+          </a:p>
+          <a:p>
+            <a:pPr algn="ctr" indent="0" marL="0">
+              <a:lnSpc>
+                <a:spcPct val="100000"/>
+              </a:lnSpc>
+              <a:buNone/>
+            </a:pPr>
+            <a:r>
+              <a:rPr lang="en-US" sz="750" dirty="0">
+                <a:solidFill>
+                  <a:srgbClr val="5C6B62"/>
+                </a:solidFill>
+                <a:latin typeface="Arial" pitchFamily="34" charset="0"/>
+                <a:ea typeface="Arial" pitchFamily="34" charset="-122"/>
+                <a:cs typeface="Arial" pitchFamily="34" charset="-120"/>
+              </a:rPr>
+              <a:t>friend · twin · AI</a:t>
+            </a:r>
+            <a:endParaRPr lang="en-US" sz="750" dirty="0"/>
+          </a:p>
+        </p:txBody>
+      </p:sp>
+      <p:sp>
+        <p:nvSpPr>
+          <p:cNvPr id="41" name="Text 39"/>
+          <p:cNvSpPr/>
+          <p:nvPr/>
+        </p:nvSpPr>
+        <p:spPr>
+          <a:xfrm>
+            <a:off x="7127748" y="2889504"/>
+            <a:ext cx="201168" cy="365760"/>
+          </a:xfrm>
+          <a:prstGeom prst="rect">
+            <a:avLst/>
+          </a:prstGeom>
+          <a:noFill/>
+          <a:ln/>
+        </p:spPr>
+        <p:txBody>
+          <a:bodyPr wrap="square" lIns="0" tIns="0" rIns="0" bIns="0" rtlCol="0" anchor="ctr"/>
+          <a:lstStyle/>
+          <a:p>
+            <a:pPr algn="ctr" indent="0" marL="0">
+              <a:buNone/>
+            </a:pPr>
+            <a:r>
+              <a:rPr lang="en-US" sz="1500" b="1" dirty="0">
+                <a:solidFill>
+                  <a:srgbClr val="9AA6A0"/>
+                </a:solidFill>
+                <a:latin typeface="Arial" pitchFamily="34" charset="0"/>
+                <a:ea typeface="Arial" pitchFamily="34" charset="-122"/>
+                <a:cs typeface="Arial" pitchFamily="34" charset="-120"/>
+              </a:rPr>
+              <a:t>→</a:t>
+            </a:r>
+            <a:endParaRPr lang="en-US" sz="1500" dirty="0"/>
+          </a:p>
+        </p:txBody>
+      </p:sp>
+      <p:sp>
+        <p:nvSpPr>
+          <p:cNvPr id="42" name="Shape 40"/>
+          <p:cNvSpPr/>
+          <p:nvPr/>
+        </p:nvSpPr>
+        <p:spPr>
+          <a:xfrm>
+            <a:off x="7315200" y="2688336"/>
+            <a:ext cx="1554480" cy="786384"/>
+          </a:xfrm>
+          <a:prstGeom prst="roundRect">
+            <a:avLst>
+              <a:gd name="adj" fmla="val 6977"/>
+            </a:avLst>
+          </a:prstGeom>
+          <a:solidFill>
+            <a:srgbClr val="C7DBFF"/>
+          </a:solidFill>
+          <a:ln w="12700">
+            <a:solidFill>
+              <a:srgbClr val="D8E5DC"/>
+            </a:solidFill>
+            <a:prstDash val="solid"/>
+          </a:ln>
+          <a:effectLst>
+            <a:outerShdw sx="100000" sy="100000" kx="0" ky="0" algn="bl" rotWithShape="0" blurRad="88900" dist="25400" dir="5400000">
+              <a:srgbClr val="6B6B6B">
+                <a:alpha val="22000"/>
+              </a:srgbClr>
+            </a:outerShdw>
+          </a:effectLst>
+        </p:spPr>
+      </p:sp>
+      <p:sp>
+        <p:nvSpPr>
+          <p:cNvPr id="43" name="Text 41"/>
+          <p:cNvSpPr/>
+          <p:nvPr/>
+        </p:nvSpPr>
+        <p:spPr>
+          <a:xfrm>
+            <a:off x="7370064" y="2743200"/>
+            <a:ext cx="1444752" cy="256032"/>
+          </a:xfrm>
+          <a:prstGeom prst="rect">
+            <a:avLst/>
+          </a:prstGeom>
+          <a:noFill/>
+          <a:ln/>
+        </p:spPr>
+        <p:txBody>
+          <a:bodyPr wrap="square" lIns="0" tIns="0" rIns="0" bIns="0" rtlCol="0" anchor="ctr"/>
+          <a:lstStyle/>
+          <a:p>
+            <a:pPr algn="ctr" indent="0" marL="0">
+              <a:lnSpc>
+                <a:spcPct val="90000"/>
+              </a:lnSpc>
+              <a:buNone/>
+            </a:pPr>
+            <a:r>
+              <a:rPr lang="en-US" sz="950" b="1" dirty="0">
                 <a:solidFill>
                   <a:srgbClr val="0E6B37"/>
                 </a:solidFill>
@@ -3211,7 +3953,7 @@
                 <a:ea typeface="Arial" pitchFamily="34" charset="-122"/>
                 <a:cs typeface="Arial" pitchFamily="34" charset="-120"/>
               </a:rPr>
-              <a:t>The moat is the user's adoption profile — it compounds and can't be copied.</a:t>
+              <a:t>Serve + learn ↻</a:t>
             </a:r>
             <a:endParaRPr lang="en-US" sz="950" dirty="0"/>
           </a:p>
@@ -3219,7 +3961,196 @@
       </p:sp>
       <p:sp>
         <p:nvSpPr>
-          <p:cNvPr id="31" name="Shape 29"/>
+          <p:cNvPr id="44" name="Text 42"/>
+          <p:cNvSpPr/>
+          <p:nvPr/>
+        </p:nvSpPr>
+        <p:spPr>
+          <a:xfrm>
+            <a:off x="7370064" y="2990088"/>
+            <a:ext cx="1444752" cy="438912"/>
+          </a:xfrm>
+          <a:prstGeom prst="rect">
+            <a:avLst/>
+          </a:prstGeom>
+          <a:noFill/>
+          <a:ln/>
+        </p:spPr>
+        <p:txBody>
+          <a:bodyPr wrap="square" lIns="0" tIns="0" rIns="0" bIns="0" rtlCol="0" anchor="ctr"/>
+          <a:lstStyle/>
+          <a:p>
+            <a:pPr algn="ctr" indent="0" marL="0">
+              <a:lnSpc>
+                <a:spcPct val="100000"/>
+              </a:lnSpc>
+              <a:buNone/>
+            </a:pPr>
+            <a:r>
+              <a:rPr lang="en-US" sz="750" dirty="0">
+                <a:solidFill>
+                  <a:srgbClr val="5C6B62"/>
+                </a:solidFill>
+                <a:latin typeface="Arial" pitchFamily="34" charset="0"/>
+                <a:ea typeface="Arial" pitchFamily="34" charset="-122"/>
+                <a:cs typeface="Arial" pitchFamily="34" charset="-120"/>
+              </a:rPr>
+              <a:t>Spotify UI · learns</a:t>
+            </a:r>
+            <a:endParaRPr lang="en-US" sz="750" dirty="0"/>
+          </a:p>
+          <a:p>
+            <a:pPr algn="ctr" indent="0" marL="0">
+              <a:lnSpc>
+                <a:spcPct val="100000"/>
+              </a:lnSpc>
+              <a:buNone/>
+            </a:pPr>
+            <a:r>
+              <a:rPr lang="en-US" sz="750" dirty="0">
+                <a:solidFill>
+                  <a:srgbClr val="5C6B62"/>
+                </a:solidFill>
+                <a:latin typeface="Arial" pitchFamily="34" charset="0"/>
+                <a:ea typeface="Arial" pitchFamily="34" charset="-122"/>
+                <a:cs typeface="Arial" pitchFamily="34" charset="-120"/>
+              </a:rPr>
+              <a:t>what you adopt</a:t>
+            </a:r>
+            <a:endParaRPr lang="en-US" sz="750" dirty="0"/>
+          </a:p>
+        </p:txBody>
+      </p:sp>
+      <p:sp>
+        <p:nvSpPr>
+          <p:cNvPr id="45" name="Shape 43"/>
+          <p:cNvSpPr/>
+          <p:nvPr/>
+        </p:nvSpPr>
+        <p:spPr>
+          <a:xfrm>
+            <a:off x="274320" y="3675888"/>
+            <a:ext cx="8595360" cy="548640"/>
+          </a:xfrm>
+          <a:prstGeom prst="roundRect">
+            <a:avLst>
+              <a:gd name="adj" fmla="val 10000"/>
+            </a:avLst>
+          </a:prstGeom>
+          <a:solidFill>
+            <a:srgbClr val="14110F"/>
+          </a:solidFill>
+          <a:ln/>
+          <a:effectLst>
+            <a:outerShdw sx="100000" sy="100000" kx="0" ky="0" algn="bl" rotWithShape="0" blurRad="88900" dist="25400" dir="5400000">
+              <a:srgbClr val="6B6B6B">
+                <a:alpha val="22000"/>
+              </a:srgbClr>
+            </a:outerShdw>
+          </a:effectLst>
+        </p:spPr>
+      </p:sp>
+      <p:sp>
+        <p:nvSpPr>
+          <p:cNvPr id="46" name="Text 44"/>
+          <p:cNvSpPr/>
+          <p:nvPr/>
+        </p:nvSpPr>
+        <p:spPr>
+          <a:xfrm>
+            <a:off x="457200" y="3730752"/>
+            <a:ext cx="8229600" cy="438912"/>
+          </a:xfrm>
+          <a:prstGeom prst="rect">
+            <a:avLst/>
+          </a:prstGeom>
+          <a:noFill/>
+          <a:ln/>
+        </p:spPr>
+        <p:txBody>
+          <a:bodyPr wrap="square" lIns="0" tIns="0" rIns="0" bIns="0" rtlCol="0" anchor="ctr"/>
+          <a:lstStyle/>
+          <a:p>
+            <a:pPr algn="ctr" indent="0" marL="0">
+              <a:lnSpc>
+                <a:spcPct val="102000"/>
+              </a:lnSpc>
+              <a:buNone/>
+            </a:pPr>
+            <a:r>
+              <a:rPr lang="en-US" sz="900" b="1" dirty="0">
+                <a:solidFill>
+                  <a:srgbClr val="7DE0A0"/>
+                </a:solidFill>
+                <a:latin typeface="Arial" pitchFamily="34" charset="0"/>
+                <a:ea typeface="Arial" pitchFamily="34" charset="-122"/>
+                <a:cs typeface="Arial" pitchFamily="34" charset="-120"/>
+              </a:rPr>
+              <a:t>Shared backbone   </a:t>
+            </a:r>
+            <a:pPr algn="ctr" indent="0" marL="0">
+              <a:lnSpc>
+                <a:spcPct val="102000"/>
+              </a:lnSpc>
+              <a:buNone/>
+            </a:pPr>
+            <a:r>
+              <a:rPr lang="en-US" sz="900" dirty="0">
+                <a:solidFill>
+                  <a:srgbClr val="ECECEC"/>
+                </a:solidFill>
+                <a:latin typeface="Arial" pitchFamily="34" charset="0"/>
+                <a:ea typeface="Arial" pitchFamily="34" charset="-122"/>
+                <a:cs typeface="Arial" pitchFamily="34" charset="-120"/>
+              </a:rPr>
+              <a:t>grounded generative AI · no-fabrication guardrail (RAG over real facts) · Groq LLM + sentence-transformer embeddings — the rigor that made the research trustworthy makes the feature trustworthy.</a:t>
+            </a:r>
+            <a:endParaRPr lang="en-US" sz="900" dirty="0"/>
+          </a:p>
+        </p:txBody>
+      </p:sp>
+      <p:sp>
+        <p:nvSpPr>
+          <p:cNvPr id="47" name="Text 45"/>
+          <p:cNvSpPr/>
+          <p:nvPr/>
+        </p:nvSpPr>
+        <p:spPr>
+          <a:xfrm>
+            <a:off x="274320" y="4315968"/>
+            <a:ext cx="8595360" cy="256032"/>
+          </a:xfrm>
+          <a:prstGeom prst="rect">
+            <a:avLst/>
+          </a:prstGeom>
+          <a:noFill/>
+          <a:ln/>
+        </p:spPr>
+        <p:txBody>
+          <a:bodyPr wrap="square" lIns="0" tIns="0" rIns="0" bIns="0" rtlCol="0" anchor="ctr"/>
+          <a:lstStyle/>
+          <a:p>
+            <a:pPr algn="ctr" indent="0" marL="0">
+              <a:buNone/>
+            </a:pPr>
+            <a:r>
+              <a:rPr lang="en-US" sz="800" i="1" dirty="0">
+                <a:solidFill>
+                  <a:srgbClr val="5C6B62"/>
+                </a:solidFill>
+                <a:latin typeface="Arial" pitchFamily="34" charset="0"/>
+                <a:ea typeface="Arial" pitchFamily="34" charset="-122"/>
+                <a:cs typeface="Arial" pitchFamily="34" charset="-120"/>
+              </a:rPr>
+              <a:t>Edge cases handled — hallucination → RAG grounding · cold-start → AI story works alone · story fatigue → one glanceable line, full story on tap.</a:t>
+            </a:r>
+            <a:endParaRPr lang="en-US" sz="800" dirty="0"/>
+          </a:p>
+        </p:txBody>
+      </p:sp>
+      <p:sp>
+        <p:nvSpPr>
+          <p:cNvPr id="48" name="Shape 46"/>
           <p:cNvSpPr/>
           <p:nvPr/>
         </p:nvSpPr>
@@ -3239,7 +4170,7 @@
       </p:sp>
       <p:sp>
         <p:nvSpPr>
-          <p:cNvPr id="32" name="Text 30"/>
+          <p:cNvPr id="49" name="Text 47"/>
           <p:cNvSpPr/>
           <p:nvPr/>
         </p:nvSpPr>
@@ -3526,7 +4457,7 @@
                 <a:ea typeface="Arial" pitchFamily="34" charset="-122"/>
                 <a:cs typeface="Arial" pitchFamily="34" charset="-120"/>
               </a:rPr>
-              <a:t>Flow &amp; Edge</a:t>
+              <a:t>Architecture</a:t>
             </a:r>
             <a:pPr algn="ctr" indent="0" marL="0">
               <a:buNone/>
@@ -5327,7 +6258,7 @@
                 <a:ea typeface="Arial" pitchFamily="34" charset="-122"/>
                 <a:cs typeface="Arial" pitchFamily="34" charset="-120"/>
               </a:rPr>
-              <a:t>Flow &amp; Edge</a:t>
+              <a:t>Architecture</a:t>
             </a:r>
             <a:pPr algn="ctr" indent="0" marL="0">
               <a:buNone/>
@@ -6735,7 +7666,7 @@
                 <a:ea typeface="Arial" pitchFamily="34" charset="-122"/>
                 <a:cs typeface="Arial" pitchFamily="34" charset="-120"/>
               </a:rPr>
-              <a:t>Flow &amp; Edge</a:t>
+              <a:t>Architecture</a:t>
             </a:r>
             <a:pPr algn="ctr" indent="0" marL="0">
               <a:buNone/>
@@ -8379,7 +9310,7 @@
                 <a:ea typeface="Arial" pitchFamily="34" charset="-122"/>
                 <a:cs typeface="Arial" pitchFamily="34" charset="-120"/>
               </a:rPr>
-              <a:t>Flow &amp; Edge</a:t>
+              <a:t>Architecture</a:t>
             </a:r>
             <a:pPr algn="ctr" indent="0" marL="0">
               <a:buNone/>
@@ -9976,7 +10907,7 @@
                 <a:ea typeface="Arial" pitchFamily="34" charset="-122"/>
                 <a:cs typeface="Arial" pitchFamily="34" charset="-120"/>
               </a:rPr>
-              <a:t>Flow &amp; Edge</a:t>
+              <a:t>Architecture</a:t>
             </a:r>
             <a:pPr algn="ctr" indent="0" marL="0">
               <a:buNone/>
@@ -11647,7 +12578,7 @@
                 <a:ea typeface="Arial" pitchFamily="34" charset="-122"/>
                 <a:cs typeface="Arial" pitchFamily="34" charset="-120"/>
               </a:rPr>
-              <a:t>Flow &amp; Edge</a:t>
+              <a:t>Architecture</a:t>
             </a:r>
             <a:pPr algn="ctr" indent="0" marL="0">
               <a:buNone/>
@@ -13406,7 +14337,7 @@
                 <a:ea typeface="Arial" pitchFamily="34" charset="-122"/>
                 <a:cs typeface="Arial" pitchFamily="34" charset="-120"/>
               </a:rPr>
-              <a:t>Flow &amp; Edge</a:t>
+              <a:t>Architecture</a:t>
             </a:r>
             <a:pPr algn="ctr" indent="0" marL="0">
               <a:buNone/>
@@ -14852,7 +15783,7 @@
                 <a:ea typeface="Arial" pitchFamily="34" charset="-122"/>
                 <a:cs typeface="Arial" pitchFamily="34" charset="-120"/>
               </a:rPr>
-              <a:t>Flow &amp; Edge</a:t>
+              <a:t>Architecture</a:t>
             </a:r>
             <a:pPr algn="ctr" indent="0" marL="0">
               <a:buNone/>
@@ -17606,7 +18537,7 @@
                 <a:ea typeface="Arial" pitchFamily="34" charset="-122"/>
                 <a:cs typeface="Arial" pitchFamily="34" charset="-120"/>
               </a:rPr>
-              <a:t>Flow &amp; Edge</a:t>
+              <a:t>Architecture</a:t>
             </a:r>
             <a:pPr algn="ctr" indent="0" marL="0">
               <a:buNone/>
@@ -19281,7 +20212,7 @@
                 <a:ea typeface="Arial" pitchFamily="34" charset="-122"/>
                 <a:cs typeface="Arial" pitchFamily="34" charset="-120"/>
               </a:rPr>
-              <a:t>Flow &amp; Edge</a:t>
+              <a:t>Architecture</a:t>
             </a:r>
             <a:pPr algn="ctr" indent="0" marL="0">
               <a:buNone/>

</xml_diff>

<commit_message>
Deck: 10 slides with cover restored; fold Context into Market
Re-add title cover; drop standalone Context slide (its accuracy->acceptance
reframe + competitor-fix point folded into the Market slide). Stays at 10.

Co-Authored-By: Claude Opus 4.8 <noreply@anthropic.com>
</commit_message>
<xml_diff>
--- a/Off_Repeat_Deck_TopFellow.pptx
+++ b/Off_Repeat_Deck_TopFellow.pptx
@@ -1658,7 +1658,7 @@
     <p:bg>
       <p:bgPr>
         <a:solidFill>
-          <a:srgbClr val="FAF6EF"/>
+          <a:srgbClr val="0E6B37"/>
         </a:solidFill>
       </p:bgPr>
     </p:bg>
@@ -1684,14 +1684,14 @@
         </p:nvSpPr>
         <p:spPr>
           <a:xfrm>
-            <a:off x="0" y="0"/>
-            <a:ext cx="9144000" cy="841248"/>
-          </a:xfrm>
-          <a:prstGeom prst="rect">
+            <a:off x="548640" y="566928"/>
+            <a:ext cx="457200" cy="457200"/>
+          </a:xfrm>
+          <a:prstGeom prst="ellipse">
             <a:avLst/>
           </a:prstGeom>
           <a:solidFill>
-            <a:srgbClr val="0E6B37"/>
+            <a:srgbClr val="1DB954"/>
           </a:solidFill>
           <a:ln/>
         </p:spPr>
@@ -1704,27 +1704,242 @@
         </p:nvSpPr>
         <p:spPr>
           <a:xfrm>
-            <a:off x="274320" y="36576"/>
-            <a:ext cx="8595360" cy="768096"/>
-          </a:xfrm>
-          <a:prstGeom prst="rect">
-            <a:avLst/>
-          </a:prstGeom>
-          <a:noFill/>
-          <a:ln/>
-        </p:spPr>
-        <p:txBody>
-          <a:bodyPr wrap="square" lIns="0" tIns="0" rIns="0" bIns="0" rtlCol="0" anchor="ctr"/>
-          <a:lstStyle/>
-          <a:p>
-            <a:pPr algn="ctr" indent="0" marL="0">
+            <a:off x="548640" y="548640"/>
+            <a:ext cx="457200" cy="457200"/>
+          </a:xfrm>
+          <a:prstGeom prst="rect">
+            <a:avLst/>
+          </a:prstGeom>
+          <a:noFill/>
+          <a:ln/>
+        </p:spPr>
+        <p:txBody>
+          <a:bodyPr wrap="square" lIns="0" tIns="0" rIns="0" bIns="0" rtlCol="0" anchor="ctr"/>
+          <a:lstStyle/>
+          <a:p>
+            <a:pPr algn="ctr" indent="0" marL="0">
+              <a:buNone/>
+            </a:pPr>
+            <a:r>
+              <a:rPr lang="en-US" sz="2200" b="1" dirty="0">
+                <a:solidFill>
+                  <a:srgbClr val="03240F"/>
+                </a:solidFill>
+                <a:latin typeface="Arial" pitchFamily="34" charset="0"/>
+                <a:ea typeface="Arial" pitchFamily="34" charset="-122"/>
+                <a:cs typeface="Arial" pitchFamily="34" charset="-120"/>
+              </a:rPr>
+              <a:t>✦</a:t>
+            </a:r>
+            <a:endParaRPr lang="en-US" sz="2200" dirty="0"/>
+          </a:p>
+        </p:txBody>
+      </p:sp>
+      <p:sp>
+        <p:nvSpPr>
+          <p:cNvPr id="4" name="Text 2"/>
+          <p:cNvSpPr/>
+          <p:nvPr/>
+        </p:nvSpPr>
+        <p:spPr>
+          <a:xfrm>
+            <a:off x="1143000" y="640080"/>
+            <a:ext cx="7498080" cy="320040"/>
+          </a:xfrm>
+          <a:prstGeom prst="rect">
+            <a:avLst/>
+          </a:prstGeom>
+          <a:noFill/>
+          <a:ln/>
+        </p:spPr>
+        <p:txBody>
+          <a:bodyPr wrap="square" lIns="0" tIns="0" rIns="0" bIns="0" rtlCol="0" anchor="ctr"/>
+          <a:lstStyle/>
+          <a:p>
+            <a:pPr indent="0" marL="0">
+              <a:buNone/>
+            </a:pPr>
+            <a:r>
+              <a:rPr lang="en-US" sz="1100" b="1" spc="200" kern="0" dirty="0">
+                <a:solidFill>
+                  <a:srgbClr val="BFE9CD"/>
+                </a:solidFill>
+                <a:latin typeface="Arial" pitchFamily="34" charset="0"/>
+                <a:ea typeface="Arial" pitchFamily="34" charset="-122"/>
+                <a:cs typeface="Arial" pitchFamily="34" charset="-120"/>
+              </a:rPr>
+              <a:t>NEXTLEAP PM FELLOWSHIP   ·   SPOTIFY · GROWTH TEAM</a:t>
+            </a:r>
+            <a:endParaRPr lang="en-US" sz="1100" dirty="0"/>
+          </a:p>
+        </p:txBody>
+      </p:sp>
+      <p:sp>
+        <p:nvSpPr>
+          <p:cNvPr id="5" name="Text 3"/>
+          <p:cNvSpPr/>
+          <p:nvPr/>
+        </p:nvSpPr>
+        <p:spPr>
+          <a:xfrm>
+            <a:off x="530352" y="1417320"/>
+            <a:ext cx="8229600" cy="1005840"/>
+          </a:xfrm>
+          <a:prstGeom prst="rect">
+            <a:avLst/>
+          </a:prstGeom>
+          <a:noFill/>
+          <a:ln/>
+        </p:spPr>
+        <p:txBody>
+          <a:bodyPr wrap="square" lIns="0" tIns="0" rIns="0" bIns="0" rtlCol="0" anchor="ctr"/>
+          <a:lstStyle/>
+          <a:p>
+            <a:pPr indent="0" marL="0">
+              <a:buNone/>
+            </a:pPr>
+            <a:r>
+              <a:rPr lang="en-US" sz="5400" b="1" dirty="0">
+                <a:solidFill>
+                  <a:srgbClr val="FFFFFF"/>
+                </a:solidFill>
+                <a:latin typeface="Arial" pitchFamily="34" charset="0"/>
+                <a:ea typeface="Arial" pitchFamily="34" charset="-122"/>
+                <a:cs typeface="Arial" pitchFamily="34" charset="-120"/>
+              </a:rPr>
+              <a:t>Off Repeat</a:t>
+            </a:r>
+            <a:endParaRPr lang="en-US" sz="5400" dirty="0"/>
+          </a:p>
+        </p:txBody>
+      </p:sp>
+      <p:sp>
+        <p:nvSpPr>
+          <p:cNvPr id="6" name="Shape 4"/>
+          <p:cNvSpPr/>
+          <p:nvPr/>
+        </p:nvSpPr>
+        <p:spPr>
+          <a:xfrm>
+            <a:off x="585216" y="2487168"/>
+            <a:ext cx="2377440" cy="64008"/>
+          </a:xfrm>
+          <a:prstGeom prst="rect">
+            <a:avLst/>
+          </a:prstGeom>
+          <a:solidFill>
+            <a:srgbClr val="1DB954"/>
+          </a:solidFill>
+          <a:ln/>
+        </p:spPr>
+      </p:sp>
+      <p:sp>
+        <p:nvSpPr>
+          <p:cNvPr id="7" name="Text 5"/>
+          <p:cNvSpPr/>
+          <p:nvPr/>
+        </p:nvSpPr>
+        <p:spPr>
+          <a:xfrm>
+            <a:off x="566928" y="2743200"/>
+            <a:ext cx="7955280" cy="914400"/>
+          </a:xfrm>
+          <a:prstGeom prst="rect">
+            <a:avLst/>
+          </a:prstGeom>
+          <a:noFill/>
+          <a:ln/>
+        </p:spPr>
+        <p:txBody>
+          <a:bodyPr wrap="square" lIns="0" tIns="0" rIns="0" bIns="0" rtlCol="0" anchor="ctr"/>
+          <a:lstStyle/>
+          <a:p>
+            <a:pPr indent="0" marL="0">
               <a:lnSpc>
-                <a:spcPct val="95000"/>
+                <a:spcPct val="120000"/>
               </a:lnSpc>
               <a:buNone/>
             </a:pPr>
             <a:r>
-              <a:rPr lang="en-US" sz="2100" b="1" dirty="0">
+              <a:rPr lang="en-US" sz="1600" dirty="0">
+                <a:solidFill>
+                  <a:srgbClr val="F2FBF5"/>
+                </a:solidFill>
+                <a:latin typeface="Arial" pitchFamily="34" charset="0"/>
+                <a:ea typeface="Arial" pitchFamily="34" charset="-122"/>
+                <a:cs typeface="Arial" pitchFamily="34" charset="-120"/>
+              </a:rPr>
+              <a:t>Spotify perfected recommendation. Discovery still stalls — because the gap was never accuracy. It's acceptance: a reason to press play on the unfamiliar.</a:t>
+            </a:r>
+            <a:endParaRPr lang="en-US" sz="1600" dirty="0"/>
+          </a:p>
+        </p:txBody>
+      </p:sp>
+      <p:sp>
+        <p:nvSpPr>
+          <p:cNvPr id="8" name="Text 6"/>
+          <p:cNvSpPr/>
+          <p:nvPr/>
+        </p:nvSpPr>
+        <p:spPr>
+          <a:xfrm>
+            <a:off x="566928" y="3703320"/>
+            <a:ext cx="7955280" cy="365760"/>
+          </a:xfrm>
+          <a:prstGeom prst="rect">
+            <a:avLst/>
+          </a:prstGeom>
+          <a:noFill/>
+          <a:ln/>
+        </p:spPr>
+        <p:txBody>
+          <a:bodyPr wrap="square" lIns="0" tIns="0" rIns="0" bIns="0" rtlCol="0" anchor="ctr"/>
+          <a:lstStyle/>
+          <a:p>
+            <a:pPr indent="0" marL="0">
+              <a:buNone/>
+            </a:pPr>
+            <a:r>
+              <a:rPr lang="en-US" sz="1400" b="1" i="1" dirty="0">
+                <a:solidFill>
+                  <a:srgbClr val="7DE0A0"/>
+                </a:solidFill>
+                <a:latin typeface="Arial" pitchFamily="34" charset="0"/>
+                <a:ea typeface="Arial" pitchFamily="34" charset="-122"/>
+                <a:cs typeface="Arial" pitchFamily="34" charset="-120"/>
+              </a:rPr>
+              <a:t>You have On Repeat. Meet Off Repeat.</a:t>
+            </a:r>
+            <a:endParaRPr lang="en-US" sz="1400" dirty="0"/>
+          </a:p>
+        </p:txBody>
+      </p:sp>
+      <p:sp>
+        <p:nvSpPr>
+          <p:cNvPr id="9" name="Text 7"/>
+          <p:cNvSpPr/>
+          <p:nvPr/>
+        </p:nvSpPr>
+        <p:spPr>
+          <a:xfrm>
+            <a:off x="566928" y="4315968"/>
+            <a:ext cx="8046720" cy="274320"/>
+          </a:xfrm>
+          <a:prstGeom prst="rect">
+            <a:avLst/>
+          </a:prstGeom>
+          <a:noFill/>
+          <a:ln/>
+        </p:spPr>
+        <p:txBody>
+          <a:bodyPr wrap="square" lIns="0" tIns="0" rIns="0" bIns="0" rtlCol="0" anchor="ctr"/>
+          <a:lstStyle/>
+          <a:p>
+            <a:pPr indent="0" marL="0">
+              <a:buNone/>
+            </a:pPr>
+            <a:r>
+              <a:rPr lang="en-US" sz="1050" b="1" dirty="0">
                 <a:solidFill>
                   <a:srgbClr val="FFFFFF"/>
                 </a:solidFill>
@@ -1732,1325 +1947,65 @@
                 <a:ea typeface="Arial" pitchFamily="34" charset="-122"/>
                 <a:cs typeface="Arial" pitchFamily="34" charset="-120"/>
               </a:rPr>
-              <a:t>Spotify perfected recommendation. Discovery still stalls.</a:t>
-            </a:r>
-            <a:endParaRPr lang="en-US" sz="2100" dirty="0"/>
-          </a:p>
-        </p:txBody>
-      </p:sp>
-      <p:sp>
-        <p:nvSpPr>
-          <p:cNvPr id="4" name="Shape 2"/>
-          <p:cNvSpPr/>
-          <p:nvPr/>
-        </p:nvSpPr>
-        <p:spPr>
-          <a:xfrm>
-            <a:off x="274320" y="960120"/>
-            <a:ext cx="2057400" cy="1234440"/>
-          </a:xfrm>
-          <a:prstGeom prst="roundRect">
-            <a:avLst>
-              <a:gd name="adj" fmla="val 5185"/>
-            </a:avLst>
-          </a:prstGeom>
-          <a:solidFill>
-            <a:srgbClr val="E7F6EC"/>
-          </a:solidFill>
-          <a:ln w="12700">
-            <a:solidFill>
-              <a:srgbClr val="D8E5DC"/>
-            </a:solidFill>
-            <a:prstDash val="solid"/>
-          </a:ln>
-          <a:effectLst>
-            <a:outerShdw sx="100000" sy="100000" kx="0" ky="0" algn="bl" rotWithShape="0" blurRad="88900" dist="25400" dir="5400000">
-              <a:srgbClr val="6B6B6B">
-                <a:alpha val="22000"/>
-              </a:srgbClr>
-            </a:outerShdw>
-          </a:effectLst>
-        </p:spPr>
-      </p:sp>
-      <p:sp>
-        <p:nvSpPr>
-          <p:cNvPr id="5" name="Text 3"/>
-          <p:cNvSpPr/>
-          <p:nvPr/>
-        </p:nvSpPr>
-        <p:spPr>
-          <a:xfrm>
-            <a:off x="365760" y="1060704"/>
-            <a:ext cx="1874520" cy="502920"/>
-          </a:xfrm>
-          <a:prstGeom prst="rect">
-            <a:avLst/>
-          </a:prstGeom>
-          <a:noFill/>
-          <a:ln/>
-        </p:spPr>
-        <p:txBody>
-          <a:bodyPr wrap="square" lIns="0" tIns="0" rIns="0" bIns="0" rtlCol="0" anchor="ctr"/>
-          <a:lstStyle/>
-          <a:p>
-            <a:pPr algn="ctr" indent="0" marL="0">
-              <a:buNone/>
-            </a:pPr>
-            <a:r>
-              <a:rPr lang="en-US" sz="3000" b="1" dirty="0">
-                <a:solidFill>
-                  <a:srgbClr val="17241D"/>
-                </a:solidFill>
-                <a:latin typeface="Arial" pitchFamily="34" charset="0"/>
-                <a:ea typeface="Arial" pitchFamily="34" charset="-122"/>
-                <a:cs typeface="Arial" pitchFamily="34" charset="-120"/>
-              </a:rPr>
-              <a:t>~675M</a:t>
-            </a:r>
-            <a:endParaRPr lang="en-US" sz="3000" dirty="0"/>
-          </a:p>
-        </p:txBody>
-      </p:sp>
-      <p:sp>
-        <p:nvSpPr>
-          <p:cNvPr id="6" name="Text 4"/>
-          <p:cNvSpPr/>
-          <p:nvPr/>
-        </p:nvSpPr>
-        <p:spPr>
-          <a:xfrm>
-            <a:off x="384048" y="1591056"/>
-            <a:ext cx="1828800" cy="548640"/>
-          </a:xfrm>
-          <a:prstGeom prst="rect">
-            <a:avLst/>
-          </a:prstGeom>
-          <a:noFill/>
-          <a:ln/>
-        </p:spPr>
-        <p:txBody>
-          <a:bodyPr wrap="square" lIns="0" tIns="0" rIns="0" bIns="0" rtlCol="0" anchor="ctr"/>
-          <a:lstStyle/>
-          <a:p>
-            <a:pPr algn="ctr" indent="0" marL="0">
+              <a:t>▶ Live prototype + AI workflow   ·   </a:t>
+            </a:r>
+            <a:pPr indent="0" marL="0">
+              <a:buNone/>
+            </a:pPr>
+            <a:r>
+              <a:rPr lang="en-US" sz="1050" dirty="0">
+                <a:solidFill>
+                  <a:srgbClr val="FFFFFF"/>
+                </a:solidFill>
+                <a:latin typeface="Arial" pitchFamily="34" charset="0"/>
+                <a:ea typeface="Arial" pitchFamily="34" charset="-122"/>
+                <a:cs typeface="Arial" pitchFamily="34" charset="-120"/>
+              </a:rPr>
+              <a:t>github.com/arjuncooliitr/spotify-discovery-engine</a:t>
+            </a:r>
+            <a:endParaRPr lang="en-US" sz="1050" dirty="0"/>
+          </a:p>
+        </p:txBody>
+      </p:sp>
+      <p:sp>
+        <p:nvSpPr>
+          <p:cNvPr id="10" name="Text 8"/>
+          <p:cNvSpPr/>
+          <p:nvPr/>
+        </p:nvSpPr>
+        <p:spPr>
+          <a:xfrm>
+            <a:off x="566928" y="4645152"/>
+            <a:ext cx="8046720" cy="320040"/>
+          </a:xfrm>
+          <a:prstGeom prst="rect">
+            <a:avLst/>
+          </a:prstGeom>
+          <a:noFill/>
+          <a:ln/>
+        </p:spPr>
+        <p:txBody>
+          <a:bodyPr wrap="square" lIns="0" tIns="0" rIns="0" bIns="0" rtlCol="0" anchor="ctr"/>
+          <a:lstStyle/>
+          <a:p>
+            <a:pPr indent="0" marL="0">
               <a:lnSpc>
                 <a:spcPct val="100000"/>
               </a:lnSpc>
               <a:buNone/>
             </a:pPr>
             <a:r>
-              <a:rPr lang="en-US" sz="950" dirty="0">
-                <a:solidFill>
-                  <a:srgbClr val="5C6B62"/>
-                </a:solidFill>
-                <a:latin typeface="Arial" pitchFamily="34" charset="0"/>
-                <a:ea typeface="Arial" pitchFamily="34" charset="-122"/>
-                <a:cs typeface="Arial" pitchFamily="34" charset="-120"/>
-              </a:rPr>
-              <a:t>monthly active users (reported)</a:t>
-            </a:r>
-            <a:endParaRPr lang="en-US" sz="950" dirty="0"/>
-          </a:p>
-        </p:txBody>
-      </p:sp>
-      <p:sp>
-        <p:nvSpPr>
-          <p:cNvPr id="7" name="Shape 5"/>
-          <p:cNvSpPr/>
-          <p:nvPr/>
-        </p:nvSpPr>
-        <p:spPr>
-          <a:xfrm>
-            <a:off x="2468880" y="960120"/>
-            <a:ext cx="2057400" cy="1234440"/>
-          </a:xfrm>
-          <a:prstGeom prst="roundRect">
-            <a:avLst>
-              <a:gd name="adj" fmla="val 5185"/>
-            </a:avLst>
-          </a:prstGeom>
-          <a:solidFill>
-            <a:srgbClr val="E7F6EC"/>
-          </a:solidFill>
-          <a:ln w="12700">
-            <a:solidFill>
-              <a:srgbClr val="D8E5DC"/>
-            </a:solidFill>
-            <a:prstDash val="solid"/>
-          </a:ln>
-          <a:effectLst>
-            <a:outerShdw sx="100000" sy="100000" kx="0" ky="0" algn="bl" rotWithShape="0" blurRad="88900" dist="25400" dir="5400000">
-              <a:srgbClr val="6B6B6B">
-                <a:alpha val="22000"/>
-              </a:srgbClr>
-            </a:outerShdw>
-          </a:effectLst>
-        </p:spPr>
-      </p:sp>
-      <p:sp>
-        <p:nvSpPr>
-          <p:cNvPr id="8" name="Text 6"/>
-          <p:cNvSpPr/>
-          <p:nvPr/>
-        </p:nvSpPr>
-        <p:spPr>
-          <a:xfrm>
-            <a:off x="2560320" y="1060704"/>
-            <a:ext cx="1874520" cy="502920"/>
-          </a:xfrm>
-          <a:prstGeom prst="rect">
-            <a:avLst/>
-          </a:prstGeom>
-          <a:noFill/>
-          <a:ln/>
-        </p:spPr>
-        <p:txBody>
-          <a:bodyPr wrap="square" lIns="0" tIns="0" rIns="0" bIns="0" rtlCol="0" anchor="ctr"/>
-          <a:lstStyle/>
-          <a:p>
-            <a:pPr algn="ctr" indent="0" marL="0">
-              <a:buNone/>
-            </a:pPr>
-            <a:r>
-              <a:rPr lang="en-US" sz="3000" b="1" dirty="0">
-                <a:solidFill>
-                  <a:srgbClr val="17241D"/>
-                </a:solidFill>
-                <a:latin typeface="Arial" pitchFamily="34" charset="0"/>
-                <a:ea typeface="Arial" pitchFamily="34" charset="-122"/>
-                <a:cs typeface="Arial" pitchFamily="34" charset="-120"/>
-              </a:rPr>
-              <a:t>263M</a:t>
-            </a:r>
-            <a:endParaRPr lang="en-US" sz="3000" dirty="0"/>
-          </a:p>
-        </p:txBody>
-      </p:sp>
-      <p:sp>
-        <p:nvSpPr>
-          <p:cNvPr id="9" name="Text 7"/>
-          <p:cNvSpPr/>
-          <p:nvPr/>
-        </p:nvSpPr>
-        <p:spPr>
-          <a:xfrm>
-            <a:off x="2578608" y="1591056"/>
-            <a:ext cx="1828800" cy="548640"/>
-          </a:xfrm>
-          <a:prstGeom prst="rect">
-            <a:avLst/>
-          </a:prstGeom>
-          <a:noFill/>
-          <a:ln/>
-        </p:spPr>
-        <p:txBody>
-          <a:bodyPr wrap="square" lIns="0" tIns="0" rIns="0" bIns="0" rtlCol="0" anchor="ctr"/>
-          <a:lstStyle/>
-          <a:p>
-            <a:pPr algn="ctr" indent="0" marL="0">
-              <a:lnSpc>
-                <a:spcPct val="100000"/>
-              </a:lnSpc>
-              <a:buNone/>
-            </a:pPr>
-            <a:r>
-              <a:rPr lang="en-US" sz="950" dirty="0">
-                <a:solidFill>
-                  <a:srgbClr val="5C6B62"/>
-                </a:solidFill>
-                <a:latin typeface="Arial" pitchFamily="34" charset="0"/>
-                <a:ea typeface="Arial" pitchFamily="34" charset="-122"/>
-                <a:cs typeface="Arial" pitchFamily="34" charset="-120"/>
-              </a:rPr>
-              <a:t>Premium subscribers</a:t>
-            </a:r>
-            <a:endParaRPr lang="en-US" sz="950" dirty="0"/>
-          </a:p>
-        </p:txBody>
-      </p:sp>
-      <p:sp>
-        <p:nvSpPr>
-          <p:cNvPr id="10" name="Shape 8"/>
-          <p:cNvSpPr/>
-          <p:nvPr/>
-        </p:nvSpPr>
-        <p:spPr>
-          <a:xfrm>
-            <a:off x="4663440" y="960120"/>
-            <a:ext cx="2057400" cy="1234440"/>
-          </a:xfrm>
-          <a:prstGeom prst="roundRect">
-            <a:avLst>
-              <a:gd name="adj" fmla="val 5185"/>
-            </a:avLst>
-          </a:prstGeom>
-          <a:solidFill>
-            <a:srgbClr val="FBE3DD"/>
-          </a:solidFill>
-          <a:ln w="12700">
-            <a:solidFill>
-              <a:srgbClr val="D8E5DC"/>
-            </a:solidFill>
-            <a:prstDash val="solid"/>
-          </a:ln>
-          <a:effectLst>
-            <a:outerShdw sx="100000" sy="100000" kx="0" ky="0" algn="bl" rotWithShape="0" blurRad="88900" dist="25400" dir="5400000">
-              <a:srgbClr val="6B6B6B">
-                <a:alpha val="22000"/>
-              </a:srgbClr>
-            </a:outerShdw>
-          </a:effectLst>
-        </p:spPr>
-      </p:sp>
-      <p:sp>
-        <p:nvSpPr>
-          <p:cNvPr id="11" name="Text 9"/>
-          <p:cNvSpPr/>
-          <p:nvPr/>
-        </p:nvSpPr>
-        <p:spPr>
-          <a:xfrm>
-            <a:off x="4754880" y="1060704"/>
-            <a:ext cx="1874520" cy="502920"/>
-          </a:xfrm>
-          <a:prstGeom prst="rect">
-            <a:avLst/>
-          </a:prstGeom>
-          <a:noFill/>
-          <a:ln/>
-        </p:spPr>
-        <p:txBody>
-          <a:bodyPr wrap="square" lIns="0" tIns="0" rIns="0" bIns="0" rtlCol="0" anchor="ctr"/>
-          <a:lstStyle/>
-          <a:p>
-            <a:pPr algn="ctr" indent="0" marL="0">
-              <a:buNone/>
-            </a:pPr>
-            <a:r>
-              <a:rPr lang="en-US" sz="3000" b="1" dirty="0">
-                <a:solidFill>
-                  <a:srgbClr val="17241D"/>
-                </a:solidFill>
-                <a:latin typeface="Arial" pitchFamily="34" charset="0"/>
-                <a:ea typeface="Arial" pitchFamily="34" charset="-122"/>
-                <a:cs typeface="Arial" pitchFamily="34" charset="-120"/>
-              </a:rPr>
-              <a:t>~30%</a:t>
-            </a:r>
-            <a:endParaRPr lang="en-US" sz="3000" dirty="0"/>
-          </a:p>
-        </p:txBody>
-      </p:sp>
-      <p:sp>
-        <p:nvSpPr>
-          <p:cNvPr id="12" name="Text 10"/>
-          <p:cNvSpPr/>
-          <p:nvPr/>
-        </p:nvSpPr>
-        <p:spPr>
-          <a:xfrm>
-            <a:off x="4773168" y="1591056"/>
-            <a:ext cx="1828800" cy="548640"/>
-          </a:xfrm>
-          <a:prstGeom prst="rect">
-            <a:avLst/>
-          </a:prstGeom>
-          <a:noFill/>
-          <a:ln/>
-        </p:spPr>
-        <p:txBody>
-          <a:bodyPr wrap="square" lIns="0" tIns="0" rIns="0" bIns="0" rtlCol="0" anchor="ctr"/>
-          <a:lstStyle/>
-          <a:p>
-            <a:pPr algn="ctr" indent="0" marL="0">
-              <a:lnSpc>
-                <a:spcPct val="100000"/>
-              </a:lnSpc>
-              <a:buNone/>
-            </a:pPr>
-            <a:r>
-              <a:rPr lang="en-US" sz="950" dirty="0">
-                <a:solidFill>
-                  <a:srgbClr val="5C6B62"/>
-                </a:solidFill>
-                <a:latin typeface="Arial" pitchFamily="34" charset="0"/>
-                <a:ea typeface="Arial" pitchFamily="34" charset="-122"/>
-                <a:cs typeface="Arial" pitchFamily="34" charset="-120"/>
-              </a:rPr>
-              <a:t>of listening is repeat / familiar</a:t>
-            </a:r>
-            <a:endParaRPr lang="en-US" sz="950" dirty="0"/>
-          </a:p>
-        </p:txBody>
-      </p:sp>
-      <p:sp>
-        <p:nvSpPr>
-          <p:cNvPr id="13" name="Shape 11"/>
-          <p:cNvSpPr/>
-          <p:nvPr/>
-        </p:nvSpPr>
-        <p:spPr>
-          <a:xfrm>
-            <a:off x="6858000" y="960120"/>
-            <a:ext cx="2057400" cy="1234440"/>
-          </a:xfrm>
-          <a:prstGeom prst="roundRect">
-            <a:avLst>
-              <a:gd name="adj" fmla="val 5185"/>
-            </a:avLst>
-          </a:prstGeom>
-          <a:solidFill>
-            <a:srgbClr val="FBE3DD"/>
-          </a:solidFill>
-          <a:ln w="12700">
-            <a:solidFill>
-              <a:srgbClr val="D8E5DC"/>
-            </a:solidFill>
-            <a:prstDash val="solid"/>
-          </a:ln>
-          <a:effectLst>
-            <a:outerShdw sx="100000" sy="100000" kx="0" ky="0" algn="bl" rotWithShape="0" blurRad="88900" dist="25400" dir="5400000">
-              <a:srgbClr val="6B6B6B">
-                <a:alpha val="22000"/>
-              </a:srgbClr>
-            </a:outerShdw>
-          </a:effectLst>
-        </p:spPr>
-      </p:sp>
-      <p:sp>
-        <p:nvSpPr>
-          <p:cNvPr id="14" name="Text 12"/>
-          <p:cNvSpPr/>
-          <p:nvPr/>
-        </p:nvSpPr>
-        <p:spPr>
-          <a:xfrm>
-            <a:off x="6949440" y="1060704"/>
-            <a:ext cx="1874520" cy="502920"/>
-          </a:xfrm>
-          <a:prstGeom prst="rect">
-            <a:avLst/>
-          </a:prstGeom>
-          <a:noFill/>
-          <a:ln/>
-        </p:spPr>
-        <p:txBody>
-          <a:bodyPr wrap="square" lIns="0" tIns="0" rIns="0" bIns="0" rtlCol="0" anchor="ctr"/>
-          <a:lstStyle/>
-          <a:p>
-            <a:pPr algn="ctr" indent="0" marL="0">
-              <a:buNone/>
-            </a:pPr>
-            <a:r>
-              <a:rPr lang="en-US" sz="3000" b="1" dirty="0">
-                <a:solidFill>
-                  <a:srgbClr val="17241D"/>
-                </a:solidFill>
-                <a:latin typeface="Arial" pitchFamily="34" charset="0"/>
-                <a:ea typeface="Arial" pitchFamily="34" charset="-122"/>
-                <a:cs typeface="Arial" pitchFamily="34" charset="-120"/>
-              </a:rPr>
-              <a:t>−12%</a:t>
-            </a:r>
-            <a:endParaRPr lang="en-US" sz="3000" dirty="0"/>
-          </a:p>
-        </p:txBody>
-      </p:sp>
-      <p:sp>
-        <p:nvSpPr>
-          <p:cNvPr id="15" name="Text 13"/>
-          <p:cNvSpPr/>
-          <p:nvPr/>
-        </p:nvSpPr>
-        <p:spPr>
-          <a:xfrm>
-            <a:off x="6967728" y="1591056"/>
-            <a:ext cx="1828800" cy="548640"/>
-          </a:xfrm>
-          <a:prstGeom prst="rect">
-            <a:avLst/>
-          </a:prstGeom>
-          <a:noFill/>
-          <a:ln/>
-        </p:spPr>
-        <p:txBody>
-          <a:bodyPr wrap="square" lIns="0" tIns="0" rIns="0" bIns="0" rtlCol="0" anchor="ctr"/>
-          <a:lstStyle/>
-          <a:p>
-            <a:pPr algn="ctr" indent="0" marL="0">
-              <a:lnSpc>
-                <a:spcPct val="100000"/>
-              </a:lnSpc>
-              <a:buNone/>
-            </a:pPr>
-            <a:r>
-              <a:rPr lang="en-US" sz="950" dirty="0">
-                <a:solidFill>
-                  <a:srgbClr val="5C6B62"/>
-                </a:solidFill>
-                <a:latin typeface="Arial" pitchFamily="34" charset="0"/>
-                <a:ea typeface="Arial" pitchFamily="34" charset="-122"/>
-                <a:cs typeface="Arial" pitchFamily="34" charset="-120"/>
-              </a:rPr>
-              <a:t>genre diversity in 6 mo · Discover Weekly (research)</a:t>
-            </a:r>
-            <a:endParaRPr lang="en-US" sz="950" dirty="0"/>
-          </a:p>
-        </p:txBody>
-      </p:sp>
-      <p:sp>
-        <p:nvSpPr>
-          <p:cNvPr id="16" name="Shape 14"/>
-          <p:cNvSpPr/>
-          <p:nvPr/>
-        </p:nvSpPr>
-        <p:spPr>
-          <a:xfrm>
-            <a:off x="274320" y="2331720"/>
-            <a:ext cx="5212080" cy="2286000"/>
-          </a:xfrm>
-          <a:prstGeom prst="roundRect">
-            <a:avLst>
-              <a:gd name="adj" fmla="val 2800"/>
-            </a:avLst>
-          </a:prstGeom>
-          <a:solidFill>
-            <a:srgbClr val="FFFFFF"/>
-          </a:solidFill>
-          <a:ln w="12700">
-            <a:solidFill>
-              <a:srgbClr val="D8E5DC"/>
-            </a:solidFill>
-            <a:prstDash val="solid"/>
-          </a:ln>
-          <a:effectLst>
-            <a:outerShdw sx="100000" sy="100000" kx="0" ky="0" algn="bl" rotWithShape="0" blurRad="88900" dist="25400" dir="5400000">
-              <a:srgbClr val="6B6B6B">
-                <a:alpha val="22000"/>
-              </a:srgbClr>
-            </a:outerShdw>
-          </a:effectLst>
-        </p:spPr>
-      </p:sp>
-      <p:sp>
-        <p:nvSpPr>
-          <p:cNvPr id="17" name="Text 15"/>
-          <p:cNvSpPr/>
-          <p:nvPr/>
-        </p:nvSpPr>
-        <p:spPr>
-          <a:xfrm>
-            <a:off x="457200" y="2450592"/>
-            <a:ext cx="4846320" cy="237744"/>
-          </a:xfrm>
-          <a:prstGeom prst="rect">
-            <a:avLst/>
-          </a:prstGeom>
-          <a:noFill/>
-          <a:ln/>
-        </p:spPr>
-        <p:txBody>
-          <a:bodyPr wrap="square" lIns="0" tIns="0" rIns="0" bIns="0" rtlCol="0" anchor="ctr"/>
-          <a:lstStyle/>
-          <a:p>
-            <a:pPr indent="0" marL="0">
-              <a:buNone/>
-            </a:pPr>
-            <a:r>
-              <a:rPr lang="en-US" sz="1000" b="1" spc="150" kern="0" dirty="0">
-                <a:solidFill>
-                  <a:srgbClr val="0E6B37"/>
-                </a:solidFill>
-                <a:latin typeface="Arial" pitchFamily="34" charset="0"/>
-                <a:ea typeface="Arial" pitchFamily="34" charset="-122"/>
-                <a:cs typeface="Arial" pitchFamily="34" charset="-120"/>
-              </a:rPr>
-              <a:t>THE DISCOVERY PARADOX</a:t>
-            </a:r>
-            <a:endParaRPr lang="en-US" sz="1000" dirty="0"/>
-          </a:p>
-        </p:txBody>
-      </p:sp>
-      <p:sp>
-        <p:nvSpPr>
-          <p:cNvPr id="18" name="Text 16"/>
-          <p:cNvSpPr/>
-          <p:nvPr/>
-        </p:nvSpPr>
-        <p:spPr>
-          <a:xfrm>
-            <a:off x="457200" y="2724912"/>
-            <a:ext cx="4937760" cy="548640"/>
-          </a:xfrm>
-          <a:prstGeom prst="rect">
-            <a:avLst/>
-          </a:prstGeom>
-          <a:noFill/>
-          <a:ln/>
-        </p:spPr>
-        <p:txBody>
-          <a:bodyPr wrap="square" lIns="0" tIns="0" rIns="0" bIns="0" rtlCol="0" anchor="ctr"/>
-          <a:lstStyle/>
-          <a:p>
-            <a:pPr indent="0" marL="0">
-              <a:lnSpc>
-                <a:spcPct val="108000"/>
-              </a:lnSpc>
-              <a:buNone/>
-            </a:pPr>
-            <a:r>
-              <a:rPr lang="en-US" sz="1150" dirty="0">
-                <a:solidFill>
-                  <a:srgbClr val="17241D"/>
-                </a:solidFill>
-                <a:latin typeface="Arial" pitchFamily="34" charset="0"/>
-                <a:ea typeface="Arial" pitchFamily="34" charset="-122"/>
-                <a:cs typeface="Arial" pitchFamily="34" charset="-120"/>
-              </a:rPr>
-              <a:t>Spotify owns one of the world's best recommenders — so the bottleneck was never finding new music. It's that engaged listeners won't act on it.</a:t>
-            </a:r>
-            <a:endParaRPr lang="en-US" sz="1150" dirty="0"/>
-          </a:p>
-        </p:txBody>
-      </p:sp>
-      <p:sp>
-        <p:nvSpPr>
-          <p:cNvPr id="19" name="Shape 17"/>
-          <p:cNvSpPr/>
-          <p:nvPr/>
-        </p:nvSpPr>
-        <p:spPr>
-          <a:xfrm>
-            <a:off x="502920" y="3346704"/>
-            <a:ext cx="137160" cy="137160"/>
-          </a:xfrm>
-          <a:prstGeom prst="ellipse">
-            <a:avLst/>
-          </a:prstGeom>
-          <a:solidFill>
-            <a:srgbClr val="1DB954"/>
-          </a:solidFill>
-          <a:ln/>
-        </p:spPr>
-      </p:sp>
-      <p:sp>
-        <p:nvSpPr>
-          <p:cNvPr id="20" name="Text 18"/>
-          <p:cNvSpPr/>
-          <p:nvPr/>
-        </p:nvSpPr>
-        <p:spPr>
-          <a:xfrm>
-            <a:off x="731520" y="3264408"/>
-            <a:ext cx="4663440" cy="384048"/>
-          </a:xfrm>
-          <a:prstGeom prst="rect">
-            <a:avLst/>
-          </a:prstGeom>
-          <a:noFill/>
-          <a:ln/>
-        </p:spPr>
-        <p:txBody>
-          <a:bodyPr wrap="square" lIns="0" tIns="0" rIns="0" bIns="0" rtlCol="0" anchor="ctr"/>
-          <a:lstStyle/>
-          <a:p>
-            <a:pPr indent="0" marL="0">
-              <a:lnSpc>
-                <a:spcPct val="108000"/>
-              </a:lnSpc>
-              <a:buNone/>
-            </a:pPr>
-            <a:r>
-              <a:rPr lang="en-US" sz="1100" b="1" dirty="0">
-                <a:solidFill>
-                  <a:srgbClr val="17241D"/>
-                </a:solidFill>
-                <a:latin typeface="Arial" pitchFamily="34" charset="0"/>
-                <a:ea typeface="Arial" pitchFamily="34" charset="-122"/>
-                <a:cs typeface="Arial" pitchFamily="34" charset="-120"/>
-              </a:rPr>
-              <a:t>Algorithm exploits familiarity — </a:t>
-            </a:r>
-            <a:pPr indent="0" marL="0">
-              <a:lnSpc>
-                <a:spcPct val="108000"/>
-              </a:lnSpc>
-              <a:buNone/>
-            </a:pPr>
-            <a:r>
-              <a:rPr lang="en-US" sz="1100" dirty="0">
-                <a:solidFill>
-                  <a:srgbClr val="5C6B62"/>
-                </a:solidFill>
-                <a:latin typeface="Arial" pitchFamily="34" charset="0"/>
-                <a:ea typeface="Arial" pitchFamily="34" charset="-122"/>
-                <a:cs typeface="Arial" pitchFamily="34" charset="-120"/>
-              </a:rPr>
-              <a:t>the more you listen, the tighter the loop</a:t>
-            </a:r>
-            <a:endParaRPr lang="en-US" sz="1100" dirty="0"/>
-          </a:p>
-        </p:txBody>
-      </p:sp>
-      <p:sp>
-        <p:nvSpPr>
-          <p:cNvPr id="21" name="Shape 19"/>
-          <p:cNvSpPr/>
-          <p:nvPr/>
-        </p:nvSpPr>
-        <p:spPr>
-          <a:xfrm>
-            <a:off x="502920" y="3767328"/>
-            <a:ext cx="137160" cy="137160"/>
-          </a:xfrm>
-          <a:prstGeom prst="ellipse">
-            <a:avLst/>
-          </a:prstGeom>
-          <a:solidFill>
-            <a:srgbClr val="1DB954"/>
-          </a:solidFill>
-          <a:ln/>
-        </p:spPr>
-      </p:sp>
-      <p:sp>
-        <p:nvSpPr>
-          <p:cNvPr id="22" name="Text 20"/>
-          <p:cNvSpPr/>
-          <p:nvPr/>
-        </p:nvSpPr>
-        <p:spPr>
-          <a:xfrm>
-            <a:off x="731520" y="3685032"/>
-            <a:ext cx="4663440" cy="384048"/>
-          </a:xfrm>
-          <a:prstGeom prst="rect">
-            <a:avLst/>
-          </a:prstGeom>
-          <a:noFill/>
-          <a:ln/>
-        </p:spPr>
-        <p:txBody>
-          <a:bodyPr wrap="square" lIns="0" tIns="0" rIns="0" bIns="0" rtlCol="0" anchor="ctr"/>
-          <a:lstStyle/>
-          <a:p>
-            <a:pPr indent="0" marL="0">
-              <a:lnSpc>
-                <a:spcPct val="108000"/>
-              </a:lnSpc>
-              <a:buNone/>
-            </a:pPr>
-            <a:r>
-              <a:rPr lang="en-US" sz="1100" b="1" dirty="0">
-                <a:solidFill>
-                  <a:srgbClr val="17241D"/>
-                </a:solidFill>
-                <a:latin typeface="Arial" pitchFamily="34" charset="0"/>
-                <a:ea typeface="Arial" pitchFamily="34" charset="-122"/>
-                <a:cs typeface="Arial" pitchFamily="34" charset="-120"/>
-              </a:rPr>
-              <a:t>Unfamiliar = unrewarded — </a:t>
-            </a:r>
-            <a:pPr indent="0" marL="0">
-              <a:lnSpc>
-                <a:spcPct val="108000"/>
-              </a:lnSpc>
-              <a:buNone/>
-            </a:pPr>
-            <a:r>
-              <a:rPr lang="en-US" sz="1100" dirty="0">
-                <a:solidFill>
-                  <a:srgbClr val="5C6B62"/>
-                </a:solidFill>
-                <a:latin typeface="Arial" pitchFamily="34" charset="0"/>
-                <a:ea typeface="Arial" pitchFamily="34" charset="-122"/>
-                <a:cs typeface="Arial" pitchFamily="34" charset="-120"/>
-              </a:rPr>
-              <a:t>no reason to trust a new pick, so users skip</a:t>
-            </a:r>
-            <a:endParaRPr lang="en-US" sz="1100" dirty="0"/>
-          </a:p>
-        </p:txBody>
-      </p:sp>
-      <p:sp>
-        <p:nvSpPr>
-          <p:cNvPr id="23" name="Shape 21"/>
-          <p:cNvSpPr/>
-          <p:nvPr/>
-        </p:nvSpPr>
-        <p:spPr>
-          <a:xfrm>
-            <a:off x="502920" y="4187952"/>
-            <a:ext cx="137160" cy="137160"/>
-          </a:xfrm>
-          <a:prstGeom prst="ellipse">
-            <a:avLst/>
-          </a:prstGeom>
-          <a:solidFill>
-            <a:srgbClr val="1DB954"/>
-          </a:solidFill>
-          <a:ln/>
-        </p:spPr>
-      </p:sp>
-      <p:sp>
-        <p:nvSpPr>
-          <p:cNvPr id="24" name="Text 22"/>
-          <p:cNvSpPr/>
-          <p:nvPr/>
-        </p:nvSpPr>
-        <p:spPr>
-          <a:xfrm>
-            <a:off x="731520" y="4105656"/>
-            <a:ext cx="4663440" cy="384048"/>
-          </a:xfrm>
-          <a:prstGeom prst="rect">
-            <a:avLst/>
-          </a:prstGeom>
-          <a:noFill/>
-          <a:ln/>
-        </p:spPr>
-        <p:txBody>
-          <a:bodyPr wrap="square" lIns="0" tIns="0" rIns="0" bIns="0" rtlCol="0" anchor="ctr"/>
-          <a:lstStyle/>
-          <a:p>
-            <a:pPr indent="0" marL="0">
-              <a:lnSpc>
-                <a:spcPct val="108000"/>
-              </a:lnSpc>
-              <a:buNone/>
-            </a:pPr>
-            <a:r>
-              <a:rPr lang="en-US" sz="1100" b="1" dirty="0">
-                <a:solidFill>
-                  <a:srgbClr val="17241D"/>
-                </a:solidFill>
-                <a:latin typeface="Arial" pitchFamily="34" charset="0"/>
-                <a:ea typeface="Arial" pitchFamily="34" charset="-122"/>
-                <a:cs typeface="Arial" pitchFamily="34" charset="-120"/>
-              </a:rPr>
-              <a:t>Loyalty backfires — </a:t>
-            </a:r>
-            <a:pPr indent="0" marL="0">
-              <a:lnSpc>
-                <a:spcPct val="108000"/>
-              </a:lnSpc>
-              <a:buNone/>
-            </a:pPr>
-            <a:r>
-              <a:rPr lang="en-US" sz="1100" dirty="0">
-                <a:solidFill>
-                  <a:srgbClr val="5C6B62"/>
-                </a:solidFill>
-                <a:latin typeface="Arial" pitchFamily="34" charset="0"/>
-                <a:ea typeface="Arial" pitchFamily="34" charset="-122"/>
-                <a:cs typeface="Arial" pitchFamily="34" charset="-120"/>
-              </a:rPr>
-              <a:t>heaviest users get the stalest discovery</a:t>
-            </a:r>
-            <a:endParaRPr lang="en-US" sz="1100" dirty="0"/>
-          </a:p>
-        </p:txBody>
-      </p:sp>
-      <p:sp>
-        <p:nvSpPr>
-          <p:cNvPr id="25" name="Shape 23"/>
-          <p:cNvSpPr/>
-          <p:nvPr/>
-        </p:nvSpPr>
-        <p:spPr>
-          <a:xfrm>
-            <a:off x="5669280" y="2331720"/>
-            <a:ext cx="3200400" cy="2286000"/>
-          </a:xfrm>
-          <a:prstGeom prst="roundRect">
-            <a:avLst>
-              <a:gd name="adj" fmla="val 2800"/>
-            </a:avLst>
-          </a:prstGeom>
-          <a:solidFill>
-            <a:srgbClr val="E7F6EC"/>
-          </a:solidFill>
-          <a:ln w="12700">
-            <a:solidFill>
-              <a:srgbClr val="D8E5DC"/>
-            </a:solidFill>
-            <a:prstDash val="solid"/>
-          </a:ln>
-          <a:effectLst>
-            <a:outerShdw sx="100000" sy="100000" kx="0" ky="0" algn="bl" rotWithShape="0" blurRad="88900" dist="25400" dir="5400000">
-              <a:srgbClr val="6B6B6B">
-                <a:alpha val="22000"/>
-              </a:srgbClr>
-            </a:outerShdw>
-          </a:effectLst>
-        </p:spPr>
-      </p:sp>
-      <p:sp>
-        <p:nvSpPr>
-          <p:cNvPr id="26" name="Text 24"/>
-          <p:cNvSpPr/>
-          <p:nvPr/>
-        </p:nvSpPr>
-        <p:spPr>
-          <a:xfrm>
-            <a:off x="5852160" y="2450592"/>
-            <a:ext cx="2834640" cy="237744"/>
-          </a:xfrm>
-          <a:prstGeom prst="rect">
-            <a:avLst/>
-          </a:prstGeom>
-          <a:noFill/>
-          <a:ln/>
-        </p:spPr>
-        <p:txBody>
-          <a:bodyPr wrap="square" lIns="0" tIns="0" rIns="0" bIns="0" rtlCol="0" anchor="ctr"/>
-          <a:lstStyle/>
-          <a:p>
-            <a:pPr indent="0" marL="0">
-              <a:buNone/>
-            </a:pPr>
-            <a:r>
-              <a:rPr lang="en-US" sz="1000" b="1" spc="150" kern="0" dirty="0">
-                <a:solidFill>
-                  <a:srgbClr val="0E6B37"/>
-                </a:solidFill>
-                <a:latin typeface="Arial" pitchFamily="34" charset="0"/>
-                <a:ea typeface="Arial" pitchFamily="34" charset="-122"/>
-                <a:cs typeface="Arial" pitchFamily="34" charset="-120"/>
-              </a:rPr>
-              <a:t>WHAT'S MISSING</a:t>
-            </a:r>
-            <a:endParaRPr lang="en-US" sz="1000" dirty="0"/>
-          </a:p>
-        </p:txBody>
-      </p:sp>
-      <p:sp>
-        <p:nvSpPr>
-          <p:cNvPr id="27" name="Text 25"/>
-          <p:cNvSpPr/>
-          <p:nvPr/>
-        </p:nvSpPr>
-        <p:spPr>
-          <a:xfrm>
-            <a:off x="5852160" y="2743200"/>
-            <a:ext cx="2880360" cy="1280160"/>
-          </a:xfrm>
-          <a:prstGeom prst="rect">
-            <a:avLst/>
-          </a:prstGeom>
-          <a:noFill/>
-          <a:ln/>
-        </p:spPr>
-        <p:txBody>
-          <a:bodyPr wrap="square" lIns="0" tIns="0" rIns="0" bIns="0" rtlCol="0" anchor="ctr"/>
-          <a:lstStyle/>
-          <a:p>
-            <a:pPr indent="0" marL="0">
-              <a:lnSpc>
-                <a:spcPct val="112000"/>
-              </a:lnSpc>
-              <a:buNone/>
-            </a:pPr>
-            <a:r>
-              <a:rPr lang="en-US" sz="1250" dirty="0">
-                <a:solidFill>
-                  <a:srgbClr val="17241D"/>
-                </a:solidFill>
-                <a:latin typeface="Arial" pitchFamily="34" charset="0"/>
-                <a:ea typeface="Arial" pitchFamily="34" charset="-122"/>
-                <a:cs typeface="Arial" pitchFamily="34" charset="-120"/>
-              </a:rPr>
-              <a:t>Every platform competes on recommendation accuracy. None has built the acceptance layer — a reason to press play on the unfamiliar.</a:t>
-            </a:r>
-            <a:endParaRPr lang="en-US" sz="1250" dirty="0"/>
-          </a:p>
-        </p:txBody>
-      </p:sp>
-      <p:sp>
-        <p:nvSpPr>
-          <p:cNvPr id="28" name="Text 26"/>
-          <p:cNvSpPr/>
-          <p:nvPr/>
-        </p:nvSpPr>
-        <p:spPr>
-          <a:xfrm>
-            <a:off x="5852160" y="4114800"/>
-            <a:ext cx="2880360" cy="411480"/>
-          </a:xfrm>
-          <a:prstGeom prst="rect">
-            <a:avLst/>
-          </a:prstGeom>
-          <a:noFill/>
-          <a:ln/>
-        </p:spPr>
-        <p:txBody>
-          <a:bodyPr wrap="square" lIns="0" tIns="0" rIns="0" bIns="0" rtlCol="0" anchor="ctr"/>
-          <a:lstStyle/>
-          <a:p>
-            <a:pPr indent="0" marL="0">
-              <a:lnSpc>
-                <a:spcPct val="105000"/>
-              </a:lnSpc>
-              <a:buNone/>
-            </a:pPr>
-            <a:r>
-              <a:rPr lang="en-US" sz="1150" b="1" i="1" dirty="0">
-                <a:solidFill>
-                  <a:srgbClr val="0E6B37"/>
-                </a:solidFill>
-                <a:latin typeface="Arial" pitchFamily="34" charset="0"/>
-                <a:ea typeface="Arial" pitchFamily="34" charset="-122"/>
-                <a:cs typeface="Arial" pitchFamily="34" charset="-120"/>
-              </a:rPr>
-              <a:t>The market gap is acceptance, not accuracy.</a:t>
-            </a:r>
-            <a:endParaRPr lang="en-US" sz="1150" dirty="0"/>
-          </a:p>
-        </p:txBody>
-      </p:sp>
-      <p:sp>
-        <p:nvSpPr>
-          <p:cNvPr id="29" name="Shape 27"/>
-          <p:cNvSpPr/>
-          <p:nvPr/>
-        </p:nvSpPr>
-        <p:spPr>
-          <a:xfrm>
-            <a:off x="0" y="4754880"/>
-            <a:ext cx="9144000" cy="388620"/>
-          </a:xfrm>
-          <a:prstGeom prst="rect">
-            <a:avLst/>
-          </a:prstGeom>
-          <a:solidFill>
-            <a:srgbClr val="0E6B37"/>
-          </a:solidFill>
-          <a:ln/>
-        </p:spPr>
-      </p:sp>
-      <p:sp>
-        <p:nvSpPr>
-          <p:cNvPr id="30" name="Text 28"/>
-          <p:cNvSpPr/>
-          <p:nvPr/>
-        </p:nvSpPr>
-        <p:spPr>
-          <a:xfrm>
-            <a:off x="182880" y="4754880"/>
-            <a:ext cx="8778240" cy="388620"/>
-          </a:xfrm>
-          <a:prstGeom prst="rect">
-            <a:avLst/>
-          </a:prstGeom>
-          <a:noFill/>
-          <a:ln/>
-        </p:spPr>
-        <p:txBody>
-          <a:bodyPr wrap="square" lIns="0" tIns="0" rIns="0" bIns="0" rtlCol="0" anchor="ctr"/>
-          <a:lstStyle/>
-          <a:p>
-            <a:pPr algn="ctr" indent="0" marL="0">
-              <a:buNone/>
-            </a:pPr>
-            <a:r>
-              <a:rPr lang="en-US" sz="1000" b="1" dirty="0">
-                <a:solidFill>
-                  <a:srgbClr val="FFFFFF"/>
-                </a:solidFill>
-                <a:latin typeface="Arial" pitchFamily="34" charset="0"/>
-                <a:ea typeface="Arial" pitchFamily="34" charset="-122"/>
-                <a:cs typeface="Arial" pitchFamily="34" charset="-120"/>
-              </a:rPr>
-              <a:t>Market</a:t>
-            </a:r>
-            <a:pPr algn="ctr" indent="0" marL="0">
-              <a:buNone/>
-            </a:pPr>
-            <a:r>
-              <a:rPr lang="en-US" sz="850" dirty="0">
-                <a:solidFill>
-                  <a:srgbClr val="FFFFFF">
-                    <a:alpha val="40000"/>
-                  </a:srgbClr>
-                </a:solidFill>
-                <a:latin typeface="Arial" pitchFamily="34" charset="0"/>
-                <a:ea typeface="Arial" pitchFamily="34" charset="-122"/>
-                <a:cs typeface="Arial" pitchFamily="34" charset="-120"/>
-              </a:rPr>
-              <a:t>   </a:t>
-            </a:r>
-            <a:pPr algn="ctr" indent="0" marL="0">
-              <a:buNone/>
-            </a:pPr>
-            <a:r>
-              <a:rPr lang="en-US" sz="850" dirty="0">
-                <a:solidFill>
-                  <a:srgbClr val="FFFFFF">
-                    <a:alpha val="55000"/>
-                  </a:srgbClr>
-                </a:solidFill>
-                <a:latin typeface="Arial" pitchFamily="34" charset="0"/>
-                <a:ea typeface="Arial" pitchFamily="34" charset="-122"/>
-                <a:cs typeface="Arial" pitchFamily="34" charset="-120"/>
-              </a:rPr>
-              <a:t>Context</a:t>
-            </a:r>
-            <a:pPr algn="ctr" indent="0" marL="0">
-              <a:buNone/>
-            </a:pPr>
-            <a:r>
-              <a:rPr lang="en-US" sz="850" dirty="0">
-                <a:solidFill>
-                  <a:srgbClr val="FFFFFF">
-                    <a:alpha val="40000"/>
-                  </a:srgbClr>
-                </a:solidFill>
-                <a:latin typeface="Arial" pitchFamily="34" charset="0"/>
-                <a:ea typeface="Arial" pitchFamily="34" charset="-122"/>
-                <a:cs typeface="Arial" pitchFamily="34" charset="-120"/>
-              </a:rPr>
-              <a:t>   </a:t>
-            </a:r>
-            <a:pPr algn="ctr" indent="0" marL="0">
-              <a:buNone/>
-            </a:pPr>
-            <a:r>
-              <a:rPr lang="en-US" sz="850" dirty="0">
-                <a:solidFill>
-                  <a:srgbClr val="FFFFFF">
-                    <a:alpha val="55000"/>
-                  </a:srgbClr>
-                </a:solidFill>
-                <a:latin typeface="Arial" pitchFamily="34" charset="0"/>
-                <a:ea typeface="Arial" pitchFamily="34" charset="-122"/>
-                <a:cs typeface="Arial" pitchFamily="34" charset="-120"/>
-              </a:rPr>
-              <a:t>Research</a:t>
-            </a:r>
-            <a:pPr algn="ctr" indent="0" marL="0">
-              <a:buNone/>
-            </a:pPr>
-            <a:r>
-              <a:rPr lang="en-US" sz="850" dirty="0">
-                <a:solidFill>
-                  <a:srgbClr val="FFFFFF">
-                    <a:alpha val="40000"/>
-                  </a:srgbClr>
-                </a:solidFill>
-                <a:latin typeface="Arial" pitchFamily="34" charset="0"/>
-                <a:ea typeface="Arial" pitchFamily="34" charset="-122"/>
-                <a:cs typeface="Arial" pitchFamily="34" charset="-120"/>
-              </a:rPr>
-              <a:t>   </a:t>
-            </a:r>
-            <a:pPr algn="ctr" indent="0" marL="0">
-              <a:buNone/>
-            </a:pPr>
-            <a:r>
-              <a:rPr lang="en-US" sz="850" dirty="0">
-                <a:solidFill>
-                  <a:srgbClr val="FFFFFF">
-                    <a:alpha val="55000"/>
-                  </a:srgbClr>
-                </a:solidFill>
-                <a:latin typeface="Arial" pitchFamily="34" charset="0"/>
-                <a:ea typeface="Arial" pitchFamily="34" charset="-122"/>
-                <a:cs typeface="Arial" pitchFamily="34" charset="-120"/>
-              </a:rPr>
-              <a:t>Persona &amp; Journey</a:t>
-            </a:r>
-            <a:pPr algn="ctr" indent="0" marL="0">
-              <a:buNone/>
-            </a:pPr>
-            <a:r>
-              <a:rPr lang="en-US" sz="850" dirty="0">
-                <a:solidFill>
-                  <a:srgbClr val="FFFFFF">
-                    <a:alpha val="40000"/>
-                  </a:srgbClr>
-                </a:solidFill>
-                <a:latin typeface="Arial" pitchFamily="34" charset="0"/>
-                <a:ea typeface="Arial" pitchFamily="34" charset="-122"/>
-                <a:cs typeface="Arial" pitchFamily="34" charset="-120"/>
-              </a:rPr>
-              <a:t>   </a:t>
-            </a:r>
-            <a:pPr algn="ctr" indent="0" marL="0">
-              <a:buNone/>
-            </a:pPr>
-            <a:r>
-              <a:rPr lang="en-US" sz="850" dirty="0">
-                <a:solidFill>
-                  <a:srgbClr val="FFFFFF">
-                    <a:alpha val="55000"/>
-                  </a:srgbClr>
-                </a:solidFill>
-                <a:latin typeface="Arial" pitchFamily="34" charset="0"/>
-                <a:ea typeface="Arial" pitchFamily="34" charset="-122"/>
-                <a:cs typeface="Arial" pitchFamily="34" charset="-120"/>
-              </a:rPr>
-              <a:t>Problem</a:t>
-            </a:r>
-            <a:pPr algn="ctr" indent="0" marL="0">
-              <a:buNone/>
-            </a:pPr>
-            <a:r>
-              <a:rPr lang="en-US" sz="850" dirty="0">
-                <a:solidFill>
-                  <a:srgbClr val="FFFFFF">
-                    <a:alpha val="40000"/>
-                  </a:srgbClr>
-                </a:solidFill>
-                <a:latin typeface="Arial" pitchFamily="34" charset="0"/>
-                <a:ea typeface="Arial" pitchFamily="34" charset="-122"/>
-                <a:cs typeface="Arial" pitchFamily="34" charset="-120"/>
-              </a:rPr>
-              <a:t>   </a:t>
-            </a:r>
-            <a:pPr algn="ctr" indent="0" marL="0">
-              <a:buNone/>
-            </a:pPr>
-            <a:r>
-              <a:rPr lang="en-US" sz="850" dirty="0">
-                <a:solidFill>
-                  <a:srgbClr val="FFFFFF">
-                    <a:alpha val="55000"/>
-                  </a:srgbClr>
-                </a:solidFill>
-                <a:latin typeface="Arial" pitchFamily="34" charset="0"/>
-                <a:ea typeface="Arial" pitchFamily="34" charset="-122"/>
-                <a:cs typeface="Arial" pitchFamily="34" charset="-120"/>
-              </a:rPr>
-              <a:t>Solution</a:t>
-            </a:r>
-            <a:pPr algn="ctr" indent="0" marL="0">
-              <a:buNone/>
-            </a:pPr>
-            <a:r>
-              <a:rPr lang="en-US" sz="850" dirty="0">
-                <a:solidFill>
-                  <a:srgbClr val="FFFFFF">
-                    <a:alpha val="40000"/>
-                  </a:srgbClr>
-                </a:solidFill>
-                <a:latin typeface="Arial" pitchFamily="34" charset="0"/>
-                <a:ea typeface="Arial" pitchFamily="34" charset="-122"/>
-                <a:cs typeface="Arial" pitchFamily="34" charset="-120"/>
-              </a:rPr>
-              <a:t>   </a:t>
-            </a:r>
-            <a:pPr algn="ctr" indent="0" marL="0">
-              <a:buNone/>
-            </a:pPr>
-            <a:r>
-              <a:rPr lang="en-US" sz="850" dirty="0">
-                <a:solidFill>
-                  <a:srgbClr val="FFFFFF">
-                    <a:alpha val="55000"/>
-                  </a:srgbClr>
-                </a:solidFill>
-                <a:latin typeface="Arial" pitchFamily="34" charset="0"/>
-                <a:ea typeface="Arial" pitchFamily="34" charset="-122"/>
-                <a:cs typeface="Arial" pitchFamily="34" charset="-120"/>
-              </a:rPr>
-              <a:t>MVP</a:t>
-            </a:r>
-            <a:pPr algn="ctr" indent="0" marL="0">
-              <a:buNone/>
-            </a:pPr>
-            <a:r>
-              <a:rPr lang="en-US" sz="850" dirty="0">
-                <a:solidFill>
-                  <a:srgbClr val="FFFFFF">
-                    <a:alpha val="40000"/>
-                  </a:srgbClr>
-                </a:solidFill>
-                <a:latin typeface="Arial" pitchFamily="34" charset="0"/>
-                <a:ea typeface="Arial" pitchFamily="34" charset="-122"/>
-                <a:cs typeface="Arial" pitchFamily="34" charset="-120"/>
-              </a:rPr>
-              <a:t>   </a:t>
-            </a:r>
-            <a:pPr algn="ctr" indent="0" marL="0">
-              <a:buNone/>
-            </a:pPr>
-            <a:r>
-              <a:rPr lang="en-US" sz="850" dirty="0">
-                <a:solidFill>
-                  <a:srgbClr val="FFFFFF">
-                    <a:alpha val="55000"/>
-                  </a:srgbClr>
-                </a:solidFill>
-                <a:latin typeface="Arial" pitchFamily="34" charset="0"/>
-                <a:ea typeface="Arial" pitchFamily="34" charset="-122"/>
-                <a:cs typeface="Arial" pitchFamily="34" charset="-120"/>
-              </a:rPr>
-              <a:t>Architecture</a:t>
-            </a:r>
-            <a:pPr algn="ctr" indent="0" marL="0">
-              <a:buNone/>
-            </a:pPr>
-            <a:r>
-              <a:rPr lang="en-US" sz="850" dirty="0">
-                <a:solidFill>
-                  <a:srgbClr val="FFFFFF">
-                    <a:alpha val="40000"/>
-                  </a:srgbClr>
-                </a:solidFill>
-                <a:latin typeface="Arial" pitchFamily="34" charset="0"/>
-                <a:ea typeface="Arial" pitchFamily="34" charset="-122"/>
-                <a:cs typeface="Arial" pitchFamily="34" charset="-120"/>
-              </a:rPr>
-              <a:t>   </a:t>
-            </a:r>
-            <a:pPr algn="ctr" indent="0" marL="0">
-              <a:buNone/>
-            </a:pPr>
-            <a:r>
-              <a:rPr lang="en-US" sz="850" dirty="0">
-                <a:solidFill>
-                  <a:srgbClr val="FFFFFF">
-                    <a:alpha val="55000"/>
-                  </a:srgbClr>
-                </a:solidFill>
-                <a:latin typeface="Arial" pitchFamily="34" charset="0"/>
-                <a:ea typeface="Arial" pitchFamily="34" charset="-122"/>
-                <a:cs typeface="Arial" pitchFamily="34" charset="-120"/>
-              </a:rPr>
-              <a:t>Metrics</a:t>
-            </a:r>
-            <a:pPr algn="ctr" indent="0" marL="0">
-              <a:buNone/>
-            </a:pPr>
-            <a:r>
-              <a:rPr lang="en-US" sz="850" dirty="0">
-                <a:solidFill>
-                  <a:srgbClr val="FFFFFF">
-                    <a:alpha val="40000"/>
-                  </a:srgbClr>
-                </a:solidFill>
-                <a:latin typeface="Arial" pitchFamily="34" charset="0"/>
-                <a:ea typeface="Arial" pitchFamily="34" charset="-122"/>
-                <a:cs typeface="Arial" pitchFamily="34" charset="-120"/>
-              </a:rPr>
-              <a:t>   </a:t>
-            </a:r>
-            <a:pPr algn="ctr" indent="0" marL="0">
-              <a:buNone/>
-            </a:pPr>
-            <a:r>
-              <a:rPr lang="en-US" sz="850" dirty="0">
-                <a:solidFill>
-                  <a:srgbClr val="FFFFFF">
-                    <a:alpha val="55000"/>
-                  </a:srgbClr>
-                </a:solidFill>
-                <a:latin typeface="Arial" pitchFamily="34" charset="0"/>
-                <a:ea typeface="Arial" pitchFamily="34" charset="-122"/>
-                <a:cs typeface="Arial" pitchFamily="34" charset="-120"/>
-              </a:rPr>
-              <a:t>Risks</a:t>
-            </a:r>
-            <a:endParaRPr lang="en-US" sz="1000" dirty="0"/>
+              <a:rPr lang="en-US" sz="750" dirty="0">
+                <a:solidFill>
+                  <a:srgbClr val="9CC7AC"/>
+                </a:solidFill>
+                <a:latin typeface="Arial" pitchFamily="34" charset="0"/>
+                <a:ea typeface="Arial" pitchFamily="34" charset="-122"/>
+                <a:cs typeface="Arial" pitchFamily="34" charset="-120"/>
+              </a:rPr>
+              <a:t>Figures: Spotify reported MAU / Premium; repeat-listening &amp; genre-diversity from published personalization research. Reviews: 7,296 analyzed via an AI review engine.</a:t>
+            </a:r>
+            <a:endParaRPr lang="en-US" sz="750" dirty="0"/>
           </a:p>
         </p:txBody>
       </p:sp>
@@ -4624,38 +3579,6 @@
                 <a:ea typeface="Arial" pitchFamily="34" charset="-122"/>
                 <a:cs typeface="Arial" pitchFamily="34" charset="-120"/>
               </a:rPr>
-              <a:t>Context</a:t>
-            </a:r>
-            <a:pPr algn="ctr" indent="0" marL="0">
-              <a:buNone/>
-            </a:pPr>
-            <a:r>
-              <a:rPr lang="en-US" sz="850" dirty="0">
-                <a:solidFill>
-                  <a:srgbClr val="FFFFFF">
-                    <a:alpha val="40000"/>
-                  </a:srgbClr>
-                </a:solidFill>
-                <a:latin typeface="Arial" pitchFamily="34" charset="0"/>
-                <a:ea typeface="Arial" pitchFamily="34" charset="-122"/>
-                <a:cs typeface="Arial" pitchFamily="34" charset="-120"/>
-              </a:rPr>
-              <a:t>   </a:t>
-            </a:r>
-            <a:pPr algn="ctr" indent="0" marL="0">
-              <a:buNone/>
-            </a:pPr>
-            <a:r>
-              <a:rPr lang="en-US" sz="850" dirty="0">
-                <a:solidFill>
-                  <a:srgbClr val="FFFFFF">
-                    <a:alpha val="55000"/>
-                  </a:srgbClr>
-                </a:solidFill>
-                <a:latin typeface="Arial" pitchFamily="34" charset="0"/>
-                <a:ea typeface="Arial" pitchFamily="34" charset="-122"/>
-                <a:cs typeface="Arial" pitchFamily="34" charset="-120"/>
-              </a:rPr>
               <a:t>Research</a:t>
             </a:r>
             <a:pPr algn="ctr" indent="0" marL="0">
@@ -4972,7 +3895,7 @@
                 <a:ea typeface="Arial" pitchFamily="34" charset="-122"/>
                 <a:cs typeface="Arial" pitchFamily="34" charset="-120"/>
               </a:rPr>
-              <a:t>Everyone optimized accuracy. Nobody optimized acceptance.</a:t>
+              <a:t>Spotify perfected recommendation. Discovery still stalls.</a:t>
             </a:r>
             <a:endParaRPr lang="en-US" sz="2100" dirty="0"/>
           </a:p>
@@ -4980,57 +3903,18 @@
       </p:sp>
       <p:sp>
         <p:nvSpPr>
-          <p:cNvPr id="4" name="Text 2"/>
-          <p:cNvSpPr/>
-          <p:nvPr/>
-        </p:nvSpPr>
-        <p:spPr>
-          <a:xfrm>
-            <a:off x="274320" y="932688"/>
-            <a:ext cx="2926080" cy="237744"/>
-          </a:xfrm>
-          <a:prstGeom prst="rect">
-            <a:avLst/>
-          </a:prstGeom>
-          <a:noFill/>
-          <a:ln/>
-        </p:spPr>
-        <p:txBody>
-          <a:bodyPr wrap="square" lIns="0" tIns="0" rIns="0" bIns="0" rtlCol="0" anchor="ctr"/>
-          <a:lstStyle/>
-          <a:p>
-            <a:pPr indent="0" marL="0">
-              <a:buNone/>
-            </a:pPr>
-            <a:r>
-              <a:rPr lang="en-US" sz="1000" b="1" spc="150" kern="0" dirty="0">
-                <a:solidFill>
-                  <a:srgbClr val="0E6B37"/>
-                </a:solidFill>
-                <a:latin typeface="Arial" pitchFamily="34" charset="0"/>
-                <a:ea typeface="Arial" pitchFamily="34" charset="-122"/>
-                <a:cs typeface="Arial" pitchFamily="34" charset="-120"/>
-              </a:rPr>
-              <a:t>WHAT THE ECOSYSTEM SOLVED</a:t>
-            </a:r>
-            <a:endParaRPr lang="en-US" sz="1000" dirty="0"/>
-          </a:p>
-        </p:txBody>
-      </p:sp>
-      <p:sp>
-        <p:nvSpPr>
-          <p:cNvPr id="5" name="Shape 3"/>
-          <p:cNvSpPr/>
-          <p:nvPr/>
-        </p:nvSpPr>
-        <p:spPr>
-          <a:xfrm>
-            <a:off x="274320" y="1207008"/>
-            <a:ext cx="2971800" cy="493776"/>
+          <p:cNvPr id="4" name="Shape 2"/>
+          <p:cNvSpPr/>
+          <p:nvPr/>
+        </p:nvSpPr>
+        <p:spPr>
+          <a:xfrm>
+            <a:off x="274320" y="960120"/>
+            <a:ext cx="2057400" cy="1234440"/>
           </a:xfrm>
           <a:prstGeom prst="roundRect">
             <a:avLst>
-              <a:gd name="adj" fmla="val 12963"/>
+              <a:gd name="adj" fmla="val 5185"/>
             </a:avLst>
           </a:prstGeom>
           <a:solidFill>
@@ -5053,65 +3937,68 @@
       </p:sp>
       <p:sp>
         <p:nvSpPr>
+          <p:cNvPr id="5" name="Text 3"/>
+          <p:cNvSpPr/>
+          <p:nvPr/>
+        </p:nvSpPr>
+        <p:spPr>
+          <a:xfrm>
+            <a:off x="365760" y="1060704"/>
+            <a:ext cx="1874520" cy="502920"/>
+          </a:xfrm>
+          <a:prstGeom prst="rect">
+            <a:avLst/>
+          </a:prstGeom>
+          <a:noFill/>
+          <a:ln/>
+        </p:spPr>
+        <p:txBody>
+          <a:bodyPr wrap="square" lIns="0" tIns="0" rIns="0" bIns="0" rtlCol="0" anchor="ctr"/>
+          <a:lstStyle/>
+          <a:p>
+            <a:pPr algn="ctr" indent="0" marL="0">
+              <a:buNone/>
+            </a:pPr>
+            <a:r>
+              <a:rPr lang="en-US" sz="3000" b="1" dirty="0">
+                <a:solidFill>
+                  <a:srgbClr val="17241D"/>
+                </a:solidFill>
+                <a:latin typeface="Arial" pitchFamily="34" charset="0"/>
+                <a:ea typeface="Arial" pitchFamily="34" charset="-122"/>
+                <a:cs typeface="Arial" pitchFamily="34" charset="-120"/>
+              </a:rPr>
+              <a:t>~675M</a:t>
+            </a:r>
+            <a:endParaRPr lang="en-US" sz="3000" dirty="0"/>
+          </a:p>
+        </p:txBody>
+      </p:sp>
+      <p:sp>
+        <p:nvSpPr>
           <p:cNvPr id="6" name="Text 4"/>
           <p:cNvSpPr/>
           <p:nvPr/>
         </p:nvSpPr>
         <p:spPr>
           <a:xfrm>
-            <a:off x="411480" y="1252728"/>
-            <a:ext cx="2743200" cy="237744"/>
-          </a:xfrm>
-          <a:prstGeom prst="rect">
-            <a:avLst/>
-          </a:prstGeom>
-          <a:noFill/>
-          <a:ln/>
-        </p:spPr>
-        <p:txBody>
-          <a:bodyPr wrap="square" lIns="0" tIns="0" rIns="0" bIns="0" rtlCol="0" anchor="ctr"/>
-          <a:lstStyle/>
-          <a:p>
-            <a:pPr indent="0" marL="0">
-              <a:buNone/>
-            </a:pPr>
-            <a:r>
-              <a:rPr lang="en-US" sz="1100" b="1" dirty="0">
-                <a:solidFill>
-                  <a:srgbClr val="17241D"/>
-                </a:solidFill>
-                <a:latin typeface="Arial" pitchFamily="34" charset="0"/>
-                <a:ea typeface="Arial" pitchFamily="34" charset="-122"/>
-                <a:cs typeface="Arial" pitchFamily="34" charset="-120"/>
-              </a:rPr>
-              <a:t>Recommendation accuracy</a:t>
-            </a:r>
-            <a:endParaRPr lang="en-US" sz="1100" dirty="0"/>
-          </a:p>
-        </p:txBody>
-      </p:sp>
-      <p:sp>
-        <p:nvSpPr>
-          <p:cNvPr id="7" name="Text 5"/>
-          <p:cNvSpPr/>
-          <p:nvPr/>
-        </p:nvSpPr>
-        <p:spPr>
-          <a:xfrm>
-            <a:off x="411480" y="1481328"/>
-            <a:ext cx="2743200" cy="201168"/>
-          </a:xfrm>
-          <a:prstGeom prst="rect">
-            <a:avLst/>
-          </a:prstGeom>
-          <a:noFill/>
-          <a:ln/>
-        </p:spPr>
-        <p:txBody>
-          <a:bodyPr wrap="square" lIns="0" tIns="0" rIns="0" bIns="0" rtlCol="0" anchor="ctr"/>
-          <a:lstStyle/>
-          <a:p>
-            <a:pPr indent="0" marL="0">
+            <a:off x="384048" y="1591056"/>
+            <a:ext cx="1828800" cy="548640"/>
+          </a:xfrm>
+          <a:prstGeom prst="rect">
+            <a:avLst/>
+          </a:prstGeom>
+          <a:noFill/>
+          <a:ln/>
+        </p:spPr>
+        <p:txBody>
+          <a:bodyPr wrap="square" lIns="0" tIns="0" rIns="0" bIns="0" rtlCol="0" anchor="ctr"/>
+          <a:lstStyle/>
+          <a:p>
+            <a:pPr algn="ctr" indent="0" marL="0">
+              <a:lnSpc>
+                <a:spcPct val="100000"/>
+              </a:lnSpc>
               <a:buNone/>
             </a:pPr>
             <a:r>
@@ -5123,7 +4010,7 @@
                 <a:ea typeface="Arial" pitchFamily="34" charset="-122"/>
                 <a:cs typeface="Arial" pitchFamily="34" charset="-120"/>
               </a:rPr>
-              <a:t>Spotify · Apple · YouTube</a:t>
+              <a:t>monthly active users (reported)</a:t>
             </a:r>
             <a:endParaRPr lang="en-US" sz="950" dirty="0"/>
           </a:p>
@@ -5131,18 +4018,18 @@
       </p:sp>
       <p:sp>
         <p:nvSpPr>
-          <p:cNvPr id="8" name="Shape 6"/>
-          <p:cNvSpPr/>
-          <p:nvPr/>
-        </p:nvSpPr>
-        <p:spPr>
-          <a:xfrm>
-            <a:off x="274320" y="1773936"/>
-            <a:ext cx="2971800" cy="493776"/>
+          <p:cNvPr id="7" name="Shape 5"/>
+          <p:cNvSpPr/>
+          <p:nvPr/>
+        </p:nvSpPr>
+        <p:spPr>
+          <a:xfrm>
+            <a:off x="2468880" y="960120"/>
+            <a:ext cx="2057400" cy="1234440"/>
           </a:xfrm>
           <a:prstGeom prst="roundRect">
             <a:avLst>
-              <a:gd name="adj" fmla="val 12963"/>
+              <a:gd name="adj" fmla="val 5185"/>
             </a:avLst>
           </a:prstGeom>
           <a:solidFill>
@@ -5165,65 +4052,68 @@
       </p:sp>
       <p:sp>
         <p:nvSpPr>
+          <p:cNvPr id="8" name="Text 6"/>
+          <p:cNvSpPr/>
+          <p:nvPr/>
+        </p:nvSpPr>
+        <p:spPr>
+          <a:xfrm>
+            <a:off x="2560320" y="1060704"/>
+            <a:ext cx="1874520" cy="502920"/>
+          </a:xfrm>
+          <a:prstGeom prst="rect">
+            <a:avLst/>
+          </a:prstGeom>
+          <a:noFill/>
+          <a:ln/>
+        </p:spPr>
+        <p:txBody>
+          <a:bodyPr wrap="square" lIns="0" tIns="0" rIns="0" bIns="0" rtlCol="0" anchor="ctr"/>
+          <a:lstStyle/>
+          <a:p>
+            <a:pPr algn="ctr" indent="0" marL="0">
+              <a:buNone/>
+            </a:pPr>
+            <a:r>
+              <a:rPr lang="en-US" sz="3000" b="1" dirty="0">
+                <a:solidFill>
+                  <a:srgbClr val="17241D"/>
+                </a:solidFill>
+                <a:latin typeface="Arial" pitchFamily="34" charset="0"/>
+                <a:ea typeface="Arial" pitchFamily="34" charset="-122"/>
+                <a:cs typeface="Arial" pitchFamily="34" charset="-120"/>
+              </a:rPr>
+              <a:t>263M</a:t>
+            </a:r>
+            <a:endParaRPr lang="en-US" sz="3000" dirty="0"/>
+          </a:p>
+        </p:txBody>
+      </p:sp>
+      <p:sp>
+        <p:nvSpPr>
           <p:cNvPr id="9" name="Text 7"/>
           <p:cNvSpPr/>
           <p:nvPr/>
         </p:nvSpPr>
         <p:spPr>
           <a:xfrm>
-            <a:off x="411480" y="1819656"/>
-            <a:ext cx="2743200" cy="237744"/>
-          </a:xfrm>
-          <a:prstGeom prst="rect">
-            <a:avLst/>
-          </a:prstGeom>
-          <a:noFill/>
-          <a:ln/>
-        </p:spPr>
-        <p:txBody>
-          <a:bodyPr wrap="square" lIns="0" tIns="0" rIns="0" bIns="0" rtlCol="0" anchor="ctr"/>
-          <a:lstStyle/>
-          <a:p>
-            <a:pPr indent="0" marL="0">
-              <a:buNone/>
-            </a:pPr>
-            <a:r>
-              <a:rPr lang="en-US" sz="1100" b="1" dirty="0">
-                <a:solidFill>
-                  <a:srgbClr val="17241D"/>
-                </a:solidFill>
-                <a:latin typeface="Arial" pitchFamily="34" charset="0"/>
-                <a:ea typeface="Arial" pitchFamily="34" charset="-122"/>
-                <a:cs typeface="Arial" pitchFamily="34" charset="-120"/>
-              </a:rPr>
-              <a:t>Natural-language playlists</a:t>
-            </a:r>
-            <a:endParaRPr lang="en-US" sz="1100" dirty="0"/>
-          </a:p>
-        </p:txBody>
-      </p:sp>
-      <p:sp>
-        <p:nvSpPr>
-          <p:cNvPr id="10" name="Text 8"/>
-          <p:cNvSpPr/>
-          <p:nvPr/>
-        </p:nvSpPr>
-        <p:spPr>
-          <a:xfrm>
-            <a:off x="411480" y="2048256"/>
-            <a:ext cx="2743200" cy="201168"/>
-          </a:xfrm>
-          <a:prstGeom prst="rect">
-            <a:avLst/>
-          </a:prstGeom>
-          <a:noFill/>
-          <a:ln/>
-        </p:spPr>
-        <p:txBody>
-          <a:bodyPr wrap="square" lIns="0" tIns="0" rIns="0" bIns="0" rtlCol="0" anchor="ctr"/>
-          <a:lstStyle/>
-          <a:p>
-            <a:pPr indent="0" marL="0">
+            <a:off x="2578608" y="1591056"/>
+            <a:ext cx="1828800" cy="548640"/>
+          </a:xfrm>
+          <a:prstGeom prst="rect">
+            <a:avLst/>
+          </a:prstGeom>
+          <a:noFill/>
+          <a:ln/>
+        </p:spPr>
+        <p:txBody>
+          <a:bodyPr wrap="square" lIns="0" tIns="0" rIns="0" bIns="0" rtlCol="0" anchor="ctr"/>
+          <a:lstStyle/>
+          <a:p>
+            <a:pPr algn="ctr" indent="0" marL="0">
+              <a:lnSpc>
+                <a:spcPct val="100000"/>
+              </a:lnSpc>
               <a:buNone/>
             </a:pPr>
             <a:r>
@@ -5235,7 +4125,7 @@
                 <a:ea typeface="Arial" pitchFamily="34" charset="-122"/>
                 <a:cs typeface="Arial" pitchFamily="34" charset="-120"/>
               </a:rPr>
-              <a:t>AI DJ · Prompted Playlist</a:t>
+              <a:t>Premium subscribers</a:t>
             </a:r>
             <a:endParaRPr lang="en-US" sz="950" dirty="0"/>
           </a:p>
@@ -5243,18 +4133,600 @@
       </p:sp>
       <p:sp>
         <p:nvSpPr>
-          <p:cNvPr id="11" name="Shape 9"/>
-          <p:cNvSpPr/>
-          <p:nvPr/>
-        </p:nvSpPr>
-        <p:spPr>
-          <a:xfrm>
-            <a:off x="274320" y="2340864"/>
-            <a:ext cx="2971800" cy="493776"/>
+          <p:cNvPr id="10" name="Shape 8"/>
+          <p:cNvSpPr/>
+          <p:nvPr/>
+        </p:nvSpPr>
+        <p:spPr>
+          <a:xfrm>
+            <a:off x="4663440" y="960120"/>
+            <a:ext cx="2057400" cy="1234440"/>
           </a:xfrm>
           <a:prstGeom prst="roundRect">
             <a:avLst>
-              <a:gd name="adj" fmla="val 12963"/>
+              <a:gd name="adj" fmla="val 5185"/>
+            </a:avLst>
+          </a:prstGeom>
+          <a:solidFill>
+            <a:srgbClr val="FBE3DD"/>
+          </a:solidFill>
+          <a:ln w="12700">
+            <a:solidFill>
+              <a:srgbClr val="D8E5DC"/>
+            </a:solidFill>
+            <a:prstDash val="solid"/>
+          </a:ln>
+          <a:effectLst>
+            <a:outerShdw sx="100000" sy="100000" kx="0" ky="0" algn="bl" rotWithShape="0" blurRad="88900" dist="25400" dir="5400000">
+              <a:srgbClr val="6B6B6B">
+                <a:alpha val="22000"/>
+              </a:srgbClr>
+            </a:outerShdw>
+          </a:effectLst>
+        </p:spPr>
+      </p:sp>
+      <p:sp>
+        <p:nvSpPr>
+          <p:cNvPr id="11" name="Text 9"/>
+          <p:cNvSpPr/>
+          <p:nvPr/>
+        </p:nvSpPr>
+        <p:spPr>
+          <a:xfrm>
+            <a:off x="4754880" y="1060704"/>
+            <a:ext cx="1874520" cy="502920"/>
+          </a:xfrm>
+          <a:prstGeom prst="rect">
+            <a:avLst/>
+          </a:prstGeom>
+          <a:noFill/>
+          <a:ln/>
+        </p:spPr>
+        <p:txBody>
+          <a:bodyPr wrap="square" lIns="0" tIns="0" rIns="0" bIns="0" rtlCol="0" anchor="ctr"/>
+          <a:lstStyle/>
+          <a:p>
+            <a:pPr algn="ctr" indent="0" marL="0">
+              <a:buNone/>
+            </a:pPr>
+            <a:r>
+              <a:rPr lang="en-US" sz="3000" b="1" dirty="0">
+                <a:solidFill>
+                  <a:srgbClr val="17241D"/>
+                </a:solidFill>
+                <a:latin typeface="Arial" pitchFamily="34" charset="0"/>
+                <a:ea typeface="Arial" pitchFamily="34" charset="-122"/>
+                <a:cs typeface="Arial" pitchFamily="34" charset="-120"/>
+              </a:rPr>
+              <a:t>~30%</a:t>
+            </a:r>
+            <a:endParaRPr lang="en-US" sz="3000" dirty="0"/>
+          </a:p>
+        </p:txBody>
+      </p:sp>
+      <p:sp>
+        <p:nvSpPr>
+          <p:cNvPr id="12" name="Text 10"/>
+          <p:cNvSpPr/>
+          <p:nvPr/>
+        </p:nvSpPr>
+        <p:spPr>
+          <a:xfrm>
+            <a:off x="4773168" y="1591056"/>
+            <a:ext cx="1828800" cy="548640"/>
+          </a:xfrm>
+          <a:prstGeom prst="rect">
+            <a:avLst/>
+          </a:prstGeom>
+          <a:noFill/>
+          <a:ln/>
+        </p:spPr>
+        <p:txBody>
+          <a:bodyPr wrap="square" lIns="0" tIns="0" rIns="0" bIns="0" rtlCol="0" anchor="ctr"/>
+          <a:lstStyle/>
+          <a:p>
+            <a:pPr algn="ctr" indent="0" marL="0">
+              <a:lnSpc>
+                <a:spcPct val="100000"/>
+              </a:lnSpc>
+              <a:buNone/>
+            </a:pPr>
+            <a:r>
+              <a:rPr lang="en-US" sz="950" dirty="0">
+                <a:solidFill>
+                  <a:srgbClr val="5C6B62"/>
+                </a:solidFill>
+                <a:latin typeface="Arial" pitchFamily="34" charset="0"/>
+                <a:ea typeface="Arial" pitchFamily="34" charset="-122"/>
+                <a:cs typeface="Arial" pitchFamily="34" charset="-120"/>
+              </a:rPr>
+              <a:t>of listening is repeat / familiar</a:t>
+            </a:r>
+            <a:endParaRPr lang="en-US" sz="950" dirty="0"/>
+          </a:p>
+        </p:txBody>
+      </p:sp>
+      <p:sp>
+        <p:nvSpPr>
+          <p:cNvPr id="13" name="Shape 11"/>
+          <p:cNvSpPr/>
+          <p:nvPr/>
+        </p:nvSpPr>
+        <p:spPr>
+          <a:xfrm>
+            <a:off x="6858000" y="960120"/>
+            <a:ext cx="2057400" cy="1234440"/>
+          </a:xfrm>
+          <a:prstGeom prst="roundRect">
+            <a:avLst>
+              <a:gd name="adj" fmla="val 5185"/>
+            </a:avLst>
+          </a:prstGeom>
+          <a:solidFill>
+            <a:srgbClr val="FBE3DD"/>
+          </a:solidFill>
+          <a:ln w="12700">
+            <a:solidFill>
+              <a:srgbClr val="D8E5DC"/>
+            </a:solidFill>
+            <a:prstDash val="solid"/>
+          </a:ln>
+          <a:effectLst>
+            <a:outerShdw sx="100000" sy="100000" kx="0" ky="0" algn="bl" rotWithShape="0" blurRad="88900" dist="25400" dir="5400000">
+              <a:srgbClr val="6B6B6B">
+                <a:alpha val="22000"/>
+              </a:srgbClr>
+            </a:outerShdw>
+          </a:effectLst>
+        </p:spPr>
+      </p:sp>
+      <p:sp>
+        <p:nvSpPr>
+          <p:cNvPr id="14" name="Text 12"/>
+          <p:cNvSpPr/>
+          <p:nvPr/>
+        </p:nvSpPr>
+        <p:spPr>
+          <a:xfrm>
+            <a:off x="6949440" y="1060704"/>
+            <a:ext cx="1874520" cy="502920"/>
+          </a:xfrm>
+          <a:prstGeom prst="rect">
+            <a:avLst/>
+          </a:prstGeom>
+          <a:noFill/>
+          <a:ln/>
+        </p:spPr>
+        <p:txBody>
+          <a:bodyPr wrap="square" lIns="0" tIns="0" rIns="0" bIns="0" rtlCol="0" anchor="ctr"/>
+          <a:lstStyle/>
+          <a:p>
+            <a:pPr algn="ctr" indent="0" marL="0">
+              <a:buNone/>
+            </a:pPr>
+            <a:r>
+              <a:rPr lang="en-US" sz="3000" b="1" dirty="0">
+                <a:solidFill>
+                  <a:srgbClr val="17241D"/>
+                </a:solidFill>
+                <a:latin typeface="Arial" pitchFamily="34" charset="0"/>
+                <a:ea typeface="Arial" pitchFamily="34" charset="-122"/>
+                <a:cs typeface="Arial" pitchFamily="34" charset="-120"/>
+              </a:rPr>
+              <a:t>−12%</a:t>
+            </a:r>
+            <a:endParaRPr lang="en-US" sz="3000" dirty="0"/>
+          </a:p>
+        </p:txBody>
+      </p:sp>
+      <p:sp>
+        <p:nvSpPr>
+          <p:cNvPr id="15" name="Text 13"/>
+          <p:cNvSpPr/>
+          <p:nvPr/>
+        </p:nvSpPr>
+        <p:spPr>
+          <a:xfrm>
+            <a:off x="6967728" y="1591056"/>
+            <a:ext cx="1828800" cy="548640"/>
+          </a:xfrm>
+          <a:prstGeom prst="rect">
+            <a:avLst/>
+          </a:prstGeom>
+          <a:noFill/>
+          <a:ln/>
+        </p:spPr>
+        <p:txBody>
+          <a:bodyPr wrap="square" lIns="0" tIns="0" rIns="0" bIns="0" rtlCol="0" anchor="ctr"/>
+          <a:lstStyle/>
+          <a:p>
+            <a:pPr algn="ctr" indent="0" marL="0">
+              <a:lnSpc>
+                <a:spcPct val="100000"/>
+              </a:lnSpc>
+              <a:buNone/>
+            </a:pPr>
+            <a:r>
+              <a:rPr lang="en-US" sz="950" dirty="0">
+                <a:solidFill>
+                  <a:srgbClr val="5C6B62"/>
+                </a:solidFill>
+                <a:latin typeface="Arial" pitchFamily="34" charset="0"/>
+                <a:ea typeface="Arial" pitchFamily="34" charset="-122"/>
+                <a:cs typeface="Arial" pitchFamily="34" charset="-120"/>
+              </a:rPr>
+              <a:t>genre diversity in 6 mo · Discover Weekly (research)</a:t>
+            </a:r>
+            <a:endParaRPr lang="en-US" sz="950" dirty="0"/>
+          </a:p>
+        </p:txBody>
+      </p:sp>
+      <p:sp>
+        <p:nvSpPr>
+          <p:cNvPr id="16" name="Shape 14"/>
+          <p:cNvSpPr/>
+          <p:nvPr/>
+        </p:nvSpPr>
+        <p:spPr>
+          <a:xfrm>
+            <a:off x="274320" y="2331720"/>
+            <a:ext cx="5212080" cy="2286000"/>
+          </a:xfrm>
+          <a:prstGeom prst="roundRect">
+            <a:avLst>
+              <a:gd name="adj" fmla="val 2800"/>
+            </a:avLst>
+          </a:prstGeom>
+          <a:solidFill>
+            <a:srgbClr val="FFFFFF"/>
+          </a:solidFill>
+          <a:ln w="12700">
+            <a:solidFill>
+              <a:srgbClr val="D8E5DC"/>
+            </a:solidFill>
+            <a:prstDash val="solid"/>
+          </a:ln>
+          <a:effectLst>
+            <a:outerShdw sx="100000" sy="100000" kx="0" ky="0" algn="bl" rotWithShape="0" blurRad="88900" dist="25400" dir="5400000">
+              <a:srgbClr val="6B6B6B">
+                <a:alpha val="22000"/>
+              </a:srgbClr>
+            </a:outerShdw>
+          </a:effectLst>
+        </p:spPr>
+      </p:sp>
+      <p:sp>
+        <p:nvSpPr>
+          <p:cNvPr id="17" name="Text 15"/>
+          <p:cNvSpPr/>
+          <p:nvPr/>
+        </p:nvSpPr>
+        <p:spPr>
+          <a:xfrm>
+            <a:off x="457200" y="2450592"/>
+            <a:ext cx="4846320" cy="237744"/>
+          </a:xfrm>
+          <a:prstGeom prst="rect">
+            <a:avLst/>
+          </a:prstGeom>
+          <a:noFill/>
+          <a:ln/>
+        </p:spPr>
+        <p:txBody>
+          <a:bodyPr wrap="square" lIns="0" tIns="0" rIns="0" bIns="0" rtlCol="0" anchor="ctr"/>
+          <a:lstStyle/>
+          <a:p>
+            <a:pPr indent="0" marL="0">
+              <a:buNone/>
+            </a:pPr>
+            <a:r>
+              <a:rPr lang="en-US" sz="1000" b="1" spc="150" kern="0" dirty="0">
+                <a:solidFill>
+                  <a:srgbClr val="0E6B37"/>
+                </a:solidFill>
+                <a:latin typeface="Arial" pitchFamily="34" charset="0"/>
+                <a:ea typeface="Arial" pitchFamily="34" charset="-122"/>
+                <a:cs typeface="Arial" pitchFamily="34" charset="-120"/>
+              </a:rPr>
+              <a:t>THE DISCOVERY PARADOX</a:t>
+            </a:r>
+            <a:endParaRPr lang="en-US" sz="1000" dirty="0"/>
+          </a:p>
+        </p:txBody>
+      </p:sp>
+      <p:sp>
+        <p:nvSpPr>
+          <p:cNvPr id="18" name="Text 16"/>
+          <p:cNvSpPr/>
+          <p:nvPr/>
+        </p:nvSpPr>
+        <p:spPr>
+          <a:xfrm>
+            <a:off x="457200" y="2724912"/>
+            <a:ext cx="4937760" cy="548640"/>
+          </a:xfrm>
+          <a:prstGeom prst="rect">
+            <a:avLst/>
+          </a:prstGeom>
+          <a:noFill/>
+          <a:ln/>
+        </p:spPr>
+        <p:txBody>
+          <a:bodyPr wrap="square" lIns="0" tIns="0" rIns="0" bIns="0" rtlCol="0" anchor="ctr"/>
+          <a:lstStyle/>
+          <a:p>
+            <a:pPr indent="0" marL="0">
+              <a:lnSpc>
+                <a:spcPct val="108000"/>
+              </a:lnSpc>
+              <a:buNone/>
+            </a:pPr>
+            <a:r>
+              <a:rPr lang="en-US" sz="1150" dirty="0">
+                <a:solidFill>
+                  <a:srgbClr val="17241D"/>
+                </a:solidFill>
+                <a:latin typeface="Arial" pitchFamily="34" charset="0"/>
+                <a:ea typeface="Arial" pitchFamily="34" charset="-122"/>
+                <a:cs typeface="Arial" pitchFamily="34" charset="-120"/>
+              </a:rPr>
+              <a:t>Spotify owns one of the world's best recommenders — so the bottleneck was never finding new music. It's that engaged listeners won't act on it.</a:t>
+            </a:r>
+            <a:endParaRPr lang="en-US" sz="1150" dirty="0"/>
+          </a:p>
+        </p:txBody>
+      </p:sp>
+      <p:sp>
+        <p:nvSpPr>
+          <p:cNvPr id="19" name="Shape 17"/>
+          <p:cNvSpPr/>
+          <p:nvPr/>
+        </p:nvSpPr>
+        <p:spPr>
+          <a:xfrm>
+            <a:off x="502920" y="3346704"/>
+            <a:ext cx="137160" cy="137160"/>
+          </a:xfrm>
+          <a:prstGeom prst="ellipse">
+            <a:avLst/>
+          </a:prstGeom>
+          <a:solidFill>
+            <a:srgbClr val="1DB954"/>
+          </a:solidFill>
+          <a:ln/>
+        </p:spPr>
+      </p:sp>
+      <p:sp>
+        <p:nvSpPr>
+          <p:cNvPr id="20" name="Text 18"/>
+          <p:cNvSpPr/>
+          <p:nvPr/>
+        </p:nvSpPr>
+        <p:spPr>
+          <a:xfrm>
+            <a:off x="731520" y="3264408"/>
+            <a:ext cx="4663440" cy="384048"/>
+          </a:xfrm>
+          <a:prstGeom prst="rect">
+            <a:avLst/>
+          </a:prstGeom>
+          <a:noFill/>
+          <a:ln/>
+        </p:spPr>
+        <p:txBody>
+          <a:bodyPr wrap="square" lIns="0" tIns="0" rIns="0" bIns="0" rtlCol="0" anchor="ctr"/>
+          <a:lstStyle/>
+          <a:p>
+            <a:pPr indent="0" marL="0">
+              <a:lnSpc>
+                <a:spcPct val="108000"/>
+              </a:lnSpc>
+              <a:buNone/>
+            </a:pPr>
+            <a:r>
+              <a:rPr lang="en-US" sz="1100" b="1" dirty="0">
+                <a:solidFill>
+                  <a:srgbClr val="17241D"/>
+                </a:solidFill>
+                <a:latin typeface="Arial" pitchFamily="34" charset="0"/>
+                <a:ea typeface="Arial" pitchFamily="34" charset="-122"/>
+                <a:cs typeface="Arial" pitchFamily="34" charset="-120"/>
+              </a:rPr>
+              <a:t>Algorithm exploits familiarity — </a:t>
+            </a:r>
+            <a:pPr indent="0" marL="0">
+              <a:lnSpc>
+                <a:spcPct val="108000"/>
+              </a:lnSpc>
+              <a:buNone/>
+            </a:pPr>
+            <a:r>
+              <a:rPr lang="en-US" sz="1100" dirty="0">
+                <a:solidFill>
+                  <a:srgbClr val="5C6B62"/>
+                </a:solidFill>
+                <a:latin typeface="Arial" pitchFamily="34" charset="0"/>
+                <a:ea typeface="Arial" pitchFamily="34" charset="-122"/>
+                <a:cs typeface="Arial" pitchFamily="34" charset="-120"/>
+              </a:rPr>
+              <a:t>the more you listen, the tighter the loop</a:t>
+            </a:r>
+            <a:endParaRPr lang="en-US" sz="1100" dirty="0"/>
+          </a:p>
+        </p:txBody>
+      </p:sp>
+      <p:sp>
+        <p:nvSpPr>
+          <p:cNvPr id="21" name="Shape 19"/>
+          <p:cNvSpPr/>
+          <p:nvPr/>
+        </p:nvSpPr>
+        <p:spPr>
+          <a:xfrm>
+            <a:off x="502920" y="3767328"/>
+            <a:ext cx="137160" cy="137160"/>
+          </a:xfrm>
+          <a:prstGeom prst="ellipse">
+            <a:avLst/>
+          </a:prstGeom>
+          <a:solidFill>
+            <a:srgbClr val="1DB954"/>
+          </a:solidFill>
+          <a:ln/>
+        </p:spPr>
+      </p:sp>
+      <p:sp>
+        <p:nvSpPr>
+          <p:cNvPr id="22" name="Text 20"/>
+          <p:cNvSpPr/>
+          <p:nvPr/>
+        </p:nvSpPr>
+        <p:spPr>
+          <a:xfrm>
+            <a:off x="731520" y="3685032"/>
+            <a:ext cx="4663440" cy="384048"/>
+          </a:xfrm>
+          <a:prstGeom prst="rect">
+            <a:avLst/>
+          </a:prstGeom>
+          <a:noFill/>
+          <a:ln/>
+        </p:spPr>
+        <p:txBody>
+          <a:bodyPr wrap="square" lIns="0" tIns="0" rIns="0" bIns="0" rtlCol="0" anchor="ctr"/>
+          <a:lstStyle/>
+          <a:p>
+            <a:pPr indent="0" marL="0">
+              <a:lnSpc>
+                <a:spcPct val="108000"/>
+              </a:lnSpc>
+              <a:buNone/>
+            </a:pPr>
+            <a:r>
+              <a:rPr lang="en-US" sz="1100" b="1" dirty="0">
+                <a:solidFill>
+                  <a:srgbClr val="17241D"/>
+                </a:solidFill>
+                <a:latin typeface="Arial" pitchFamily="34" charset="0"/>
+                <a:ea typeface="Arial" pitchFamily="34" charset="-122"/>
+                <a:cs typeface="Arial" pitchFamily="34" charset="-120"/>
+              </a:rPr>
+              <a:t>Unfamiliar = unrewarded — </a:t>
+            </a:r>
+            <a:pPr indent="0" marL="0">
+              <a:lnSpc>
+                <a:spcPct val="108000"/>
+              </a:lnSpc>
+              <a:buNone/>
+            </a:pPr>
+            <a:r>
+              <a:rPr lang="en-US" sz="1100" dirty="0">
+                <a:solidFill>
+                  <a:srgbClr val="5C6B62"/>
+                </a:solidFill>
+                <a:latin typeface="Arial" pitchFamily="34" charset="0"/>
+                <a:ea typeface="Arial" pitchFamily="34" charset="-122"/>
+                <a:cs typeface="Arial" pitchFamily="34" charset="-120"/>
+              </a:rPr>
+              <a:t>no reason to trust a new pick, so users skip</a:t>
+            </a:r>
+            <a:endParaRPr lang="en-US" sz="1100" dirty="0"/>
+          </a:p>
+        </p:txBody>
+      </p:sp>
+      <p:sp>
+        <p:nvSpPr>
+          <p:cNvPr id="23" name="Shape 21"/>
+          <p:cNvSpPr/>
+          <p:nvPr/>
+        </p:nvSpPr>
+        <p:spPr>
+          <a:xfrm>
+            <a:off x="502920" y="4187952"/>
+            <a:ext cx="137160" cy="137160"/>
+          </a:xfrm>
+          <a:prstGeom prst="ellipse">
+            <a:avLst/>
+          </a:prstGeom>
+          <a:solidFill>
+            <a:srgbClr val="1DB954"/>
+          </a:solidFill>
+          <a:ln/>
+        </p:spPr>
+      </p:sp>
+      <p:sp>
+        <p:nvSpPr>
+          <p:cNvPr id="24" name="Text 22"/>
+          <p:cNvSpPr/>
+          <p:nvPr/>
+        </p:nvSpPr>
+        <p:spPr>
+          <a:xfrm>
+            <a:off x="731520" y="4105656"/>
+            <a:ext cx="4663440" cy="384048"/>
+          </a:xfrm>
+          <a:prstGeom prst="rect">
+            <a:avLst/>
+          </a:prstGeom>
+          <a:noFill/>
+          <a:ln/>
+        </p:spPr>
+        <p:txBody>
+          <a:bodyPr wrap="square" lIns="0" tIns="0" rIns="0" bIns="0" rtlCol="0" anchor="ctr"/>
+          <a:lstStyle/>
+          <a:p>
+            <a:pPr indent="0" marL="0">
+              <a:lnSpc>
+                <a:spcPct val="108000"/>
+              </a:lnSpc>
+              <a:buNone/>
+            </a:pPr>
+            <a:r>
+              <a:rPr lang="en-US" sz="1100" b="1" dirty="0">
+                <a:solidFill>
+                  <a:srgbClr val="17241D"/>
+                </a:solidFill>
+                <a:latin typeface="Arial" pitchFamily="34" charset="0"/>
+                <a:ea typeface="Arial" pitchFamily="34" charset="-122"/>
+                <a:cs typeface="Arial" pitchFamily="34" charset="-120"/>
+              </a:rPr>
+              <a:t>Loyalty backfires — </a:t>
+            </a:r>
+            <a:pPr indent="0" marL="0">
+              <a:lnSpc>
+                <a:spcPct val="108000"/>
+              </a:lnSpc>
+              <a:buNone/>
+            </a:pPr>
+            <a:r>
+              <a:rPr lang="en-US" sz="1100" dirty="0">
+                <a:solidFill>
+                  <a:srgbClr val="5C6B62"/>
+                </a:solidFill>
+                <a:latin typeface="Arial" pitchFamily="34" charset="0"/>
+                <a:ea typeface="Arial" pitchFamily="34" charset="-122"/>
+                <a:cs typeface="Arial" pitchFamily="34" charset="-120"/>
+              </a:rPr>
+              <a:t>heaviest users get the stalest discovery</a:t>
+            </a:r>
+            <a:endParaRPr lang="en-US" sz="1100" dirty="0"/>
+          </a:p>
+        </p:txBody>
+      </p:sp>
+      <p:sp>
+        <p:nvSpPr>
+          <p:cNvPr id="25" name="Shape 23"/>
+          <p:cNvSpPr/>
+          <p:nvPr/>
+        </p:nvSpPr>
+        <p:spPr>
+          <a:xfrm>
+            <a:off x="5669280" y="2331720"/>
+            <a:ext cx="3200400" cy="2286000"/>
+          </a:xfrm>
+          <a:prstGeom prst="roundRect">
+            <a:avLst>
+              <a:gd name="adj" fmla="val 2800"/>
             </a:avLst>
           </a:prstGeom>
           <a:solidFill>
@@ -5277,14 +4749,14 @@
       </p:sp>
       <p:sp>
         <p:nvSpPr>
-          <p:cNvPr id="12" name="Text 10"/>
-          <p:cNvSpPr/>
-          <p:nvPr/>
-        </p:nvSpPr>
-        <p:spPr>
-          <a:xfrm>
-            <a:off x="411480" y="2386584"/>
-            <a:ext cx="2743200" cy="237744"/>
+          <p:cNvPr id="26" name="Text 24"/>
+          <p:cNvSpPr/>
+          <p:nvPr/>
+        </p:nvSpPr>
+        <p:spPr>
+          <a:xfrm>
+            <a:off x="5852160" y="2450592"/>
+            <a:ext cx="2834640" cy="237744"/>
           </a:xfrm>
           <a:prstGeom prst="rect">
             <a:avLst/>
@@ -5300,7 +4772,49 @@
               <a:buNone/>
             </a:pPr>
             <a:r>
-              <a:rPr lang="en-US" sz="1100" b="1" dirty="0">
+              <a:rPr lang="en-US" sz="1000" b="1" spc="150" kern="0" dirty="0">
+                <a:solidFill>
+                  <a:srgbClr val="0E6B37"/>
+                </a:solidFill>
+                <a:latin typeface="Arial" pitchFamily="34" charset="0"/>
+                <a:ea typeface="Arial" pitchFamily="34" charset="-122"/>
+                <a:cs typeface="Arial" pitchFamily="34" charset="-120"/>
+              </a:rPr>
+              <a:t>WHAT'S MISSING</a:t>
+            </a:r>
+            <a:endParaRPr lang="en-US" sz="1000" dirty="0"/>
+          </a:p>
+        </p:txBody>
+      </p:sp>
+      <p:sp>
+        <p:nvSpPr>
+          <p:cNvPr id="27" name="Text 25"/>
+          <p:cNvSpPr/>
+          <p:nvPr/>
+        </p:nvSpPr>
+        <p:spPr>
+          <a:xfrm>
+            <a:off x="5852160" y="2743200"/>
+            <a:ext cx="2880360" cy="1280160"/>
+          </a:xfrm>
+          <a:prstGeom prst="rect">
+            <a:avLst/>
+          </a:prstGeom>
+          <a:noFill/>
+          <a:ln/>
+        </p:spPr>
+        <p:txBody>
+          <a:bodyPr wrap="square" lIns="0" tIns="0" rIns="0" bIns="0" rtlCol="0" anchor="ctr"/>
+          <a:lstStyle/>
+          <a:p>
+            <a:pPr indent="0" marL="0">
+              <a:lnSpc>
+                <a:spcPct val="112000"/>
+              </a:lnSpc>
+              <a:buNone/>
+            </a:pPr>
+            <a:r>
+              <a:rPr lang="en-US" sz="1200" dirty="0">
                 <a:solidFill>
                   <a:srgbClr val="17241D"/>
                 </a:solidFill>
@@ -5308,431 +4822,22 @@
                 <a:ea typeface="Arial" pitchFamily="34" charset="-122"/>
                 <a:cs typeface="Arial" pitchFamily="34" charset="-120"/>
               </a:rPr>
-              <a:t>Song context / credits</a:t>
-            </a:r>
-            <a:endParaRPr lang="en-US" sz="1100" dirty="0"/>
-          </a:p>
-        </p:txBody>
-      </p:sp>
-      <p:sp>
-        <p:nvSpPr>
-          <p:cNvPr id="13" name="Text 11"/>
-          <p:cNvSpPr/>
-          <p:nvPr/>
-        </p:nvSpPr>
-        <p:spPr>
-          <a:xfrm>
-            <a:off x="411480" y="2615184"/>
-            <a:ext cx="2743200" cy="201168"/>
-          </a:xfrm>
-          <a:prstGeom prst="rect">
-            <a:avLst/>
-          </a:prstGeom>
-          <a:noFill/>
-          <a:ln/>
-        </p:spPr>
-        <p:txBody>
-          <a:bodyPr wrap="square" lIns="0" tIns="0" rIns="0" bIns="0" rtlCol="0" anchor="ctr"/>
-          <a:lstStyle/>
-          <a:p>
-            <a:pPr indent="0" marL="0">
-              <a:buNone/>
-            </a:pPr>
-            <a:r>
-              <a:rPr lang="en-US" sz="950" dirty="0">
-                <a:solidFill>
-                  <a:srgbClr val="5C6B62"/>
-                </a:solidFill>
-                <a:latin typeface="Arial" pitchFamily="34" charset="0"/>
-                <a:ea typeface="Arial" pitchFamily="34" charset="-122"/>
-                <a:cs typeface="Arial" pitchFamily="34" charset="-120"/>
-              </a:rPr>
-              <a:t>SongDNA</a:t>
-            </a:r>
-            <a:endParaRPr lang="en-US" sz="950" dirty="0"/>
-          </a:p>
-        </p:txBody>
-      </p:sp>
-      <p:sp>
-        <p:nvSpPr>
-          <p:cNvPr id="14" name="Text 12"/>
-          <p:cNvSpPr/>
-          <p:nvPr/>
-        </p:nvSpPr>
-        <p:spPr>
-          <a:xfrm>
-            <a:off x="274320" y="3017520"/>
-            <a:ext cx="2926080" cy="237744"/>
-          </a:xfrm>
-          <a:prstGeom prst="rect">
-            <a:avLst/>
-          </a:prstGeom>
-          <a:noFill/>
-          <a:ln/>
-        </p:spPr>
-        <p:txBody>
-          <a:bodyPr wrap="square" lIns="0" tIns="0" rIns="0" bIns="0" rtlCol="0" anchor="ctr"/>
-          <a:lstStyle/>
-          <a:p>
-            <a:pPr indent="0" marL="0">
-              <a:buNone/>
-            </a:pPr>
-            <a:r>
-              <a:rPr lang="en-US" sz="1000" b="1" spc="150" kern="0" dirty="0">
-                <a:solidFill>
-                  <a:srgbClr val="0E6B37"/>
-                </a:solidFill>
-                <a:latin typeface="Arial" pitchFamily="34" charset="0"/>
-                <a:ea typeface="Arial" pitchFamily="34" charset="-122"/>
-                <a:cs typeface="Arial" pitchFamily="34" charset="-120"/>
-              </a:rPr>
-              <a:t>WHAT NOBODY SOLVED</a:t>
-            </a:r>
-            <a:endParaRPr lang="en-US" sz="1000" dirty="0"/>
-          </a:p>
-        </p:txBody>
-      </p:sp>
-      <p:sp>
-        <p:nvSpPr>
-          <p:cNvPr id="15" name="Shape 13"/>
-          <p:cNvSpPr/>
-          <p:nvPr/>
-        </p:nvSpPr>
-        <p:spPr>
-          <a:xfrm>
-            <a:off x="274320" y="3291840"/>
-            <a:ext cx="2971800" cy="365760"/>
-          </a:xfrm>
-          <a:prstGeom prst="roundRect">
-            <a:avLst>
-              <a:gd name="adj" fmla="val 17500"/>
-            </a:avLst>
-          </a:prstGeom>
-          <a:solidFill>
-            <a:srgbClr val="FBE3DD"/>
-          </a:solidFill>
-          <a:ln w="12700">
-            <a:solidFill>
-              <a:srgbClr val="D8E5DC"/>
-            </a:solidFill>
-            <a:prstDash val="solid"/>
-          </a:ln>
-          <a:effectLst>
-            <a:outerShdw sx="100000" sy="100000" kx="0" ky="0" algn="bl" rotWithShape="0" blurRad="88900" dist="25400" dir="5400000">
-              <a:srgbClr val="6B6B6B">
-                <a:alpha val="22000"/>
-              </a:srgbClr>
-            </a:outerShdw>
-          </a:effectLst>
-        </p:spPr>
-      </p:sp>
-      <p:sp>
-        <p:nvSpPr>
-          <p:cNvPr id="16" name="Text 14"/>
-          <p:cNvSpPr/>
-          <p:nvPr/>
-        </p:nvSpPr>
-        <p:spPr>
-          <a:xfrm>
-            <a:off x="411480" y="3319272"/>
-            <a:ext cx="2743200" cy="310896"/>
-          </a:xfrm>
-          <a:prstGeom prst="rect">
-            <a:avLst/>
-          </a:prstGeom>
-          <a:noFill/>
-          <a:ln/>
-        </p:spPr>
-        <p:txBody>
-          <a:bodyPr wrap="square" lIns="0" tIns="0" rIns="0" bIns="0" rtlCol="0" anchor="ctr"/>
-          <a:lstStyle/>
-          <a:p>
-            <a:pPr indent="0" marL="0">
-              <a:buNone/>
-            </a:pPr>
-            <a:r>
-              <a:rPr lang="en-US" sz="1050" b="1" dirty="0">
-                <a:solidFill>
-                  <a:srgbClr val="17241D"/>
-                </a:solidFill>
-                <a:latin typeface="Arial" pitchFamily="34" charset="0"/>
-                <a:ea typeface="Arial" pitchFamily="34" charset="-122"/>
-                <a:cs typeface="Arial" pitchFamily="34" charset="-120"/>
-              </a:rPr>
-              <a:t>✗  A reason to TRY the unfamiliar</a:t>
-            </a:r>
-            <a:endParaRPr lang="en-US" sz="1050" dirty="0"/>
-          </a:p>
-        </p:txBody>
-      </p:sp>
-      <p:sp>
-        <p:nvSpPr>
-          <p:cNvPr id="17" name="Shape 15"/>
-          <p:cNvSpPr/>
-          <p:nvPr/>
-        </p:nvSpPr>
-        <p:spPr>
-          <a:xfrm>
-            <a:off x="274320" y="3712464"/>
-            <a:ext cx="2971800" cy="365760"/>
-          </a:xfrm>
-          <a:prstGeom prst="roundRect">
-            <a:avLst>
-              <a:gd name="adj" fmla="val 17500"/>
-            </a:avLst>
-          </a:prstGeom>
-          <a:solidFill>
-            <a:srgbClr val="FBE3DD"/>
-          </a:solidFill>
-          <a:ln w="12700">
-            <a:solidFill>
-              <a:srgbClr val="D8E5DC"/>
-            </a:solidFill>
-            <a:prstDash val="solid"/>
-          </a:ln>
-          <a:effectLst>
-            <a:outerShdw sx="100000" sy="100000" kx="0" ky="0" algn="bl" rotWithShape="0" blurRad="88900" dist="25400" dir="5400000">
-              <a:srgbClr val="6B6B6B">
-                <a:alpha val="22000"/>
-              </a:srgbClr>
-            </a:outerShdw>
-          </a:effectLst>
-        </p:spPr>
-      </p:sp>
-      <p:sp>
-        <p:nvSpPr>
-          <p:cNvPr id="18" name="Text 16"/>
-          <p:cNvSpPr/>
-          <p:nvPr/>
-        </p:nvSpPr>
-        <p:spPr>
-          <a:xfrm>
-            <a:off x="411480" y="3739896"/>
-            <a:ext cx="2743200" cy="310896"/>
-          </a:xfrm>
-          <a:prstGeom prst="rect">
-            <a:avLst/>
-          </a:prstGeom>
-          <a:noFill/>
-          <a:ln/>
-        </p:spPr>
-        <p:txBody>
-          <a:bodyPr wrap="square" lIns="0" tIns="0" rIns="0" bIns="0" rtlCol="0" anchor="ctr"/>
-          <a:lstStyle/>
-          <a:p>
-            <a:pPr indent="0" marL="0">
-              <a:buNone/>
-            </a:pPr>
-            <a:r>
-              <a:rPr lang="en-US" sz="1050" b="1" dirty="0">
-                <a:solidFill>
-                  <a:srgbClr val="17241D"/>
-                </a:solidFill>
-                <a:latin typeface="Arial" pitchFamily="34" charset="0"/>
-                <a:ea typeface="Arial" pitchFamily="34" charset="-122"/>
-                <a:cs typeface="Arial" pitchFamily="34" charset="-120"/>
-              </a:rPr>
-              <a:t>✗  Trust in a brand-new rec</a:t>
-            </a:r>
-            <a:endParaRPr lang="en-US" sz="1050" dirty="0"/>
-          </a:p>
-        </p:txBody>
-      </p:sp>
-      <p:sp>
-        <p:nvSpPr>
-          <p:cNvPr id="19" name="Shape 17"/>
-          <p:cNvSpPr/>
-          <p:nvPr/>
-        </p:nvSpPr>
-        <p:spPr>
-          <a:xfrm>
-            <a:off x="274320" y="4133088"/>
-            <a:ext cx="2971800" cy="365760"/>
-          </a:xfrm>
-          <a:prstGeom prst="roundRect">
-            <a:avLst>
-              <a:gd name="adj" fmla="val 17500"/>
-            </a:avLst>
-          </a:prstGeom>
-          <a:solidFill>
-            <a:srgbClr val="FBE3DD"/>
-          </a:solidFill>
-          <a:ln w="12700">
-            <a:solidFill>
-              <a:srgbClr val="D8E5DC"/>
-            </a:solidFill>
-            <a:prstDash val="solid"/>
-          </a:ln>
-          <a:effectLst>
-            <a:outerShdw sx="100000" sy="100000" kx="0" ky="0" algn="bl" rotWithShape="0" blurRad="88900" dist="25400" dir="5400000">
-              <a:srgbClr val="6B6B6B">
-                <a:alpha val="22000"/>
-              </a:srgbClr>
-            </a:outerShdw>
-          </a:effectLst>
-        </p:spPr>
-      </p:sp>
-      <p:sp>
-        <p:nvSpPr>
-          <p:cNvPr id="20" name="Text 18"/>
-          <p:cNvSpPr/>
-          <p:nvPr/>
-        </p:nvSpPr>
-        <p:spPr>
-          <a:xfrm>
-            <a:off x="411480" y="4160520"/>
-            <a:ext cx="2743200" cy="310896"/>
-          </a:xfrm>
-          <a:prstGeom prst="rect">
-            <a:avLst/>
-          </a:prstGeom>
-          <a:noFill/>
-          <a:ln/>
-        </p:spPr>
-        <p:txBody>
-          <a:bodyPr wrap="square" lIns="0" tIns="0" rIns="0" bIns="0" rtlCol="0" anchor="ctr"/>
-          <a:lstStyle/>
-          <a:p>
-            <a:pPr indent="0" marL="0">
-              <a:buNone/>
-            </a:pPr>
-            <a:r>
-              <a:rPr lang="en-US" sz="1050" b="1" dirty="0">
-                <a:solidFill>
-                  <a:srgbClr val="17241D"/>
-                </a:solidFill>
-                <a:latin typeface="Arial" pitchFamily="34" charset="0"/>
-                <a:ea typeface="Arial" pitchFamily="34" charset="-122"/>
-                <a:cs typeface="Arial" pitchFamily="34" charset="-120"/>
-              </a:rPr>
-              <a:t>✗  Why THIS song, for YOU</a:t>
-            </a:r>
-            <a:endParaRPr lang="en-US" sz="1050" dirty="0"/>
-          </a:p>
-        </p:txBody>
-      </p:sp>
-      <p:sp>
-        <p:nvSpPr>
-          <p:cNvPr id="21" name="Text 19"/>
-          <p:cNvSpPr/>
-          <p:nvPr/>
-        </p:nvSpPr>
-        <p:spPr>
-          <a:xfrm>
-            <a:off x="3429000" y="932688"/>
-            <a:ext cx="2651760" cy="237744"/>
-          </a:xfrm>
-          <a:prstGeom prst="rect">
-            <a:avLst/>
-          </a:prstGeom>
-          <a:noFill/>
-          <a:ln/>
-        </p:spPr>
-        <p:txBody>
-          <a:bodyPr wrap="square" lIns="0" tIns="0" rIns="0" bIns="0" rtlCol="0" anchor="ctr"/>
-          <a:lstStyle/>
-          <a:p>
-            <a:pPr indent="0" marL="0">
-              <a:buNone/>
-            </a:pPr>
-            <a:r>
-              <a:rPr lang="en-US" sz="1000" b="1" spc="150" kern="0" dirty="0">
-                <a:solidFill>
-                  <a:srgbClr val="0E6B37"/>
-                </a:solidFill>
-                <a:latin typeface="Arial" pitchFamily="34" charset="0"/>
-                <a:ea typeface="Arial" pitchFamily="34" charset="-122"/>
-                <a:cs typeface="Arial" pitchFamily="34" charset="-120"/>
-              </a:rPr>
-              <a:t>WHY EACH EXISTING FIX FALLS SHORT</a:t>
-            </a:r>
-            <a:endParaRPr lang="en-US" sz="1000" dirty="0"/>
-          </a:p>
-        </p:txBody>
-      </p:sp>
-      <p:sp>
-        <p:nvSpPr>
-          <p:cNvPr id="22" name="Shape 20"/>
-          <p:cNvSpPr/>
-          <p:nvPr/>
-        </p:nvSpPr>
-        <p:spPr>
-          <a:xfrm>
-            <a:off x="3429000" y="1207008"/>
-            <a:ext cx="2651760" cy="822960"/>
-          </a:xfrm>
-          <a:prstGeom prst="roundRect">
-            <a:avLst>
-              <a:gd name="adj" fmla="val 7778"/>
-            </a:avLst>
-          </a:prstGeom>
-          <a:solidFill>
-            <a:srgbClr val="FFFFFF"/>
-          </a:solidFill>
-          <a:ln w="12700">
-            <a:solidFill>
-              <a:srgbClr val="D8E5DC"/>
-            </a:solidFill>
-            <a:prstDash val="solid"/>
-          </a:ln>
-          <a:effectLst>
-            <a:outerShdw sx="100000" sy="100000" kx="0" ky="0" algn="bl" rotWithShape="0" blurRad="88900" dist="25400" dir="5400000">
-              <a:srgbClr val="6B6B6B">
-                <a:alpha val="22000"/>
-              </a:srgbClr>
-            </a:outerShdw>
-          </a:effectLst>
-        </p:spPr>
-      </p:sp>
-      <p:sp>
-        <p:nvSpPr>
-          <p:cNvPr id="23" name="Text 21"/>
-          <p:cNvSpPr/>
-          <p:nvPr/>
-        </p:nvSpPr>
-        <p:spPr>
-          <a:xfrm>
-            <a:off x="3566160" y="1280160"/>
-            <a:ext cx="2395728" cy="256032"/>
-          </a:xfrm>
-          <a:prstGeom prst="rect">
-            <a:avLst/>
-          </a:prstGeom>
-          <a:noFill/>
-          <a:ln/>
-        </p:spPr>
-        <p:txBody>
-          <a:bodyPr wrap="square" lIns="0" tIns="0" rIns="0" bIns="0" rtlCol="0" anchor="ctr"/>
-          <a:lstStyle/>
-          <a:p>
-            <a:pPr indent="0" marL="0">
-              <a:buNone/>
-            </a:pPr>
-            <a:r>
-              <a:rPr lang="en-US" sz="1100" b="1" dirty="0">
-                <a:solidFill>
-                  <a:srgbClr val="17241D"/>
-                </a:solidFill>
-                <a:latin typeface="Arial" pitchFamily="34" charset="0"/>
-                <a:ea typeface="Arial" pitchFamily="34" charset="-122"/>
-                <a:cs typeface="Arial" pitchFamily="34" charset="-120"/>
-              </a:rPr>
-              <a:t>Discover Weekly / Daylist</a:t>
-            </a:r>
-            <a:endParaRPr lang="en-US" sz="1100" dirty="0"/>
-          </a:p>
-        </p:txBody>
-      </p:sp>
-      <p:sp>
-        <p:nvSpPr>
-          <p:cNvPr id="24" name="Text 22"/>
-          <p:cNvSpPr/>
-          <p:nvPr/>
-        </p:nvSpPr>
-        <p:spPr>
-          <a:xfrm>
-            <a:off x="3566160" y="1536192"/>
-            <a:ext cx="2395728" cy="457200"/>
+              <a:t>Discover Weekly, AI DJ, SongDNA — every fix improves WHAT to recommend. None built the acceptance layer: a reason to press play on the unfamiliar.</a:t>
+            </a:r>
+            <a:endParaRPr lang="en-US" sz="1200" dirty="0"/>
+          </a:p>
+        </p:txBody>
+      </p:sp>
+      <p:sp>
+        <p:nvSpPr>
+          <p:cNvPr id="28" name="Text 26"/>
+          <p:cNvSpPr/>
+          <p:nvPr/>
+        </p:nvSpPr>
+        <p:spPr>
+          <a:xfrm>
+            <a:off x="5852160" y="4114800"/>
+            <a:ext cx="2880360" cy="411480"/>
           </a:xfrm>
           <a:prstGeom prst="rect">
             <a:avLst/>
@@ -5751,310 +4856,7 @@
               <a:buNone/>
             </a:pPr>
             <a:r>
-              <a:rPr lang="en-US" sz="950" dirty="0">
-                <a:solidFill>
-                  <a:srgbClr val="5C6B62"/>
-                </a:solidFill>
-                <a:latin typeface="Arial" pitchFamily="34" charset="0"/>
-                <a:ea typeface="Arial" pitchFamily="34" charset="-122"/>
-                <a:cs typeface="Arial" pitchFamily="34" charset="-120"/>
-              </a:rPr>
-              <a:t>Personalizes you into a tighter loop — diversity drops over time.</a:t>
-            </a:r>
-            <a:endParaRPr lang="en-US" sz="950" dirty="0"/>
-          </a:p>
-        </p:txBody>
-      </p:sp>
-      <p:sp>
-        <p:nvSpPr>
-          <p:cNvPr id="25" name="Shape 23"/>
-          <p:cNvSpPr/>
-          <p:nvPr/>
-        </p:nvSpPr>
-        <p:spPr>
-          <a:xfrm>
-            <a:off x="3429000" y="2121408"/>
-            <a:ext cx="2651760" cy="822960"/>
-          </a:xfrm>
-          <a:prstGeom prst="roundRect">
-            <a:avLst>
-              <a:gd name="adj" fmla="val 7778"/>
-            </a:avLst>
-          </a:prstGeom>
-          <a:solidFill>
-            <a:srgbClr val="FFFFFF"/>
-          </a:solidFill>
-          <a:ln w="12700">
-            <a:solidFill>
-              <a:srgbClr val="D8E5DC"/>
-            </a:solidFill>
-            <a:prstDash val="solid"/>
-          </a:ln>
-          <a:effectLst>
-            <a:outerShdw sx="100000" sy="100000" kx="0" ky="0" algn="bl" rotWithShape="0" blurRad="88900" dist="25400" dir="5400000">
-              <a:srgbClr val="6B6B6B">
-                <a:alpha val="22000"/>
-              </a:srgbClr>
-            </a:outerShdw>
-          </a:effectLst>
-        </p:spPr>
-      </p:sp>
-      <p:sp>
-        <p:nvSpPr>
-          <p:cNvPr id="26" name="Text 24"/>
-          <p:cNvSpPr/>
-          <p:nvPr/>
-        </p:nvSpPr>
-        <p:spPr>
-          <a:xfrm>
-            <a:off x="3566160" y="2194560"/>
-            <a:ext cx="2395728" cy="256032"/>
-          </a:xfrm>
-          <a:prstGeom prst="rect">
-            <a:avLst/>
-          </a:prstGeom>
-          <a:noFill/>
-          <a:ln/>
-        </p:spPr>
-        <p:txBody>
-          <a:bodyPr wrap="square" lIns="0" tIns="0" rIns="0" bIns="0" rtlCol="0" anchor="ctr"/>
-          <a:lstStyle/>
-          <a:p>
-            <a:pPr indent="0" marL="0">
-              <a:buNone/>
-            </a:pPr>
-            <a:r>
-              <a:rPr lang="en-US" sz="1100" b="1" dirty="0">
-                <a:solidFill>
-                  <a:srgbClr val="17241D"/>
-                </a:solidFill>
-                <a:latin typeface="Arial" pitchFamily="34" charset="0"/>
-                <a:ea typeface="Arial" pitchFamily="34" charset="-122"/>
-                <a:cs typeface="Arial" pitchFamily="34" charset="-120"/>
-              </a:rPr>
-              <a:t>AI DJ / Prompted Playlist</a:t>
-            </a:r>
-            <a:endParaRPr lang="en-US" sz="1100" dirty="0"/>
-          </a:p>
-        </p:txBody>
-      </p:sp>
-      <p:sp>
-        <p:nvSpPr>
-          <p:cNvPr id="27" name="Text 25"/>
-          <p:cNvSpPr/>
-          <p:nvPr/>
-        </p:nvSpPr>
-        <p:spPr>
-          <a:xfrm>
-            <a:off x="3566160" y="2450592"/>
-            <a:ext cx="2395728" cy="457200"/>
-          </a:xfrm>
-          <a:prstGeom prst="rect">
-            <a:avLst/>
-          </a:prstGeom>
-          <a:noFill/>
-          <a:ln/>
-        </p:spPr>
-        <p:txBody>
-          <a:bodyPr wrap="square" lIns="0" tIns="0" rIns="0" bIns="0" rtlCol="0" anchor="ctr"/>
-          <a:lstStyle/>
-          <a:p>
-            <a:pPr indent="0" marL="0">
-              <a:lnSpc>
-                <a:spcPct val="105000"/>
-              </a:lnSpc>
-              <a:buNone/>
-            </a:pPr>
-            <a:r>
-              <a:rPr lang="en-US" sz="950" dirty="0">
-                <a:solidFill>
-                  <a:srgbClr val="5C6B62"/>
-                </a:solidFill>
-                <a:latin typeface="Arial" pitchFamily="34" charset="0"/>
-                <a:ea typeface="Arial" pitchFamily="34" charset="-122"/>
-                <a:cs typeface="Arial" pitchFamily="34" charset="-120"/>
-              </a:rPr>
-              <a:t>Lets you ask, but still just serves — generic, not personal to your history.</a:t>
-            </a:r>
-            <a:endParaRPr lang="en-US" sz="950" dirty="0"/>
-          </a:p>
-        </p:txBody>
-      </p:sp>
-      <p:sp>
-        <p:nvSpPr>
-          <p:cNvPr id="28" name="Shape 26"/>
-          <p:cNvSpPr/>
-          <p:nvPr/>
-        </p:nvSpPr>
-        <p:spPr>
-          <a:xfrm>
-            <a:off x="3429000" y="3035808"/>
-            <a:ext cx="2651760" cy="822960"/>
-          </a:xfrm>
-          <a:prstGeom prst="roundRect">
-            <a:avLst>
-              <a:gd name="adj" fmla="val 7778"/>
-            </a:avLst>
-          </a:prstGeom>
-          <a:solidFill>
-            <a:srgbClr val="FFFFFF"/>
-          </a:solidFill>
-          <a:ln w="12700">
-            <a:solidFill>
-              <a:srgbClr val="D8E5DC"/>
-            </a:solidFill>
-            <a:prstDash val="solid"/>
-          </a:ln>
-          <a:effectLst>
-            <a:outerShdw sx="100000" sy="100000" kx="0" ky="0" algn="bl" rotWithShape="0" blurRad="88900" dist="25400" dir="5400000">
-              <a:srgbClr val="6B6B6B">
-                <a:alpha val="22000"/>
-              </a:srgbClr>
-            </a:outerShdw>
-          </a:effectLst>
-        </p:spPr>
-      </p:sp>
-      <p:sp>
-        <p:nvSpPr>
-          <p:cNvPr id="29" name="Text 27"/>
-          <p:cNvSpPr/>
-          <p:nvPr/>
-        </p:nvSpPr>
-        <p:spPr>
-          <a:xfrm>
-            <a:off x="3566160" y="3108960"/>
-            <a:ext cx="2395728" cy="256032"/>
-          </a:xfrm>
-          <a:prstGeom prst="rect">
-            <a:avLst/>
-          </a:prstGeom>
-          <a:noFill/>
-          <a:ln/>
-        </p:spPr>
-        <p:txBody>
-          <a:bodyPr wrap="square" lIns="0" tIns="0" rIns="0" bIns="0" rtlCol="0" anchor="ctr"/>
-          <a:lstStyle/>
-          <a:p>
-            <a:pPr indent="0" marL="0">
-              <a:buNone/>
-            </a:pPr>
-            <a:r>
-              <a:rPr lang="en-US" sz="1100" b="1" dirty="0">
-                <a:solidFill>
-                  <a:srgbClr val="17241D"/>
-                </a:solidFill>
-                <a:latin typeface="Arial" pitchFamily="34" charset="0"/>
-                <a:ea typeface="Arial" pitchFamily="34" charset="-122"/>
-                <a:cs typeface="Arial" pitchFamily="34" charset="-120"/>
-              </a:rPr>
-              <a:t>SongDNA / Smart Shuffle</a:t>
-            </a:r>
-            <a:endParaRPr lang="en-US" sz="1100" dirty="0"/>
-          </a:p>
-        </p:txBody>
-      </p:sp>
-      <p:sp>
-        <p:nvSpPr>
-          <p:cNvPr id="30" name="Text 28"/>
-          <p:cNvSpPr/>
-          <p:nvPr/>
-        </p:nvSpPr>
-        <p:spPr>
-          <a:xfrm>
-            <a:off x="3566160" y="3364992"/>
-            <a:ext cx="2395728" cy="457200"/>
-          </a:xfrm>
-          <a:prstGeom prst="rect">
-            <a:avLst/>
-          </a:prstGeom>
-          <a:noFill/>
-          <a:ln/>
-        </p:spPr>
-        <p:txBody>
-          <a:bodyPr wrap="square" lIns="0" tIns="0" rIns="0" bIns="0" rtlCol="0" anchor="ctr"/>
-          <a:lstStyle/>
-          <a:p>
-            <a:pPr indent="0" marL="0">
-              <a:lnSpc>
-                <a:spcPct val="105000"/>
-              </a:lnSpc>
-              <a:buNone/>
-            </a:pPr>
-            <a:r>
-              <a:rPr lang="en-US" sz="950" dirty="0">
-                <a:solidFill>
-                  <a:srgbClr val="5C6B62"/>
-                </a:solidFill>
-                <a:latin typeface="Arial" pitchFamily="34" charset="0"/>
-                <a:ea typeface="Arial" pitchFamily="34" charset="-122"/>
-                <a:cs typeface="Arial" pitchFamily="34" charset="-120"/>
-              </a:rPr>
-              <a:t>Facts and reshuffles — gives no reason to care about a new track.</a:t>
-            </a:r>
-            <a:endParaRPr lang="en-US" sz="950" dirty="0"/>
-          </a:p>
-        </p:txBody>
-      </p:sp>
-      <p:sp>
-        <p:nvSpPr>
-          <p:cNvPr id="31" name="Shape 29"/>
-          <p:cNvSpPr/>
-          <p:nvPr/>
-        </p:nvSpPr>
-        <p:spPr>
-          <a:xfrm>
-            <a:off x="6263640" y="960120"/>
-            <a:ext cx="2606040" cy="3611880"/>
-          </a:xfrm>
-          <a:prstGeom prst="roundRect">
-            <a:avLst>
-              <a:gd name="adj" fmla="val 2456"/>
-            </a:avLst>
-          </a:prstGeom>
-          <a:solidFill>
-            <a:srgbClr val="E6EFF7"/>
-          </a:solidFill>
-          <a:ln w="12700">
-            <a:solidFill>
-              <a:srgbClr val="D8E5DC"/>
-            </a:solidFill>
-            <a:prstDash val="solid"/>
-          </a:ln>
-          <a:effectLst>
-            <a:outerShdw sx="100000" sy="100000" kx="0" ky="0" algn="bl" rotWithShape="0" blurRad="88900" dist="25400" dir="5400000">
-              <a:srgbClr val="6B6B6B">
-                <a:alpha val="22000"/>
-              </a:srgbClr>
-            </a:outerShdw>
-          </a:effectLst>
-        </p:spPr>
-      </p:sp>
-      <p:sp>
-        <p:nvSpPr>
-          <p:cNvPr id="32" name="Text 30"/>
-          <p:cNvSpPr/>
-          <p:nvPr/>
-        </p:nvSpPr>
-        <p:spPr>
-          <a:xfrm>
-            <a:off x="6446520" y="1097280"/>
-            <a:ext cx="2286000" cy="237744"/>
-          </a:xfrm>
-          <a:prstGeom prst="rect">
-            <a:avLst/>
-          </a:prstGeom>
-          <a:noFill/>
-          <a:ln/>
-        </p:spPr>
-        <p:txBody>
-          <a:bodyPr wrap="square" lIns="0" tIns="0" rIns="0" bIns="0" rtlCol="0" anchor="ctr"/>
-          <a:lstStyle/>
-          <a:p>
-            <a:pPr indent="0" marL="0">
-              <a:buNone/>
-            </a:pPr>
-            <a:r>
-              <a:rPr lang="en-US" sz="1000" b="1" spc="150" kern="0" dirty="0">
+              <a:rPr lang="en-US" sz="1150" b="1" i="1" dirty="0">
                 <a:solidFill>
                   <a:srgbClr val="0E6B37"/>
                 </a:solidFill>
@@ -6062,128 +4864,15 @@
                 <a:ea typeface="Arial" pitchFamily="34" charset="-122"/>
                 <a:cs typeface="Arial" pitchFamily="34" charset="-120"/>
               </a:rPr>
-              <a:t>HYPOTHESIS</a:t>
-            </a:r>
-            <a:endParaRPr lang="en-US" sz="1000" dirty="0"/>
-          </a:p>
-        </p:txBody>
-      </p:sp>
-      <p:sp>
-        <p:nvSpPr>
-          <p:cNvPr id="33" name="Text 31"/>
-          <p:cNvSpPr/>
-          <p:nvPr/>
-        </p:nvSpPr>
-        <p:spPr>
-          <a:xfrm>
-            <a:off x="6446520" y="1389888"/>
-            <a:ext cx="2286000" cy="1828800"/>
-          </a:xfrm>
-          <a:prstGeom prst="rect">
-            <a:avLst/>
-          </a:prstGeom>
-          <a:noFill/>
-          <a:ln/>
-        </p:spPr>
-        <p:txBody>
-          <a:bodyPr wrap="square" lIns="0" tIns="0" rIns="0" bIns="0" rtlCol="0" anchor="ctr"/>
-          <a:lstStyle/>
-          <a:p>
-            <a:pPr indent="0" marL="0">
-              <a:lnSpc>
-                <a:spcPct val="114000"/>
-              </a:lnSpc>
-              <a:buNone/>
-            </a:pPr>
-            <a:r>
-              <a:rPr lang="en-US" sz="1150" dirty="0">
-                <a:solidFill>
-                  <a:srgbClr val="17241D"/>
-                </a:solidFill>
-                <a:latin typeface="Arial" pitchFamily="34" charset="0"/>
-                <a:ea typeface="Arial" pitchFamily="34" charset="-122"/>
-                <a:cs typeface="Arial" pitchFamily="34" charset="-120"/>
-              </a:rPr>
-              <a:t>Accuracy is a solved problem. The unsolved problem is acceptance: users won't act on a recommendation they have no reason to trust.</a:t>
+              <a:t>The market gap is acceptance, not accuracy.</a:t>
             </a:r>
             <a:endParaRPr lang="en-US" sz="1150" dirty="0"/>
           </a:p>
-          <a:p>
-            <a:pPr indent="0" marL="0">
-              <a:lnSpc>
-                <a:spcPct val="114000"/>
-              </a:lnSpc>
-              <a:buNone/>
-            </a:pPr>
-            <a:endParaRPr lang="en-US" sz="1150" dirty="0"/>
-          </a:p>
-          <a:p>
-            <a:pPr indent="0" marL="0">
-              <a:lnSpc>
-                <a:spcPct val="114000"/>
-              </a:lnSpc>
-              <a:buNone/>
-            </a:pPr>
-            <a:r>
-              <a:rPr lang="en-US" sz="1150" dirty="0">
-                <a:solidFill>
-                  <a:srgbClr val="17241D"/>
-                </a:solidFill>
-                <a:latin typeface="Arial" pitchFamily="34" charset="0"/>
-                <a:ea typeface="Arial" pitchFamily="34" charset="-122"/>
-                <a:cs typeface="Arial" pitchFamily="34" charset="-120"/>
-              </a:rPr>
-              <a:t>When the unfamiliar arrives with no story and no signal, the safe move is to skip — back to the familiar.</a:t>
-            </a:r>
-            <a:endParaRPr lang="en-US" sz="1150" dirty="0"/>
-          </a:p>
-        </p:txBody>
-      </p:sp>
-      <p:sp>
-        <p:nvSpPr>
-          <p:cNvPr id="34" name="Text 32"/>
-          <p:cNvSpPr/>
-          <p:nvPr/>
-        </p:nvSpPr>
-        <p:spPr>
-          <a:xfrm>
-            <a:off x="6446520" y="3611880"/>
-            <a:ext cx="2286000" cy="868680"/>
-          </a:xfrm>
-          <a:prstGeom prst="rect">
-            <a:avLst/>
-          </a:prstGeom>
-          <a:noFill/>
-          <a:ln/>
-        </p:spPr>
-        <p:txBody>
-          <a:bodyPr wrap="square" lIns="0" tIns="0" rIns="0" bIns="0" rtlCol="0" anchor="ctr"/>
-          <a:lstStyle/>
-          <a:p>
-            <a:pPr indent="0" marL="0">
-              <a:lnSpc>
-                <a:spcPct val="110000"/>
-              </a:lnSpc>
-              <a:buNone/>
-            </a:pPr>
-            <a:r>
-              <a:rPr lang="en-US" sz="1150" b="1" i="1" dirty="0">
-                <a:solidFill>
-                  <a:srgbClr val="0E6B37"/>
-                </a:solidFill>
-                <a:latin typeface="Arial" pitchFamily="34" charset="0"/>
-                <a:ea typeface="Arial" pitchFamily="34" charset="-122"/>
-                <a:cs typeface="Arial" pitchFamily="34" charset="-120"/>
-              </a:rPr>
-              <a:t>Users don't need better recs. They need a reason to say yes to the ones they already get.</a:t>
-            </a:r>
-            <a:endParaRPr lang="en-US" sz="1150" dirty="0"/>
-          </a:p>
-        </p:txBody>
-      </p:sp>
-      <p:sp>
-        <p:nvSpPr>
-          <p:cNvPr id="35" name="Shape 33"/>
+        </p:txBody>
+      </p:sp>
+      <p:sp>
+        <p:nvSpPr>
+          <p:cNvPr id="29" name="Shape 27"/>
           <p:cNvSpPr/>
           <p:nvPr/>
         </p:nvSpPr>
@@ -6203,7 +4892,7 @@
       </p:sp>
       <p:sp>
         <p:nvSpPr>
-          <p:cNvPr id="36" name="Text 34"/>
+          <p:cNvPr id="30" name="Text 28"/>
           <p:cNvSpPr/>
           <p:nvPr/>
         </p:nvSpPr>
@@ -6222,6 +4911,36 @@
           <a:bodyPr wrap="square" lIns="0" tIns="0" rIns="0" bIns="0" rtlCol="0" anchor="ctr"/>
           <a:lstStyle/>
           <a:p>
+            <a:pPr algn="ctr" indent="0" marL="0">
+              <a:buNone/>
+            </a:pPr>
+            <a:r>
+              <a:rPr lang="en-US" sz="1000" b="1" dirty="0">
+                <a:solidFill>
+                  <a:srgbClr val="FFFFFF"/>
+                </a:solidFill>
+                <a:latin typeface="Arial" pitchFamily="34" charset="0"/>
+                <a:ea typeface="Arial" pitchFamily="34" charset="-122"/>
+                <a:cs typeface="Arial" pitchFamily="34" charset="-120"/>
+              </a:rPr>
+              <a:t>Market</a:t>
+            </a:r>
+            <a:pPr algn="ctr" indent="0" marL="0">
+              <a:buNone/>
+            </a:pPr>
+            <a:r>
+              <a:rPr lang="en-US" sz="850" dirty="0">
+                <a:solidFill>
+                  <a:srgbClr val="FFFFFF">
+                    <a:alpha val="40000"/>
+                  </a:srgbClr>
+                </a:solidFill>
+                <a:latin typeface="Arial" pitchFamily="34" charset="0"/>
+                <a:ea typeface="Arial" pitchFamily="34" charset="-122"/>
+                <a:cs typeface="Arial" pitchFamily="34" charset="-120"/>
+              </a:rPr>
+              <a:t>   </a:t>
+            </a:r>
             <a:pPr algn="ctr" indent="0" marL="0">
               <a:buNone/>
             </a:pPr>
@@ -6236,7 +4955,7 @@
                 <a:ea typeface="Arial" pitchFamily="34" charset="-122"/>
                 <a:cs typeface="Arial" pitchFamily="34" charset="-120"/>
               </a:rPr>
-              <a:t>Market</a:t>
+              <a:t>Research</a:t>
             </a:r>
             <a:pPr algn="ctr" indent="0" marL="0">
               <a:buNone/>
@@ -6258,15 +4977,17 @@
               <a:buNone/>
             </a:pPr>
             <a:r>
-              <a:rPr lang="en-US" sz="1000" b="1" dirty="0">
-                <a:solidFill>
-                  <a:srgbClr val="FFFFFF"/>
-                </a:solidFill>
-                <a:latin typeface="Arial" pitchFamily="34" charset="0"/>
-                <a:ea typeface="Arial" pitchFamily="34" charset="-122"/>
-                <a:cs typeface="Arial" pitchFamily="34" charset="-120"/>
-              </a:rPr>
-              <a:t>Context</a:t>
+              <a:rPr lang="en-US" sz="850" dirty="0">
+                <a:solidFill>
+                  <a:srgbClr val="FFFFFF">
+                    <a:alpha val="55000"/>
+                  </a:srgbClr>
+                </a:solidFill>
+                <a:latin typeface="Arial" pitchFamily="34" charset="0"/>
+                <a:ea typeface="Arial" pitchFamily="34" charset="-122"/>
+                <a:cs typeface="Arial" pitchFamily="34" charset="-120"/>
+              </a:rPr>
+              <a:t>Persona &amp; Journey</a:t>
             </a:r>
             <a:pPr algn="ctr" indent="0" marL="0">
               <a:buNone/>
@@ -6298,7 +5019,7 @@
                 <a:ea typeface="Arial" pitchFamily="34" charset="-122"/>
                 <a:cs typeface="Arial" pitchFamily="34" charset="-120"/>
               </a:rPr>
-              <a:t>Research</a:t>
+              <a:t>Problem</a:t>
             </a:r>
             <a:pPr algn="ctr" indent="0" marL="0">
               <a:buNone/>
@@ -6330,7 +5051,7 @@
                 <a:ea typeface="Arial" pitchFamily="34" charset="-122"/>
                 <a:cs typeface="Arial" pitchFamily="34" charset="-120"/>
               </a:rPr>
-              <a:t>Persona &amp; Journey</a:t>
+              <a:t>Solution</a:t>
             </a:r>
             <a:pPr algn="ctr" indent="0" marL="0">
               <a:buNone/>
@@ -6362,7 +5083,7 @@
                 <a:ea typeface="Arial" pitchFamily="34" charset="-122"/>
                 <a:cs typeface="Arial" pitchFamily="34" charset="-120"/>
               </a:rPr>
-              <a:t>Problem</a:t>
+              <a:t>MVP</a:t>
             </a:r>
             <a:pPr algn="ctr" indent="0" marL="0">
               <a:buNone/>
@@ -6394,7 +5115,7 @@
                 <a:ea typeface="Arial" pitchFamily="34" charset="-122"/>
                 <a:cs typeface="Arial" pitchFamily="34" charset="-120"/>
               </a:rPr>
-              <a:t>Solution</a:t>
+              <a:t>Architecture</a:t>
             </a:r>
             <a:pPr algn="ctr" indent="0" marL="0">
               <a:buNone/>
@@ -6426,7 +5147,7 @@
                 <a:ea typeface="Arial" pitchFamily="34" charset="-122"/>
                 <a:cs typeface="Arial" pitchFamily="34" charset="-120"/>
               </a:rPr>
-              <a:t>MVP</a:t>
+              <a:t>Metrics</a:t>
             </a:r>
             <a:pPr algn="ctr" indent="0" marL="0">
               <a:buNone/>
@@ -6458,73 +5179,9 @@
                 <a:ea typeface="Arial" pitchFamily="34" charset="-122"/>
                 <a:cs typeface="Arial" pitchFamily="34" charset="-120"/>
               </a:rPr>
-              <a:t>Architecture</a:t>
-            </a:r>
-            <a:pPr algn="ctr" indent="0" marL="0">
-              <a:buNone/>
-            </a:pPr>
-            <a:r>
-              <a:rPr lang="en-US" sz="850" dirty="0">
-                <a:solidFill>
-                  <a:srgbClr val="FFFFFF">
-                    <a:alpha val="40000"/>
-                  </a:srgbClr>
-                </a:solidFill>
-                <a:latin typeface="Arial" pitchFamily="34" charset="0"/>
-                <a:ea typeface="Arial" pitchFamily="34" charset="-122"/>
-                <a:cs typeface="Arial" pitchFamily="34" charset="-120"/>
-              </a:rPr>
-              <a:t>   </a:t>
-            </a:r>
-            <a:pPr algn="ctr" indent="0" marL="0">
-              <a:buNone/>
-            </a:pPr>
-            <a:r>
-              <a:rPr lang="en-US" sz="850" dirty="0">
-                <a:solidFill>
-                  <a:srgbClr val="FFFFFF">
-                    <a:alpha val="55000"/>
-                  </a:srgbClr>
-                </a:solidFill>
-                <a:latin typeface="Arial" pitchFamily="34" charset="0"/>
-                <a:ea typeface="Arial" pitchFamily="34" charset="-122"/>
-                <a:cs typeface="Arial" pitchFamily="34" charset="-120"/>
-              </a:rPr>
-              <a:t>Metrics</a:t>
-            </a:r>
-            <a:pPr algn="ctr" indent="0" marL="0">
-              <a:buNone/>
-            </a:pPr>
-            <a:r>
-              <a:rPr lang="en-US" sz="850" dirty="0">
-                <a:solidFill>
-                  <a:srgbClr val="FFFFFF">
-                    <a:alpha val="40000"/>
-                  </a:srgbClr>
-                </a:solidFill>
-                <a:latin typeface="Arial" pitchFamily="34" charset="0"/>
-                <a:ea typeface="Arial" pitchFamily="34" charset="-122"/>
-                <a:cs typeface="Arial" pitchFamily="34" charset="-120"/>
-              </a:rPr>
-              <a:t>   </a:t>
-            </a:r>
-            <a:pPr algn="ctr" indent="0" marL="0">
-              <a:buNone/>
-            </a:pPr>
-            <a:r>
-              <a:rPr lang="en-US" sz="850" dirty="0">
-                <a:solidFill>
-                  <a:srgbClr val="FFFFFF">
-                    <a:alpha val="55000"/>
-                  </a:srgbClr>
-                </a:solidFill>
-                <a:latin typeface="Arial" pitchFamily="34" charset="0"/>
-                <a:ea typeface="Arial" pitchFamily="34" charset="-122"/>
-                <a:cs typeface="Arial" pitchFamily="34" charset="-120"/>
-              </a:rPr>
               <a:t>Risks</a:t>
             </a:r>
-            <a:endParaRPr lang="en-US" sz="850" dirty="0"/>
+            <a:endParaRPr lang="en-US" sz="1000" dirty="0"/>
           </a:p>
         </p:txBody>
       </p:sp>
@@ -7855,38 +6512,6 @@
               <a:buNone/>
             </a:pPr>
             <a:r>
-              <a:rPr lang="en-US" sz="850" dirty="0">
-                <a:solidFill>
-                  <a:srgbClr val="FFFFFF">
-                    <a:alpha val="55000"/>
-                  </a:srgbClr>
-                </a:solidFill>
-                <a:latin typeface="Arial" pitchFamily="34" charset="0"/>
-                <a:ea typeface="Arial" pitchFamily="34" charset="-122"/>
-                <a:cs typeface="Arial" pitchFamily="34" charset="-120"/>
-              </a:rPr>
-              <a:t>Context</a:t>
-            </a:r>
-            <a:pPr algn="ctr" indent="0" marL="0">
-              <a:buNone/>
-            </a:pPr>
-            <a:r>
-              <a:rPr lang="en-US" sz="850" dirty="0">
-                <a:solidFill>
-                  <a:srgbClr val="FFFFFF">
-                    <a:alpha val="40000"/>
-                  </a:srgbClr>
-                </a:solidFill>
-                <a:latin typeface="Arial" pitchFamily="34" charset="0"/>
-                <a:ea typeface="Arial" pitchFamily="34" charset="-122"/>
-                <a:cs typeface="Arial" pitchFamily="34" charset="-120"/>
-              </a:rPr>
-              <a:t>   </a:t>
-            </a:r>
-            <a:pPr algn="ctr" indent="0" marL="0">
-              <a:buNone/>
-            </a:pPr>
-            <a:r>
               <a:rPr lang="en-US" sz="1000" b="1" dirty="0">
                 <a:solidFill>
                   <a:srgbClr val="FFFFFF"/>
@@ -10250,38 +8875,6 @@
                 <a:ea typeface="Arial" pitchFamily="34" charset="-122"/>
                 <a:cs typeface="Arial" pitchFamily="34" charset="-120"/>
               </a:rPr>
-              <a:t>Context</a:t>
-            </a:r>
-            <a:pPr algn="ctr" indent="0" marL="0">
-              <a:buNone/>
-            </a:pPr>
-            <a:r>
-              <a:rPr lang="en-US" sz="850" dirty="0">
-                <a:solidFill>
-                  <a:srgbClr val="FFFFFF">
-                    <a:alpha val="40000"/>
-                  </a:srgbClr>
-                </a:solidFill>
-                <a:latin typeface="Arial" pitchFamily="34" charset="0"/>
-                <a:ea typeface="Arial" pitchFamily="34" charset="-122"/>
-                <a:cs typeface="Arial" pitchFamily="34" charset="-120"/>
-              </a:rPr>
-              <a:t>   </a:t>
-            </a:r>
-            <a:pPr algn="ctr" indent="0" marL="0">
-              <a:buNone/>
-            </a:pPr>
-            <a:r>
-              <a:rPr lang="en-US" sz="850" dirty="0">
-                <a:solidFill>
-                  <a:srgbClr val="FFFFFF">
-                    <a:alpha val="55000"/>
-                  </a:srgbClr>
-                </a:solidFill>
-                <a:latin typeface="Arial" pitchFamily="34" charset="0"/>
-                <a:ea typeface="Arial" pitchFamily="34" charset="-122"/>
-                <a:cs typeface="Arial" pitchFamily="34" charset="-120"/>
-              </a:rPr>
               <a:t>Research</a:t>
             </a:r>
             <a:pPr algn="ctr" indent="0" marL="0">
@@ -11665,38 +10258,6 @@
                 <a:cs typeface="Arial" pitchFamily="34" charset="-120"/>
               </a:rPr>
               <a:t>Market</a:t>
-            </a:r>
-            <a:pPr algn="ctr" indent="0" marL="0">
-              <a:buNone/>
-            </a:pPr>
-            <a:r>
-              <a:rPr lang="en-US" sz="850" dirty="0">
-                <a:solidFill>
-                  <a:srgbClr val="FFFFFF">
-                    <a:alpha val="40000"/>
-                  </a:srgbClr>
-                </a:solidFill>
-                <a:latin typeface="Arial" pitchFamily="34" charset="0"/>
-                <a:ea typeface="Arial" pitchFamily="34" charset="-122"/>
-                <a:cs typeface="Arial" pitchFamily="34" charset="-120"/>
-              </a:rPr>
-              <a:t>   </a:t>
-            </a:r>
-            <a:pPr algn="ctr" indent="0" marL="0">
-              <a:buNone/>
-            </a:pPr>
-            <a:r>
-              <a:rPr lang="en-US" sz="850" dirty="0">
-                <a:solidFill>
-                  <a:srgbClr val="FFFFFF">
-                    <a:alpha val="55000"/>
-                  </a:srgbClr>
-                </a:solidFill>
-                <a:latin typeface="Arial" pitchFamily="34" charset="0"/>
-                <a:ea typeface="Arial" pitchFamily="34" charset="-122"/>
-                <a:cs typeface="Arial" pitchFamily="34" charset="-120"/>
-              </a:rPr>
-              <a:t>Context</a:t>
             </a:r>
             <a:pPr algn="ctr" indent="0" marL="0">
               <a:buNone/>
@@ -14450,38 +13011,6 @@
                 <a:ea typeface="Arial" pitchFamily="34" charset="-122"/>
                 <a:cs typeface="Arial" pitchFamily="34" charset="-120"/>
               </a:rPr>
-              <a:t>Context</a:t>
-            </a:r>
-            <a:pPr algn="ctr" indent="0" marL="0">
-              <a:buNone/>
-            </a:pPr>
-            <a:r>
-              <a:rPr lang="en-US" sz="850" dirty="0">
-                <a:solidFill>
-                  <a:srgbClr val="FFFFFF">
-                    <a:alpha val="40000"/>
-                  </a:srgbClr>
-                </a:solidFill>
-                <a:latin typeface="Arial" pitchFamily="34" charset="0"/>
-                <a:ea typeface="Arial" pitchFamily="34" charset="-122"/>
-                <a:cs typeface="Arial" pitchFamily="34" charset="-120"/>
-              </a:rPr>
-              <a:t>   </a:t>
-            </a:r>
-            <a:pPr algn="ctr" indent="0" marL="0">
-              <a:buNone/>
-            </a:pPr>
-            <a:r>
-              <a:rPr lang="en-US" sz="850" dirty="0">
-                <a:solidFill>
-                  <a:srgbClr val="FFFFFF">
-                    <a:alpha val="55000"/>
-                  </a:srgbClr>
-                </a:solidFill>
-                <a:latin typeface="Arial" pitchFamily="34" charset="0"/>
-                <a:ea typeface="Arial" pitchFamily="34" charset="-122"/>
-                <a:cs typeface="Arial" pitchFamily="34" charset="-120"/>
-              </a:rPr>
               <a:t>Research</a:t>
             </a:r>
             <a:pPr algn="ctr" indent="0" marL="0">
@@ -16125,38 +14654,6 @@
                 <a:ea typeface="Arial" pitchFamily="34" charset="-122"/>
                 <a:cs typeface="Arial" pitchFamily="34" charset="-120"/>
               </a:rPr>
-              <a:t>Context</a:t>
-            </a:r>
-            <a:pPr algn="ctr" indent="0" marL="0">
-              <a:buNone/>
-            </a:pPr>
-            <a:r>
-              <a:rPr lang="en-US" sz="850" dirty="0">
-                <a:solidFill>
-                  <a:srgbClr val="FFFFFF">
-                    <a:alpha val="40000"/>
-                  </a:srgbClr>
-                </a:solidFill>
-                <a:latin typeface="Arial" pitchFamily="34" charset="0"/>
-                <a:ea typeface="Arial" pitchFamily="34" charset="-122"/>
-                <a:cs typeface="Arial" pitchFamily="34" charset="-120"/>
-              </a:rPr>
-              <a:t>   </a:t>
-            </a:r>
-            <a:pPr algn="ctr" indent="0" marL="0">
-              <a:buNone/>
-            </a:pPr>
-            <a:r>
-              <a:rPr lang="en-US" sz="850" dirty="0">
-                <a:solidFill>
-                  <a:srgbClr val="FFFFFF">
-                    <a:alpha val="55000"/>
-                  </a:srgbClr>
-                </a:solidFill>
-                <a:latin typeface="Arial" pitchFamily="34" charset="0"/>
-                <a:ea typeface="Arial" pitchFamily="34" charset="-122"/>
-                <a:cs typeface="Arial" pitchFamily="34" charset="-120"/>
-              </a:rPr>
               <a:t>Research</a:t>
             </a:r>
             <a:pPr algn="ctr" indent="0" marL="0">
@@ -18491,38 +16988,6 @@
                 <a:cs typeface="Arial" pitchFamily="34" charset="-120"/>
               </a:rPr>
               <a:t>Market</a:t>
-            </a:r>
-            <a:pPr algn="ctr" indent="0" marL="0">
-              <a:buNone/>
-            </a:pPr>
-            <a:r>
-              <a:rPr lang="en-US" sz="850" dirty="0">
-                <a:solidFill>
-                  <a:srgbClr val="FFFFFF">
-                    <a:alpha val="40000"/>
-                  </a:srgbClr>
-                </a:solidFill>
-                <a:latin typeface="Arial" pitchFamily="34" charset="0"/>
-                <a:ea typeface="Arial" pitchFamily="34" charset="-122"/>
-                <a:cs typeface="Arial" pitchFamily="34" charset="-120"/>
-              </a:rPr>
-              <a:t>   </a:t>
-            </a:r>
-            <a:pPr algn="ctr" indent="0" marL="0">
-              <a:buNone/>
-            </a:pPr>
-            <a:r>
-              <a:rPr lang="en-US" sz="850" dirty="0">
-                <a:solidFill>
-                  <a:srgbClr val="FFFFFF">
-                    <a:alpha val="55000"/>
-                  </a:srgbClr>
-                </a:solidFill>
-                <a:latin typeface="Arial" pitchFamily="34" charset="0"/>
-                <a:ea typeface="Arial" pitchFamily="34" charset="-122"/>
-                <a:cs typeface="Arial" pitchFamily="34" charset="-120"/>
-              </a:rPr>
-              <a:t>Context</a:t>
             </a:r>
             <a:pPr algn="ctr" indent="0" marL="0">
               <a:buNone/>
@@ -21214,38 +19679,6 @@
                 <a:cs typeface="Arial" pitchFamily="34" charset="-120"/>
               </a:rPr>
               <a:t>Market</a:t>
-            </a:r>
-            <a:pPr algn="ctr" indent="0" marL="0">
-              <a:buNone/>
-            </a:pPr>
-            <a:r>
-              <a:rPr lang="en-US" sz="850" dirty="0">
-                <a:solidFill>
-                  <a:srgbClr val="FFFFFF">
-                    <a:alpha val="40000"/>
-                  </a:srgbClr>
-                </a:solidFill>
-                <a:latin typeface="Arial" pitchFamily="34" charset="0"/>
-                <a:ea typeface="Arial" pitchFamily="34" charset="-122"/>
-                <a:cs typeface="Arial" pitchFamily="34" charset="-120"/>
-              </a:rPr>
-              <a:t>   </a:t>
-            </a:r>
-            <a:pPr algn="ctr" indent="0" marL="0">
-              <a:buNone/>
-            </a:pPr>
-            <a:r>
-              <a:rPr lang="en-US" sz="850" dirty="0">
-                <a:solidFill>
-                  <a:srgbClr val="FFFFFF">
-                    <a:alpha val="55000"/>
-                  </a:srgbClr>
-                </a:solidFill>
-                <a:latin typeface="Arial" pitchFamily="34" charset="0"/>
-                <a:ea typeface="Arial" pitchFamily="34" charset="-122"/>
-                <a:cs typeface="Arial" pitchFamily="34" charset="-120"/>
-              </a:rPr>
-              <a:t>Context</a:t>
             </a:r>
             <a:pPr algn="ctr" indent="0" marL="0">
               <a:buNone/>

</xml_diff>

<commit_message>
Deck: remove all survey/interview/n= language — evidence is review-based only
Retitle research slide (no 'survey 30 people'), drop (n=7,296) notation on
research + metrics slides, and reframe risk-slide 'interviews' as a targeted
user test. Keeps the deck honestly grounded in review analysis only.

Co-Authored-By: Claude Opus 4.8 <noreply@anthropic.com>
</commit_message>
<xml_diff>
--- a/Off_Repeat_Deck_TopFellow.pptx
+++ b/Off_Repeat_Deck_TopFellow.pptx
@@ -4782,7 +4782,7 @@
                           <a:ea typeface="Arial" pitchFamily="34" charset="-122"/>
                           <a:cs typeface="Arial" pitchFamily="34" charset="-120"/>
                         </a:rPr>
-                        <a:t>Validate the driver in Part-2 interviews; ship to lean-in surfaces only; measure by moment.</a:t>
+                        <a:t>Validate the driver with a targeted user test before building; ship to lean-in surfaces only.</a:t>
                       </a:r>
                       <a:endParaRPr lang="en-US" sz="780" dirty="0">
                         <a:latin typeface="Arial" charset="0"/>
@@ -6542,7 +6542,7 @@
                 <a:ea typeface="Arial" pitchFamily="34" charset="-122"/>
                 <a:cs typeface="Arial" pitchFamily="34" charset="-120"/>
               </a:rPr>
-              <a:t>it earns the play. The riskiest failures are the ones users don't notice, so we de-risk the acceptance driver in interviews before we build.</a:t>
+              <a:t>it earns the play. The riskiest failures are the ones users don't notice, so we de-risk the acceptance driver with a small user test before we build.</a:t>
             </a:r>
             <a:endParaRPr lang="en-US" sz="850" dirty="0"/>
           </a:p>
@@ -6675,7 +6675,7 @@
                 <a:ea typeface="Arial" pitchFamily="34" charset="-122"/>
                 <a:cs typeface="Arial" pitchFamily="34" charset="-120"/>
               </a:rPr>
-              <a:t>We didn't survey 30 people — we analyzed 7,296 reviews; repetition is the #1 pain</a:t>
+              <a:t>We analyzed 7,296 real reviews — repetition is the #1 discovery pain</a:t>
             </a:r>
             <a:endParaRPr lang="en-US" sz="1750" dirty="0"/>
           </a:p>
@@ -6780,7 +6780,7 @@
                 <a:ea typeface="Arial" pitchFamily="34" charset="-122"/>
                 <a:cs typeface="Arial" pitchFamily="34" charset="-120"/>
               </a:rPr>
-              <a:t>1 · REVIEW FINDINGS (N=7,296)</a:t>
+              <a:t>1 · REVIEW FINDINGS — 7,296 REVIEWS</a:t>
             </a:r>
             <a:endParaRPr lang="en-US" sz="950" dirty="0"/>
           </a:p>
@@ -19253,7 +19253,7 @@
                 <a:ea typeface="Arial" pitchFamily="34" charset="-122"/>
                 <a:cs typeface="Arial" pitchFamily="34" charset="-120"/>
               </a:rPr>
-              <a:t>Every threshold derived from our review analysis (n=7,296) with secondary research woven in.</a:t>
+              <a:t>Every threshold derived from our analysis of 7,296 real reviews, with secondary research woven in.</a:t>
             </a:r>
             <a:endParaRPr lang="en-US" sz="1000" dirty="0"/>
           </a:p>

</xml_diff>

<commit_message>
Deck: align all numbers with the engine's actual output (insights.json)
Replace contradicting stats (19.4% discovery, '#1 theme = stale/repetitive',
fabricated 'what users ask for' bars) with the engine's real figures:
130 discovery mentions (3rd theme), 90 praise vs 63 'stale/looping',
sentiment 1933/627/3449 — so deck and engine link never contradict.

Co-Authored-By: Claude Opus 4.8 <noreply@anthropic.com>
</commit_message>
<xml_diff>
--- a/Off_Repeat_Deck_TopFellow.pptx
+++ b/Off_Repeat_Deck_TopFellow.pptx
@@ -3800,7 +3800,7 @@
                 <a:ea typeface="Arial" pitchFamily="34" charset="-122"/>
                 <a:cs typeface="Arial" pitchFamily="34" charset="-120"/>
               </a:rPr>
-              <a:t>19.4%</a:t>
+              <a:t>63</a:t>
             </a:r>
             <a:endParaRPr lang="en-US" sz="1800" dirty="0"/>
           </a:p>
@@ -3842,7 +3842,7 @@
                 <a:ea typeface="Arial" pitchFamily="34" charset="-122"/>
                 <a:cs typeface="Arial" pitchFamily="34" charset="-120"/>
               </a:rPr>
-              <a:t>of analyzed reviews cite repetition / discovery pain</a:t>
+              <a:t>reviews say recs feel 'stale / looping'</a:t>
             </a:r>
             <a:endParaRPr lang="en-US" sz="700" dirty="0"/>
           </a:p>
@@ -6675,7 +6675,7 @@
                 <a:ea typeface="Arial" pitchFamily="34" charset="-122"/>
                 <a:cs typeface="Arial" pitchFamily="34" charset="-120"/>
               </a:rPr>
-              <a:t>We analyzed 7,296 real reviews — repetition is the #1 discovery pain</a:t>
+              <a:t>AI-coded 7,296 reviews: discovery is praised for accuracy, panned for the loop</a:t>
             </a:r>
             <a:endParaRPr lang="en-US" sz="1750" dirty="0"/>
           </a:p>
@@ -6990,7 +6990,7 @@
                 <a:ea typeface="Arial" pitchFamily="34" charset="-122"/>
                 <a:cs typeface="Arial" pitchFamily="34" charset="-120"/>
               </a:rPr>
-              <a:t>LLM-labeled</a:t>
+              <a:t>AI-labeled</a:t>
             </a:r>
             <a:endParaRPr lang="en-US" sz="700" dirty="0"/>
           </a:p>
@@ -7056,7 +7056,7 @@
                 <a:ea typeface="Arial" pitchFamily="34" charset="-122"/>
                 <a:cs typeface="Arial" pitchFamily="34" charset="-120"/>
               </a:rPr>
-              <a:t>19.4%</a:t>
+              <a:t>130</a:t>
             </a:r>
             <a:endParaRPr lang="en-US" sz="1400" dirty="0"/>
           </a:p>
@@ -7095,7 +7095,7 @@
                 <a:ea typeface="Arial" pitchFamily="34" charset="-122"/>
                 <a:cs typeface="Arial" pitchFamily="34" charset="-120"/>
               </a:rPr>
-              <a:t>cite discovery pain</a:t>
+              <a:t>flag discovery · 3rd theme</a:t>
             </a:r>
             <a:endParaRPr lang="en-US" sz="700" dirty="0"/>
           </a:p>
@@ -7161,7 +7161,7 @@
                 <a:ea typeface="Arial" pitchFamily="34" charset="-122"/>
                 <a:cs typeface="Arial" pitchFamily="34" charset="-120"/>
               </a:rPr>
-              <a:t>#1</a:t>
+              <a:t>63</a:t>
             </a:r>
             <a:endParaRPr lang="en-US" sz="1400" dirty="0"/>
           </a:p>
@@ -7200,7 +7200,7 @@
                 <a:ea typeface="Arial" pitchFamily="34" charset="-122"/>
                 <a:cs typeface="Arial" pitchFamily="34" charset="-120"/>
               </a:rPr>
-              <a:t>theme = stale/repetitive</a:t>
+              <a:t>say 'stale / looping'</a:t>
             </a:r>
             <a:endParaRPr lang="en-US" sz="700" dirty="0"/>
           </a:p>
@@ -7239,7 +7239,7 @@
                 <a:ea typeface="Arial" pitchFamily="34" charset="-122"/>
                 <a:cs typeface="Arial" pitchFamily="34" charset="-120"/>
               </a:rPr>
-              <a:t>What reviewers ask for</a:t>
+              <a:t>Inside the 130 discovery mentions</a:t>
             </a:r>
             <a:endParaRPr lang="en-US" sz="850" dirty="0"/>
           </a:p>
@@ -7254,7 +7254,7 @@
         <p:spPr>
           <a:xfrm>
             <a:off x="365760" y="2523744"/>
-            <a:ext cx="412394" cy="182880"/>
+            <a:ext cx="1005840" cy="182880"/>
           </a:xfrm>
           <a:prstGeom prst="roundRect">
             <a:avLst>
@@ -7300,7 +7300,7 @@
                 <a:ea typeface="Arial" pitchFamily="34" charset="-122"/>
                 <a:cs typeface="Arial" pitchFamily="34" charset="-120"/>
               </a:rPr>
-              <a:t>41%</a:t>
+              <a:t>90</a:t>
             </a:r>
             <a:endParaRPr lang="en-US" sz="800" dirty="0"/>
           </a:p>
@@ -7339,7 +7339,7 @@
                 <a:ea typeface="Arial" pitchFamily="34" charset="-122"/>
                 <a:cs typeface="Arial" pitchFamily="34" charset="-120"/>
               </a:rPr>
-              <a:t>More variety</a:t>
+              <a:t>Praise it (accurate)</a:t>
             </a:r>
             <a:endParaRPr lang="en-US" sz="850" dirty="0"/>
           </a:p>
@@ -7354,7 +7354,7 @@
         <p:spPr>
           <a:xfrm>
             <a:off x="365760" y="2798064"/>
-            <a:ext cx="331927" cy="182880"/>
+            <a:ext cx="704088" cy="182880"/>
           </a:xfrm>
           <a:prstGeom prst="roundRect">
             <a:avLst>
@@ -7400,7 +7400,7 @@
                 <a:ea typeface="Arial" pitchFamily="34" charset="-122"/>
                 <a:cs typeface="Arial" pitchFamily="34" charset="-120"/>
               </a:rPr>
-              <a:t>33%</a:t>
+              <a:t>63</a:t>
             </a:r>
             <a:endParaRPr lang="en-US" sz="800" dirty="0"/>
           </a:p>
@@ -7439,7 +7439,7 @@
                 <a:ea typeface="Arial" pitchFamily="34" charset="-122"/>
                 <a:cs typeface="Arial" pitchFamily="34" charset="-120"/>
               </a:rPr>
-              <a:t>Less repetition</a:t>
+              <a:t>Stale / looping</a:t>
             </a:r>
             <a:endParaRPr lang="en-US" sz="850" dirty="0"/>
           </a:p>
@@ -7454,106 +7454,6 @@
         <p:spPr>
           <a:xfrm>
             <a:off x="365760" y="3072384"/>
-            <a:ext cx="170993" cy="182880"/>
-          </a:xfrm>
-          <a:prstGeom prst="roundRect">
-            <a:avLst>
-              <a:gd name="adj" fmla="val 16043"/>
-            </a:avLst>
-          </a:prstGeom>
-          <a:solidFill>
-            <a:srgbClr val="1ED760"/>
-          </a:solidFill>
-          <a:ln/>
-        </p:spPr>
-      </p:sp>
-      <p:sp>
-        <p:nvSpPr>
-          <p:cNvPr id="28" name="Text 26"/>
-          <p:cNvSpPr/>
-          <p:nvPr/>
-        </p:nvSpPr>
-        <p:spPr>
-          <a:xfrm>
-            <a:off x="402336" y="3072384"/>
-            <a:ext cx="640080" cy="182880"/>
-          </a:xfrm>
-          <a:prstGeom prst="rect">
-            <a:avLst/>
-          </a:prstGeom>
-          <a:noFill/>
-          <a:ln/>
-        </p:spPr>
-        <p:txBody>
-          <a:bodyPr wrap="square" lIns="0" tIns="0" rIns="0" bIns="0" rtlCol="0" anchor="ctr"/>
-          <a:lstStyle/>
-          <a:p>
-            <a:pPr indent="0" marL="0">
-              <a:buNone/>
-            </a:pPr>
-            <a:r>
-              <a:rPr lang="en-US" sz="800" b="1" dirty="0">
-                <a:solidFill>
-                  <a:srgbClr val="03240F"/>
-                </a:solidFill>
-                <a:latin typeface="Arial" pitchFamily="34" charset="0"/>
-                <a:ea typeface="Arial" pitchFamily="34" charset="-122"/>
-                <a:cs typeface="Arial" pitchFamily="34" charset="-120"/>
-              </a:rPr>
-              <a:t>17%</a:t>
-            </a:r>
-            <a:endParaRPr lang="en-US" sz="800" dirty="0"/>
-          </a:p>
-        </p:txBody>
-      </p:sp>
-      <p:sp>
-        <p:nvSpPr>
-          <p:cNvPr id="29" name="Text 27"/>
-          <p:cNvSpPr/>
-          <p:nvPr/>
-        </p:nvSpPr>
-        <p:spPr>
-          <a:xfrm>
-            <a:off x="1444752" y="3072384"/>
-            <a:ext cx="2194560" cy="182880"/>
-          </a:xfrm>
-          <a:prstGeom prst="rect">
-            <a:avLst/>
-          </a:prstGeom>
-          <a:noFill/>
-          <a:ln/>
-        </p:spPr>
-        <p:txBody>
-          <a:bodyPr wrap="square" lIns="0" tIns="0" rIns="0" bIns="0" rtlCol="0" anchor="ctr"/>
-          <a:lstStyle/>
-          <a:p>
-            <a:pPr indent="0" marL="0">
-              <a:buNone/>
-            </a:pPr>
-            <a:r>
-              <a:rPr lang="en-US" sz="850" dirty="0">
-                <a:solidFill>
-                  <a:srgbClr val="E8E8E8"/>
-                </a:solidFill>
-                <a:latin typeface="Arial" pitchFamily="34" charset="0"/>
-                <a:ea typeface="Arial" pitchFamily="34" charset="-122"/>
-                <a:cs typeface="Arial" pitchFamily="34" charset="-120"/>
-              </a:rPr>
-              <a:t>A real shuffle</a:t>
-            </a:r>
-            <a:endParaRPr lang="en-US" sz="850" dirty="0"/>
-          </a:p>
-        </p:txBody>
-      </p:sp>
-      <p:sp>
-        <p:nvSpPr>
-          <p:cNvPr id="30" name="Shape 28"/>
-          <p:cNvSpPr/>
-          <p:nvPr/>
-        </p:nvSpPr>
-        <p:spPr>
-          <a:xfrm>
-            <a:off x="365760" y="3346704"/>
             <a:ext cx="164592" cy="182880"/>
           </a:xfrm>
           <a:prstGeom prst="roundRect">
@@ -7569,6 +7469,106 @@
       </p:sp>
       <p:sp>
         <p:nvSpPr>
+          <p:cNvPr id="28" name="Text 26"/>
+          <p:cNvSpPr/>
+          <p:nvPr/>
+        </p:nvSpPr>
+        <p:spPr>
+          <a:xfrm>
+            <a:off x="402336" y="3072384"/>
+            <a:ext cx="640080" cy="182880"/>
+          </a:xfrm>
+          <a:prstGeom prst="rect">
+            <a:avLst/>
+          </a:prstGeom>
+          <a:noFill/>
+          <a:ln/>
+        </p:spPr>
+        <p:txBody>
+          <a:bodyPr wrap="square" lIns="0" tIns="0" rIns="0" bIns="0" rtlCol="0" anchor="ctr"/>
+          <a:lstStyle/>
+          <a:p>
+            <a:pPr indent="0" marL="0">
+              <a:buNone/>
+            </a:pPr>
+            <a:r>
+              <a:rPr lang="en-US" sz="800" b="1" dirty="0">
+                <a:solidFill>
+                  <a:srgbClr val="03240F"/>
+                </a:solidFill>
+                <a:latin typeface="Arial" pitchFamily="34" charset="0"/>
+                <a:ea typeface="Arial" pitchFamily="34" charset="-122"/>
+                <a:cs typeface="Arial" pitchFamily="34" charset="-120"/>
+              </a:rPr>
+              <a:t>14</a:t>
+            </a:r>
+            <a:endParaRPr lang="en-US" sz="800" dirty="0"/>
+          </a:p>
+        </p:txBody>
+      </p:sp>
+      <p:sp>
+        <p:nvSpPr>
+          <p:cNvPr id="29" name="Text 27"/>
+          <p:cNvSpPr/>
+          <p:nvPr/>
+        </p:nvSpPr>
+        <p:spPr>
+          <a:xfrm>
+            <a:off x="1444752" y="3072384"/>
+            <a:ext cx="2194560" cy="182880"/>
+          </a:xfrm>
+          <a:prstGeom prst="rect">
+            <a:avLst/>
+          </a:prstGeom>
+          <a:noFill/>
+          <a:ln/>
+        </p:spPr>
+        <p:txBody>
+          <a:bodyPr wrap="square" lIns="0" tIns="0" rIns="0" bIns="0" rtlCol="0" anchor="ctr"/>
+          <a:lstStyle/>
+          <a:p>
+            <a:pPr indent="0" marL="0">
+              <a:buNone/>
+            </a:pPr>
+            <a:r>
+              <a:rPr lang="en-US" sz="850" dirty="0">
+                <a:solidFill>
+                  <a:srgbClr val="E8E8E8"/>
+                </a:solidFill>
+                <a:latin typeface="Arial" pitchFamily="34" charset="0"/>
+                <a:ea typeface="Arial" pitchFamily="34" charset="-122"/>
+                <a:cs typeface="Arial" pitchFamily="34" charset="-120"/>
+              </a:rPr>
+              <a:t>Niche underserved</a:t>
+            </a:r>
+            <a:endParaRPr lang="en-US" sz="850" dirty="0"/>
+          </a:p>
+        </p:txBody>
+      </p:sp>
+      <p:sp>
+        <p:nvSpPr>
+          <p:cNvPr id="30" name="Shape 28"/>
+          <p:cNvSpPr/>
+          <p:nvPr/>
+        </p:nvSpPr>
+        <p:spPr>
+          <a:xfrm>
+            <a:off x="365760" y="3346704"/>
+            <a:ext cx="164592" cy="182880"/>
+          </a:xfrm>
+          <a:prstGeom prst="roundRect">
+            <a:avLst>
+              <a:gd name="adj" fmla="val 16667"/>
+            </a:avLst>
+          </a:prstGeom>
+          <a:solidFill>
+            <a:srgbClr val="1ED760"/>
+          </a:solidFill>
+          <a:ln/>
+        </p:spPr>
+      </p:sp>
+      <p:sp>
+        <p:nvSpPr>
           <p:cNvPr id="31" name="Text 29"/>
           <p:cNvSpPr/>
           <p:nvPr/>
@@ -7600,7 +7600,7 @@
                 <a:ea typeface="Arial" pitchFamily="34" charset="-122"/>
                 <a:cs typeface="Arial" pitchFamily="34" charset="-120"/>
               </a:rPr>
-              <a:t>9%</a:t>
+              <a:t>5</a:t>
             </a:r>
             <a:endParaRPr lang="en-US" sz="800" dirty="0"/>
           </a:p>
@@ -7639,7 +7639,7 @@
                 <a:ea typeface="Arial" pitchFamily="34" charset="-122"/>
                 <a:cs typeface="Arial" pitchFamily="34" charset="-120"/>
               </a:rPr>
-              <a:t>Better new-music</a:t>
+              <a:t>Search / steer gaps</a:t>
             </a:r>
             <a:endParaRPr lang="en-US" sz="850" dirty="0"/>
           </a:p>
@@ -9026,7 +9026,7 @@
                 <a:ea typeface="Arial" pitchFamily="34" charset="-122"/>
                 <a:cs typeface="Arial" pitchFamily="34" charset="-120"/>
               </a:rPr>
-              <a:t>highest LTV, feel the pain most, and are the most articulate — they drive the discovery complaints (19.4% of reviews). Win them, then expand to all Premium.</a:t>
+              <a:t>highest LTV, feel the pain most, and are the most articulate — they drive the 'stale / looping' complaints — the top discovery pain in the reviews. Win them, then expand to all Premium.</a:t>
             </a:r>
             <a:endParaRPr lang="en-US" sz="900" dirty="0"/>
           </a:p>
@@ -11618,7 +11618,7 @@
                 <a:ea typeface="Arial" pitchFamily="34" charset="-122"/>
                 <a:cs typeface="Arial" pitchFamily="34" charset="-120"/>
               </a:rPr>
-              <a:t>19.4% cite repetition; #1 theme</a:t>
+              <a:t>130 flag discovery; 63 'stale/looping'</a:t>
             </a:r>
             <a:endParaRPr lang="en-US" sz="800" dirty="0"/>
           </a:p>
@@ -18527,7 +18527,7 @@
                 <a:ea typeface="Arial" pitchFamily="34" charset="-122"/>
                 <a:cs typeface="Arial" pitchFamily="34" charset="-120"/>
               </a:rPr>
-              <a:t>review #1 pain = repetition; users want a reason, not a score</a:t>
+              <a:t>top discovery gripe = 'stale/looping'; users want a reason, not a score</a:t>
             </a:r>
             <a:endParaRPr lang="en-US" sz="850" dirty="0"/>
           </a:p>

</xml_diff>